<commit_message>
fixing as i go to 3
</commit_message>
<xml_diff>
--- a/docs/ecostats_lectures/lecture_03/03_01_lecture_powerpoint.pptx
+++ b/docs/ecostats_lectures/lecture_03/03_01_lecture_powerpoint.pptx
@@ -54,7 +54,6 @@
     <p:sldId id="302" r:id="rId48"/>
     <p:sldId id="303" r:id="rId49"/>
     <p:sldId id="304" r:id="rId50"/>
-    <p:sldId id="305" r:id="rId51"/>
   </p:sldIdLst>
   <p:sldSz cx="9144000" cy="5143500" type="screen16x9"/>
   <p:notesSz cx="6858000" cy="9144000"/>
@@ -4148,404 +4147,23 @@
               <a:t>Mean length of all fish: 324.5 mm</a:t>
             </a:r>
           </a:p>
+          <a:p>
+            <a:pPr lvl="0" indent="0">
+              <a:buNone/>
+            </a:pPr>
+            <a:r>
+              <a:rPr>
+                <a:latin typeface="Courier"/>
+              </a:rPr>
+              <a:t># A tibble: 2 × 2
+  lake  mean_length
+  &lt;chr&gt;       &lt;dbl&gt;
+1 I3           266.
+2 I8           363.</a:t>
+            </a:r>
+          </a:p>
         </p:txBody>
       </p:sp>
-      <p:graphicFrame xmlns:a="http://schemas.openxmlformats.org/drawingml/2006/main" xmlns:r="http://schemas.openxmlformats.org/officeDocument/2006/relationships" xmlns:p="http://schemas.openxmlformats.org/presentationml/2006/main">
-        <p:nvGraphicFramePr>
-          <p:cNvPr id="865498621" name=""/>
-          <p:cNvGraphicFramePr>
-            <a:graphicFrameLocks noGrp="true"/>
-          </p:cNvGraphicFramePr>
-          <p:nvPr/>
-        </p:nvGraphicFramePr>
-        <p:xfrm rot="0">
-          <a:off x="914400" y="1828800"/>
-          <a:ext cx="9144000" cy="5486400"/>
-        </p:xfrm>
-        <a:graphic>
-          <a:graphicData uri="http://schemas.openxmlformats.org/drawingml/2006/table">
-            <a:tbl>
-              <a:tblPr/>
-              <a:tblGrid>
-                <a:gridCol w="685800"/>
-                <a:gridCol w="685800"/>
-              </a:tblGrid>
-              <a:tr h="228600">
-                <a:tc>
-                  <a:txBody>
-                    <a:bodyPr/>
-                    <a:lstStyle/>
-                    <a:p>
-                      <a:pPr algn="l" marL="63500" marR="63500">
-                        <a:lnSpc>
-                          <a:spcPct val="100000"/>
-                        </a:lnSpc>
-                        <a:spcBef>
-                          <a:spcPts val="500"/>
-                        </a:spcBef>
-                        <a:spcAft>
-                          <a:spcPts val="500"/>
-                        </a:spcAft>
-                        <a:buNone/>
-                      </a:pPr>
-                      <a:r>
-                        <a:rPr cap="none" sz="1100" i="0" b="0" u="none">
-                          <a:solidFill>
-                            <a:srgbClr val="000000">
-                              <a:alpha val="100000"/>
-                            </a:srgbClr>
-                          </a:solidFill>
-                          <a:latin typeface="Helvetica"/>
-                          <a:cs typeface="Helvetica"/>
-                          <a:ea typeface="Helvetica"/>
-                          <a:sym typeface="Helvetica"/>
-                        </a:rPr>
-                        <a:t>lake</a:t>
-                      </a:r>
-                    </a:p>
-                  </a:txBody>
-                  <a:tcPr anchor="ctr" marB="63500" marT="63500" marR="0" marL="0">
-                    <a:lnL algn="ctr" cmpd="sng" cap="flat" w="0">
-                      <a:noFill/>
-                      <a:prstDash val="solid"/>
-                    </a:lnL>
-                    <a:lnR algn="ctr" cmpd="sng" cap="flat" w="0">
-                      <a:noFill/>
-                      <a:prstDash val="solid"/>
-                    </a:lnR>
-                    <a:lnT algn="ctr" cmpd="sng" cap="flat" w="19050">
-                      <a:solidFill>
-                        <a:srgbClr val="666666">
-                          <a:alpha val="100000"/>
-                        </a:srgbClr>
-                      </a:solidFill>
-                      <a:prstDash val="solid"/>
-                    </a:lnT>
-                    <a:lnB algn="ctr" cmpd="sng" cap="flat" w="19050">
-                      <a:solidFill>
-                        <a:srgbClr val="666666">
-                          <a:alpha val="100000"/>
-                        </a:srgbClr>
-                      </a:solidFill>
-                      <a:prstDash val="solid"/>
-                    </a:lnB>
-                    <a:solidFill>
-                      <a:srgbClr val="FFFFFF">
-                        <a:alpha val="0"/>
-                      </a:srgbClr>
-                    </a:solidFill>
-                  </a:tcPr>
-                </a:tc>
-                <a:tc>
-                  <a:txBody>
-                    <a:bodyPr/>
-                    <a:lstStyle/>
-                    <a:p>
-                      <a:pPr algn="r" marL="63500" marR="63500">
-                        <a:lnSpc>
-                          <a:spcPct val="100000"/>
-                        </a:lnSpc>
-                        <a:spcBef>
-                          <a:spcPts val="500"/>
-                        </a:spcBef>
-                        <a:spcAft>
-                          <a:spcPts val="500"/>
-                        </a:spcAft>
-                        <a:buNone/>
-                      </a:pPr>
-                      <a:r>
-                        <a:rPr cap="none" sz="1100" i="0" b="0" u="none">
-                          <a:solidFill>
-                            <a:srgbClr val="000000">
-                              <a:alpha val="100000"/>
-                            </a:srgbClr>
-                          </a:solidFill>
-                          <a:latin typeface="Helvetica"/>
-                          <a:cs typeface="Helvetica"/>
-                          <a:ea typeface="Helvetica"/>
-                          <a:sym typeface="Helvetica"/>
-                        </a:rPr>
-                        <a:t>mean_length</a:t>
-                      </a:r>
-                    </a:p>
-                  </a:txBody>
-                  <a:tcPr anchor="ctr" marB="63500" marT="63500" marR="0" marL="0">
-                    <a:lnL algn="ctr" cmpd="sng" cap="flat" w="0">
-                      <a:noFill/>
-                      <a:prstDash val="solid"/>
-                    </a:lnL>
-                    <a:lnR algn="ctr" cmpd="sng" cap="flat" w="0">
-                      <a:noFill/>
-                      <a:prstDash val="solid"/>
-                    </a:lnR>
-                    <a:lnT algn="ctr" cmpd="sng" cap="flat" w="19050">
-                      <a:solidFill>
-                        <a:srgbClr val="666666">
-                          <a:alpha val="100000"/>
-                        </a:srgbClr>
-                      </a:solidFill>
-                      <a:prstDash val="solid"/>
-                    </a:lnT>
-                    <a:lnB algn="ctr" cmpd="sng" cap="flat" w="19050">
-                      <a:solidFill>
-                        <a:srgbClr val="666666">
-                          <a:alpha val="100000"/>
-                        </a:srgbClr>
-                      </a:solidFill>
-                      <a:prstDash val="solid"/>
-                    </a:lnB>
-                    <a:solidFill>
-                      <a:srgbClr val="FFFFFF">
-                        <a:alpha val="0"/>
-                      </a:srgbClr>
-                    </a:solidFill>
-                  </a:tcPr>
-                </a:tc>
-              </a:tr>
-              <a:tr h="228600">
-                <a:tc>
-                  <a:txBody>
-                    <a:bodyPr/>
-                    <a:lstStyle/>
-                    <a:p>
-                      <a:pPr algn="l" marL="63500" marR="63500">
-                        <a:lnSpc>
-                          <a:spcPct val="100000"/>
-                        </a:lnSpc>
-                        <a:spcBef>
-                          <a:spcPts val="500"/>
-                        </a:spcBef>
-                        <a:spcAft>
-                          <a:spcPts val="500"/>
-                        </a:spcAft>
-                        <a:buNone/>
-                      </a:pPr>
-                      <a:r>
-                        <a:rPr cap="none" sz="1100" i="0" b="0" u="none">
-                          <a:solidFill>
-                            <a:srgbClr val="000000">
-                              <a:alpha val="100000"/>
-                            </a:srgbClr>
-                          </a:solidFill>
-                          <a:latin typeface="Helvetica"/>
-                          <a:cs typeface="Helvetica"/>
-                          <a:ea typeface="Helvetica"/>
-                          <a:sym typeface="Helvetica"/>
-                        </a:rPr>
-                        <a:t>I3</a:t>
-                      </a:r>
-                    </a:p>
-                  </a:txBody>
-                  <a:tcPr anchor="ctr" marB="63500" marT="63500" marR="0" marL="0">
-                    <a:lnL algn="ctr" cmpd="sng" cap="flat" w="0">
-                      <a:noFill/>
-                      <a:prstDash val="solid"/>
-                    </a:lnL>
-                    <a:lnR algn="ctr" cmpd="sng" cap="flat" w="0">
-                      <a:noFill/>
-                      <a:prstDash val="solid"/>
-                    </a:lnR>
-                    <a:lnT algn="ctr" cmpd="sng" cap="flat" w="0">
-                      <a:noFill/>
-                      <a:prstDash val="solid"/>
-                    </a:lnT>
-                    <a:lnB algn="ctr" cmpd="sng" cap="flat" w="0">
-                      <a:noFill/>
-                      <a:prstDash val="solid"/>
-                    </a:lnB>
-                    <a:solidFill>
-                      <a:srgbClr val="FFFFFF">
-                        <a:alpha val="0"/>
-                      </a:srgbClr>
-                    </a:solidFill>
-                  </a:tcPr>
-                </a:tc>
-                <a:tc>
-                  <a:txBody>
-                    <a:bodyPr/>
-                    <a:lstStyle/>
-                    <a:p>
-                      <a:pPr algn="r" marL="63500" marR="63500">
-                        <a:lnSpc>
-                          <a:spcPct val="100000"/>
-                        </a:lnSpc>
-                        <a:spcBef>
-                          <a:spcPts val="500"/>
-                        </a:spcBef>
-                        <a:spcAft>
-                          <a:spcPts val="500"/>
-                        </a:spcAft>
-                        <a:buNone/>
-                      </a:pPr>
-                      <a:r>
-                        <a:rPr cap="none" sz="1100" i="0" b="0" u="none">
-                          <a:solidFill>
-                            <a:srgbClr val="000000">
-                              <a:alpha val="100000"/>
-                            </a:srgbClr>
-                          </a:solidFill>
-                          <a:latin typeface="Helvetica"/>
-                          <a:cs typeface="Helvetica"/>
-                          <a:ea typeface="Helvetica"/>
-                          <a:sym typeface="Helvetica"/>
-                        </a:rPr>
-                        <a:t>265.6061</a:t>
-                      </a:r>
-                    </a:p>
-                  </a:txBody>
-                  <a:tcPr anchor="ctr" marB="63500" marT="63500" marR="0" marL="0">
-                    <a:lnL algn="ctr" cmpd="sng" cap="flat" w="0">
-                      <a:noFill/>
-                      <a:prstDash val="solid"/>
-                    </a:lnL>
-                    <a:lnR algn="ctr" cmpd="sng" cap="flat" w="0">
-                      <a:noFill/>
-                      <a:prstDash val="solid"/>
-                    </a:lnR>
-                    <a:lnT algn="ctr" cmpd="sng" cap="flat" w="0">
-                      <a:noFill/>
-                      <a:prstDash val="solid"/>
-                    </a:lnT>
-                    <a:lnB algn="ctr" cmpd="sng" cap="flat" w="0">
-                      <a:noFill/>
-                      <a:prstDash val="solid"/>
-                    </a:lnB>
-                    <a:solidFill>
-                      <a:srgbClr val="FFFFFF">
-                        <a:alpha val="0"/>
-                      </a:srgbClr>
-                    </a:solidFill>
-                  </a:tcPr>
-                </a:tc>
-              </a:tr>
-              <a:tr h="228600">
-                <a:tc>
-                  <a:txBody>
-                    <a:bodyPr/>
-                    <a:lstStyle/>
-                    <a:p>
-                      <a:pPr algn="l" marL="63500" marR="63500">
-                        <a:lnSpc>
-                          <a:spcPct val="100000"/>
-                        </a:lnSpc>
-                        <a:spcBef>
-                          <a:spcPts val="500"/>
-                        </a:spcBef>
-                        <a:spcAft>
-                          <a:spcPts val="500"/>
-                        </a:spcAft>
-                        <a:buNone/>
-                      </a:pPr>
-                      <a:r>
-                        <a:rPr cap="none" sz="1100" i="0" b="0" u="none">
-                          <a:solidFill>
-                            <a:srgbClr val="000000">
-                              <a:alpha val="100000"/>
-                            </a:srgbClr>
-                          </a:solidFill>
-                          <a:latin typeface="Helvetica"/>
-                          <a:cs typeface="Helvetica"/>
-                          <a:ea typeface="Helvetica"/>
-                          <a:sym typeface="Helvetica"/>
-                        </a:rPr>
-                        <a:t>I8</a:t>
-                      </a:r>
-                    </a:p>
-                  </a:txBody>
-                  <a:tcPr anchor="ctr" marB="63500" marT="63500" marR="0" marL="0">
-                    <a:lnL algn="ctr" cmpd="sng" cap="flat" w="0">
-                      <a:noFill/>
-                      <a:prstDash val="solid"/>
-                    </a:lnL>
-                    <a:lnR algn="ctr" cmpd="sng" cap="flat" w="0">
-                      <a:noFill/>
-                      <a:prstDash val="solid"/>
-                    </a:lnR>
-                    <a:lnT algn="ctr" cmpd="sng" cap="flat" w="0">
-                      <a:noFill/>
-                      <a:prstDash val="solid"/>
-                    </a:lnT>
-                    <a:lnB algn="ctr" cmpd="sng" cap="flat" w="19050">
-                      <a:solidFill>
-                        <a:srgbClr val="666666">
-                          <a:alpha val="100000"/>
-                        </a:srgbClr>
-                      </a:solidFill>
-                      <a:prstDash val="solid"/>
-                    </a:lnB>
-                    <a:solidFill>
-                      <a:srgbClr val="FFFFFF">
-                        <a:alpha val="0"/>
-                      </a:srgbClr>
-                    </a:solidFill>
-                  </a:tcPr>
-                </a:tc>
-                <a:tc>
-                  <a:txBody>
-                    <a:bodyPr/>
-                    <a:lstStyle/>
-                    <a:p>
-                      <a:pPr algn="r" marL="63500" marR="63500">
-                        <a:lnSpc>
-                          <a:spcPct val="100000"/>
-                        </a:lnSpc>
-                        <a:spcBef>
-                          <a:spcPts val="500"/>
-                        </a:spcBef>
-                        <a:spcAft>
-                          <a:spcPts val="500"/>
-                        </a:spcAft>
-                        <a:buNone/>
-                      </a:pPr>
-                      <a:r>
-                        <a:rPr cap="none" sz="1100" i="0" b="0" u="none">
-                          <a:solidFill>
-                            <a:srgbClr val="000000">
-                              <a:alpha val="100000"/>
-                            </a:srgbClr>
-                          </a:solidFill>
-                          <a:latin typeface="Helvetica"/>
-                          <a:cs typeface="Helvetica"/>
-                          <a:ea typeface="Helvetica"/>
-                          <a:sym typeface="Helvetica"/>
-                        </a:rPr>
-                        <a:t>362.5980</a:t>
-                      </a:r>
-                    </a:p>
-                  </a:txBody>
-                  <a:tcPr anchor="ctr" marB="63500" marT="63500" marR="0" marL="0">
-                    <a:lnL algn="ctr" cmpd="sng" cap="flat" w="0">
-                      <a:noFill/>
-                      <a:prstDash val="solid"/>
-                    </a:lnL>
-                    <a:lnR algn="ctr" cmpd="sng" cap="flat" w="0">
-                      <a:noFill/>
-                      <a:prstDash val="solid"/>
-                    </a:lnR>
-                    <a:lnT algn="ctr" cmpd="sng" cap="flat" w="0">
-                      <a:noFill/>
-                      <a:prstDash val="solid"/>
-                    </a:lnT>
-                    <a:lnB algn="ctr" cmpd="sng" cap="flat" w="19050">
-                      <a:solidFill>
-                        <a:srgbClr val="666666">
-                          <a:alpha val="100000"/>
-                        </a:srgbClr>
-                      </a:solidFill>
-                      <a:prstDash val="solid"/>
-                    </a:lnB>
-                    <a:solidFill>
-                      <a:srgbClr val="FFFFFF">
-                        <a:alpha val="0"/>
-                      </a:srgbClr>
-                    </a:solidFill>
-                  </a:tcPr>
-                </a:tc>
-              </a:tr>
-            </a:tbl>
-          </a:graphicData>
-        </a:graphic>
-      </p:graphicFrame>
     </p:spTree>
   </p:cSld>
 </p:sld>
@@ -4646,404 +4264,23 @@
               <a:t>Median length of all fish: 324.5 mm</a:t>
             </a:r>
           </a:p>
+          <a:p>
+            <a:pPr lvl="0" indent="0">
+              <a:buNone/>
+            </a:pPr>
+            <a:r>
+              <a:rPr>
+                <a:latin typeface="Courier"/>
+              </a:rPr>
+              <a:t># A tibble: 2 × 2
+  lake  median_length
+  &lt;chr&gt;         &lt;dbl&gt;
+1 I3              266
+2 I8              373</a:t>
+            </a:r>
+          </a:p>
         </p:txBody>
       </p:sp>
-      <p:graphicFrame xmlns:a="http://schemas.openxmlformats.org/drawingml/2006/main" xmlns:r="http://schemas.openxmlformats.org/officeDocument/2006/relationships" xmlns:p="http://schemas.openxmlformats.org/presentationml/2006/main">
-        <p:nvGraphicFramePr>
-          <p:cNvPr id="134251882" name=""/>
-          <p:cNvGraphicFramePr>
-            <a:graphicFrameLocks noGrp="true"/>
-          </p:cNvGraphicFramePr>
-          <p:nvPr/>
-        </p:nvGraphicFramePr>
-        <p:xfrm rot="0">
-          <a:off x="914400" y="1828800"/>
-          <a:ext cx="9144000" cy="5486400"/>
-        </p:xfrm>
-        <a:graphic>
-          <a:graphicData uri="http://schemas.openxmlformats.org/drawingml/2006/table">
-            <a:tbl>
-              <a:tblPr/>
-              <a:tblGrid>
-                <a:gridCol w="685800"/>
-                <a:gridCol w="685800"/>
-              </a:tblGrid>
-              <a:tr h="228600">
-                <a:tc>
-                  <a:txBody>
-                    <a:bodyPr/>
-                    <a:lstStyle/>
-                    <a:p>
-                      <a:pPr algn="l" marL="63500" marR="63500">
-                        <a:lnSpc>
-                          <a:spcPct val="100000"/>
-                        </a:lnSpc>
-                        <a:spcBef>
-                          <a:spcPts val="500"/>
-                        </a:spcBef>
-                        <a:spcAft>
-                          <a:spcPts val="500"/>
-                        </a:spcAft>
-                        <a:buNone/>
-                      </a:pPr>
-                      <a:r>
-                        <a:rPr cap="none" sz="1100" i="0" b="0" u="none">
-                          <a:solidFill>
-                            <a:srgbClr val="000000">
-                              <a:alpha val="100000"/>
-                            </a:srgbClr>
-                          </a:solidFill>
-                          <a:latin typeface="Helvetica"/>
-                          <a:cs typeface="Helvetica"/>
-                          <a:ea typeface="Helvetica"/>
-                          <a:sym typeface="Helvetica"/>
-                        </a:rPr>
-                        <a:t>lake</a:t>
-                      </a:r>
-                    </a:p>
-                  </a:txBody>
-                  <a:tcPr anchor="ctr" marB="63500" marT="63500" marR="0" marL="0">
-                    <a:lnL algn="ctr" cmpd="sng" cap="flat" w="0">
-                      <a:noFill/>
-                      <a:prstDash val="solid"/>
-                    </a:lnL>
-                    <a:lnR algn="ctr" cmpd="sng" cap="flat" w="0">
-                      <a:noFill/>
-                      <a:prstDash val="solid"/>
-                    </a:lnR>
-                    <a:lnT algn="ctr" cmpd="sng" cap="flat" w="19050">
-                      <a:solidFill>
-                        <a:srgbClr val="666666">
-                          <a:alpha val="100000"/>
-                        </a:srgbClr>
-                      </a:solidFill>
-                      <a:prstDash val="solid"/>
-                    </a:lnT>
-                    <a:lnB algn="ctr" cmpd="sng" cap="flat" w="19050">
-                      <a:solidFill>
-                        <a:srgbClr val="666666">
-                          <a:alpha val="100000"/>
-                        </a:srgbClr>
-                      </a:solidFill>
-                      <a:prstDash val="solid"/>
-                    </a:lnB>
-                    <a:solidFill>
-                      <a:srgbClr val="FFFFFF">
-                        <a:alpha val="0"/>
-                      </a:srgbClr>
-                    </a:solidFill>
-                  </a:tcPr>
-                </a:tc>
-                <a:tc>
-                  <a:txBody>
-                    <a:bodyPr/>
-                    <a:lstStyle/>
-                    <a:p>
-                      <a:pPr algn="r" marL="63500" marR="63500">
-                        <a:lnSpc>
-                          <a:spcPct val="100000"/>
-                        </a:lnSpc>
-                        <a:spcBef>
-                          <a:spcPts val="500"/>
-                        </a:spcBef>
-                        <a:spcAft>
-                          <a:spcPts val="500"/>
-                        </a:spcAft>
-                        <a:buNone/>
-                      </a:pPr>
-                      <a:r>
-                        <a:rPr cap="none" sz="1100" i="0" b="0" u="none">
-                          <a:solidFill>
-                            <a:srgbClr val="000000">
-                              <a:alpha val="100000"/>
-                            </a:srgbClr>
-                          </a:solidFill>
-                          <a:latin typeface="Helvetica"/>
-                          <a:cs typeface="Helvetica"/>
-                          <a:ea typeface="Helvetica"/>
-                          <a:sym typeface="Helvetica"/>
-                        </a:rPr>
-                        <a:t>median_length</a:t>
-                      </a:r>
-                    </a:p>
-                  </a:txBody>
-                  <a:tcPr anchor="ctr" marB="63500" marT="63500" marR="0" marL="0">
-                    <a:lnL algn="ctr" cmpd="sng" cap="flat" w="0">
-                      <a:noFill/>
-                      <a:prstDash val="solid"/>
-                    </a:lnL>
-                    <a:lnR algn="ctr" cmpd="sng" cap="flat" w="0">
-                      <a:noFill/>
-                      <a:prstDash val="solid"/>
-                    </a:lnR>
-                    <a:lnT algn="ctr" cmpd="sng" cap="flat" w="19050">
-                      <a:solidFill>
-                        <a:srgbClr val="666666">
-                          <a:alpha val="100000"/>
-                        </a:srgbClr>
-                      </a:solidFill>
-                      <a:prstDash val="solid"/>
-                    </a:lnT>
-                    <a:lnB algn="ctr" cmpd="sng" cap="flat" w="19050">
-                      <a:solidFill>
-                        <a:srgbClr val="666666">
-                          <a:alpha val="100000"/>
-                        </a:srgbClr>
-                      </a:solidFill>
-                      <a:prstDash val="solid"/>
-                    </a:lnB>
-                    <a:solidFill>
-                      <a:srgbClr val="FFFFFF">
-                        <a:alpha val="0"/>
-                      </a:srgbClr>
-                    </a:solidFill>
-                  </a:tcPr>
-                </a:tc>
-              </a:tr>
-              <a:tr h="228600">
-                <a:tc>
-                  <a:txBody>
-                    <a:bodyPr/>
-                    <a:lstStyle/>
-                    <a:p>
-                      <a:pPr algn="l" marL="63500" marR="63500">
-                        <a:lnSpc>
-                          <a:spcPct val="100000"/>
-                        </a:lnSpc>
-                        <a:spcBef>
-                          <a:spcPts val="500"/>
-                        </a:spcBef>
-                        <a:spcAft>
-                          <a:spcPts val="500"/>
-                        </a:spcAft>
-                        <a:buNone/>
-                      </a:pPr>
-                      <a:r>
-                        <a:rPr cap="none" sz="1100" i="0" b="0" u="none">
-                          <a:solidFill>
-                            <a:srgbClr val="000000">
-                              <a:alpha val="100000"/>
-                            </a:srgbClr>
-                          </a:solidFill>
-                          <a:latin typeface="Helvetica"/>
-                          <a:cs typeface="Helvetica"/>
-                          <a:ea typeface="Helvetica"/>
-                          <a:sym typeface="Helvetica"/>
-                        </a:rPr>
-                        <a:t>I3</a:t>
-                      </a:r>
-                    </a:p>
-                  </a:txBody>
-                  <a:tcPr anchor="ctr" marB="63500" marT="63500" marR="0" marL="0">
-                    <a:lnL algn="ctr" cmpd="sng" cap="flat" w="0">
-                      <a:noFill/>
-                      <a:prstDash val="solid"/>
-                    </a:lnL>
-                    <a:lnR algn="ctr" cmpd="sng" cap="flat" w="0">
-                      <a:noFill/>
-                      <a:prstDash val="solid"/>
-                    </a:lnR>
-                    <a:lnT algn="ctr" cmpd="sng" cap="flat" w="0">
-                      <a:noFill/>
-                      <a:prstDash val="solid"/>
-                    </a:lnT>
-                    <a:lnB algn="ctr" cmpd="sng" cap="flat" w="0">
-                      <a:noFill/>
-                      <a:prstDash val="solid"/>
-                    </a:lnB>
-                    <a:solidFill>
-                      <a:srgbClr val="FFFFFF">
-                        <a:alpha val="0"/>
-                      </a:srgbClr>
-                    </a:solidFill>
-                  </a:tcPr>
-                </a:tc>
-                <a:tc>
-                  <a:txBody>
-                    <a:bodyPr/>
-                    <a:lstStyle/>
-                    <a:p>
-                      <a:pPr algn="r" marL="63500" marR="63500">
-                        <a:lnSpc>
-                          <a:spcPct val="100000"/>
-                        </a:lnSpc>
-                        <a:spcBef>
-                          <a:spcPts val="500"/>
-                        </a:spcBef>
-                        <a:spcAft>
-                          <a:spcPts val="500"/>
-                        </a:spcAft>
-                        <a:buNone/>
-                      </a:pPr>
-                      <a:r>
-                        <a:rPr cap="none" sz="1100" i="0" b="0" u="none">
-                          <a:solidFill>
-                            <a:srgbClr val="000000">
-                              <a:alpha val="100000"/>
-                            </a:srgbClr>
-                          </a:solidFill>
-                          <a:latin typeface="Helvetica"/>
-                          <a:cs typeface="Helvetica"/>
-                          <a:ea typeface="Helvetica"/>
-                          <a:sym typeface="Helvetica"/>
-                        </a:rPr>
-                        <a:t>266</a:t>
-                      </a:r>
-                    </a:p>
-                  </a:txBody>
-                  <a:tcPr anchor="ctr" marB="63500" marT="63500" marR="0" marL="0">
-                    <a:lnL algn="ctr" cmpd="sng" cap="flat" w="0">
-                      <a:noFill/>
-                      <a:prstDash val="solid"/>
-                    </a:lnL>
-                    <a:lnR algn="ctr" cmpd="sng" cap="flat" w="0">
-                      <a:noFill/>
-                      <a:prstDash val="solid"/>
-                    </a:lnR>
-                    <a:lnT algn="ctr" cmpd="sng" cap="flat" w="0">
-                      <a:noFill/>
-                      <a:prstDash val="solid"/>
-                    </a:lnT>
-                    <a:lnB algn="ctr" cmpd="sng" cap="flat" w="0">
-                      <a:noFill/>
-                      <a:prstDash val="solid"/>
-                    </a:lnB>
-                    <a:solidFill>
-                      <a:srgbClr val="FFFFFF">
-                        <a:alpha val="0"/>
-                      </a:srgbClr>
-                    </a:solidFill>
-                  </a:tcPr>
-                </a:tc>
-              </a:tr>
-              <a:tr h="228600">
-                <a:tc>
-                  <a:txBody>
-                    <a:bodyPr/>
-                    <a:lstStyle/>
-                    <a:p>
-                      <a:pPr algn="l" marL="63500" marR="63500">
-                        <a:lnSpc>
-                          <a:spcPct val="100000"/>
-                        </a:lnSpc>
-                        <a:spcBef>
-                          <a:spcPts val="500"/>
-                        </a:spcBef>
-                        <a:spcAft>
-                          <a:spcPts val="500"/>
-                        </a:spcAft>
-                        <a:buNone/>
-                      </a:pPr>
-                      <a:r>
-                        <a:rPr cap="none" sz="1100" i="0" b="0" u="none">
-                          <a:solidFill>
-                            <a:srgbClr val="000000">
-                              <a:alpha val="100000"/>
-                            </a:srgbClr>
-                          </a:solidFill>
-                          <a:latin typeface="Helvetica"/>
-                          <a:cs typeface="Helvetica"/>
-                          <a:ea typeface="Helvetica"/>
-                          <a:sym typeface="Helvetica"/>
-                        </a:rPr>
-                        <a:t>I8</a:t>
-                      </a:r>
-                    </a:p>
-                  </a:txBody>
-                  <a:tcPr anchor="ctr" marB="63500" marT="63500" marR="0" marL="0">
-                    <a:lnL algn="ctr" cmpd="sng" cap="flat" w="0">
-                      <a:noFill/>
-                      <a:prstDash val="solid"/>
-                    </a:lnL>
-                    <a:lnR algn="ctr" cmpd="sng" cap="flat" w="0">
-                      <a:noFill/>
-                      <a:prstDash val="solid"/>
-                    </a:lnR>
-                    <a:lnT algn="ctr" cmpd="sng" cap="flat" w="0">
-                      <a:noFill/>
-                      <a:prstDash val="solid"/>
-                    </a:lnT>
-                    <a:lnB algn="ctr" cmpd="sng" cap="flat" w="19050">
-                      <a:solidFill>
-                        <a:srgbClr val="666666">
-                          <a:alpha val="100000"/>
-                        </a:srgbClr>
-                      </a:solidFill>
-                      <a:prstDash val="solid"/>
-                    </a:lnB>
-                    <a:solidFill>
-                      <a:srgbClr val="FFFFFF">
-                        <a:alpha val="0"/>
-                      </a:srgbClr>
-                    </a:solidFill>
-                  </a:tcPr>
-                </a:tc>
-                <a:tc>
-                  <a:txBody>
-                    <a:bodyPr/>
-                    <a:lstStyle/>
-                    <a:p>
-                      <a:pPr algn="r" marL="63500" marR="63500">
-                        <a:lnSpc>
-                          <a:spcPct val="100000"/>
-                        </a:lnSpc>
-                        <a:spcBef>
-                          <a:spcPts val="500"/>
-                        </a:spcBef>
-                        <a:spcAft>
-                          <a:spcPts val="500"/>
-                        </a:spcAft>
-                        <a:buNone/>
-                      </a:pPr>
-                      <a:r>
-                        <a:rPr cap="none" sz="1100" i="0" b="0" u="none">
-                          <a:solidFill>
-                            <a:srgbClr val="000000">
-                              <a:alpha val="100000"/>
-                            </a:srgbClr>
-                          </a:solidFill>
-                          <a:latin typeface="Helvetica"/>
-                          <a:cs typeface="Helvetica"/>
-                          <a:ea typeface="Helvetica"/>
-                          <a:sym typeface="Helvetica"/>
-                        </a:rPr>
-                        <a:t>373</a:t>
-                      </a:r>
-                    </a:p>
-                  </a:txBody>
-                  <a:tcPr anchor="ctr" marB="63500" marT="63500" marR="0" marL="0">
-                    <a:lnL algn="ctr" cmpd="sng" cap="flat" w="0">
-                      <a:noFill/>
-                      <a:prstDash val="solid"/>
-                    </a:lnL>
-                    <a:lnR algn="ctr" cmpd="sng" cap="flat" w="0">
-                      <a:noFill/>
-                      <a:prstDash val="solid"/>
-                    </a:lnR>
-                    <a:lnT algn="ctr" cmpd="sng" cap="flat" w="0">
-                      <a:noFill/>
-                      <a:prstDash val="solid"/>
-                    </a:lnT>
-                    <a:lnB algn="ctr" cmpd="sng" cap="flat" w="19050">
-                      <a:solidFill>
-                        <a:srgbClr val="666666">
-                          <a:alpha val="100000"/>
-                        </a:srgbClr>
-                      </a:solidFill>
-                      <a:prstDash val="solid"/>
-                    </a:lnB>
-                    <a:solidFill>
-                      <a:srgbClr val="FFFFFF">
-                        <a:alpha val="0"/>
-                      </a:srgbClr>
-                    </a:solidFill>
-                  </a:tcPr>
-                </a:tc>
-              </a:tr>
-            </a:tbl>
-          </a:graphicData>
-        </a:graphic>
-      </p:graphicFrame>
     </p:spTree>
   </p:cSld>
 </p:sld>
@@ -5464,588 +4701,23 @@
               <a:t>Standard deviation of length: 65 mm</a:t>
             </a:r>
           </a:p>
+          <a:p>
+            <a:pPr lvl="0" indent="0">
+              <a:buNone/>
+            </a:pPr>
+            <a:r>
+              <a:rPr>
+                <a:latin typeface="Courier"/>
+              </a:rPr>
+              <a:t># A tibble: 2 × 3
+  lake  var_length sd_length
+  &lt;chr&gt;      &lt;dbl&gt;     &lt;dbl&gt;
+1 I3          801.      28.3
+2 I8         2739.      52.3</a:t>
+            </a:r>
+          </a:p>
         </p:txBody>
       </p:sp>
-      <p:graphicFrame xmlns:a="http://schemas.openxmlformats.org/drawingml/2006/main" xmlns:r="http://schemas.openxmlformats.org/officeDocument/2006/relationships" xmlns:p="http://schemas.openxmlformats.org/presentationml/2006/main">
-        <p:nvGraphicFramePr>
-          <p:cNvPr id="429456795" name=""/>
-          <p:cNvGraphicFramePr>
-            <a:graphicFrameLocks noGrp="true"/>
-          </p:cNvGraphicFramePr>
-          <p:nvPr/>
-        </p:nvGraphicFramePr>
-        <p:xfrm rot="0">
-          <a:off x="914400" y="1828800"/>
-          <a:ext cx="9144000" cy="5486400"/>
-        </p:xfrm>
-        <a:graphic>
-          <a:graphicData uri="http://schemas.openxmlformats.org/drawingml/2006/table">
-            <a:tbl>
-              <a:tblPr/>
-              <a:tblGrid>
-                <a:gridCol w="685800"/>
-                <a:gridCol w="685800"/>
-                <a:gridCol w="685800"/>
-              </a:tblGrid>
-              <a:tr h="228600">
-                <a:tc>
-                  <a:txBody>
-                    <a:bodyPr/>
-                    <a:lstStyle/>
-                    <a:p>
-                      <a:pPr algn="l" marL="63500" marR="63500">
-                        <a:lnSpc>
-                          <a:spcPct val="100000"/>
-                        </a:lnSpc>
-                        <a:spcBef>
-                          <a:spcPts val="500"/>
-                        </a:spcBef>
-                        <a:spcAft>
-                          <a:spcPts val="500"/>
-                        </a:spcAft>
-                        <a:buNone/>
-                      </a:pPr>
-                      <a:r>
-                        <a:rPr cap="none" sz="1100" i="0" b="0" u="none">
-                          <a:solidFill>
-                            <a:srgbClr val="000000">
-                              <a:alpha val="100000"/>
-                            </a:srgbClr>
-                          </a:solidFill>
-                          <a:latin typeface="Helvetica"/>
-                          <a:cs typeface="Helvetica"/>
-                          <a:ea typeface="Helvetica"/>
-                          <a:sym typeface="Helvetica"/>
-                        </a:rPr>
-                        <a:t>lake</a:t>
-                      </a:r>
-                    </a:p>
-                  </a:txBody>
-                  <a:tcPr anchor="ctr" marB="63500" marT="63500" marR="0" marL="0">
-                    <a:lnL algn="ctr" cmpd="sng" cap="flat" w="0">
-                      <a:noFill/>
-                      <a:prstDash val="solid"/>
-                    </a:lnL>
-                    <a:lnR algn="ctr" cmpd="sng" cap="flat" w="0">
-                      <a:noFill/>
-                      <a:prstDash val="solid"/>
-                    </a:lnR>
-                    <a:lnT algn="ctr" cmpd="sng" cap="flat" w="19050">
-                      <a:solidFill>
-                        <a:srgbClr val="666666">
-                          <a:alpha val="100000"/>
-                        </a:srgbClr>
-                      </a:solidFill>
-                      <a:prstDash val="solid"/>
-                    </a:lnT>
-                    <a:lnB algn="ctr" cmpd="sng" cap="flat" w="19050">
-                      <a:solidFill>
-                        <a:srgbClr val="666666">
-                          <a:alpha val="100000"/>
-                        </a:srgbClr>
-                      </a:solidFill>
-                      <a:prstDash val="solid"/>
-                    </a:lnB>
-                    <a:solidFill>
-                      <a:srgbClr val="FFFFFF">
-                        <a:alpha val="0"/>
-                      </a:srgbClr>
-                    </a:solidFill>
-                  </a:tcPr>
-                </a:tc>
-                <a:tc>
-                  <a:txBody>
-                    <a:bodyPr/>
-                    <a:lstStyle/>
-                    <a:p>
-                      <a:pPr algn="r" marL="63500" marR="63500">
-                        <a:lnSpc>
-                          <a:spcPct val="100000"/>
-                        </a:lnSpc>
-                        <a:spcBef>
-                          <a:spcPts val="500"/>
-                        </a:spcBef>
-                        <a:spcAft>
-                          <a:spcPts val="500"/>
-                        </a:spcAft>
-                        <a:buNone/>
-                      </a:pPr>
-                      <a:r>
-                        <a:rPr cap="none" sz="1100" i="0" b="0" u="none">
-                          <a:solidFill>
-                            <a:srgbClr val="000000">
-                              <a:alpha val="100000"/>
-                            </a:srgbClr>
-                          </a:solidFill>
-                          <a:latin typeface="Helvetica"/>
-                          <a:cs typeface="Helvetica"/>
-                          <a:ea typeface="Helvetica"/>
-                          <a:sym typeface="Helvetica"/>
-                        </a:rPr>
-                        <a:t>var_length</a:t>
-                      </a:r>
-                    </a:p>
-                  </a:txBody>
-                  <a:tcPr anchor="ctr" marB="63500" marT="63500" marR="0" marL="0">
-                    <a:lnL algn="ctr" cmpd="sng" cap="flat" w="0">
-                      <a:noFill/>
-                      <a:prstDash val="solid"/>
-                    </a:lnL>
-                    <a:lnR algn="ctr" cmpd="sng" cap="flat" w="0">
-                      <a:noFill/>
-                      <a:prstDash val="solid"/>
-                    </a:lnR>
-                    <a:lnT algn="ctr" cmpd="sng" cap="flat" w="19050">
-                      <a:solidFill>
-                        <a:srgbClr val="666666">
-                          <a:alpha val="100000"/>
-                        </a:srgbClr>
-                      </a:solidFill>
-                      <a:prstDash val="solid"/>
-                    </a:lnT>
-                    <a:lnB algn="ctr" cmpd="sng" cap="flat" w="19050">
-                      <a:solidFill>
-                        <a:srgbClr val="666666">
-                          <a:alpha val="100000"/>
-                        </a:srgbClr>
-                      </a:solidFill>
-                      <a:prstDash val="solid"/>
-                    </a:lnB>
-                    <a:solidFill>
-                      <a:srgbClr val="FFFFFF">
-                        <a:alpha val="0"/>
-                      </a:srgbClr>
-                    </a:solidFill>
-                  </a:tcPr>
-                </a:tc>
-                <a:tc>
-                  <a:txBody>
-                    <a:bodyPr/>
-                    <a:lstStyle/>
-                    <a:p>
-                      <a:pPr algn="r" marL="63500" marR="63500">
-                        <a:lnSpc>
-                          <a:spcPct val="100000"/>
-                        </a:lnSpc>
-                        <a:spcBef>
-                          <a:spcPts val="500"/>
-                        </a:spcBef>
-                        <a:spcAft>
-                          <a:spcPts val="500"/>
-                        </a:spcAft>
-                        <a:buNone/>
-                      </a:pPr>
-                      <a:r>
-                        <a:rPr cap="none" sz="1100" i="0" b="0" u="none">
-                          <a:solidFill>
-                            <a:srgbClr val="000000">
-                              <a:alpha val="100000"/>
-                            </a:srgbClr>
-                          </a:solidFill>
-                          <a:latin typeface="Helvetica"/>
-                          <a:cs typeface="Helvetica"/>
-                          <a:ea typeface="Helvetica"/>
-                          <a:sym typeface="Helvetica"/>
-                        </a:rPr>
-                        <a:t>sd_length</a:t>
-                      </a:r>
-                    </a:p>
-                  </a:txBody>
-                  <a:tcPr anchor="ctr" marB="63500" marT="63500" marR="0" marL="0">
-                    <a:lnL algn="ctr" cmpd="sng" cap="flat" w="0">
-                      <a:noFill/>
-                      <a:prstDash val="solid"/>
-                    </a:lnL>
-                    <a:lnR algn="ctr" cmpd="sng" cap="flat" w="0">
-                      <a:noFill/>
-                      <a:prstDash val="solid"/>
-                    </a:lnR>
-                    <a:lnT algn="ctr" cmpd="sng" cap="flat" w="19050">
-                      <a:solidFill>
-                        <a:srgbClr val="666666">
-                          <a:alpha val="100000"/>
-                        </a:srgbClr>
-                      </a:solidFill>
-                      <a:prstDash val="solid"/>
-                    </a:lnT>
-                    <a:lnB algn="ctr" cmpd="sng" cap="flat" w="19050">
-                      <a:solidFill>
-                        <a:srgbClr val="666666">
-                          <a:alpha val="100000"/>
-                        </a:srgbClr>
-                      </a:solidFill>
-                      <a:prstDash val="solid"/>
-                    </a:lnB>
-                    <a:solidFill>
-                      <a:srgbClr val="FFFFFF">
-                        <a:alpha val="0"/>
-                      </a:srgbClr>
-                    </a:solidFill>
-                  </a:tcPr>
-                </a:tc>
-              </a:tr>
-              <a:tr h="228600">
-                <a:tc>
-                  <a:txBody>
-                    <a:bodyPr/>
-                    <a:lstStyle/>
-                    <a:p>
-                      <a:pPr algn="l" marL="63500" marR="63500">
-                        <a:lnSpc>
-                          <a:spcPct val="100000"/>
-                        </a:lnSpc>
-                        <a:spcBef>
-                          <a:spcPts val="500"/>
-                        </a:spcBef>
-                        <a:spcAft>
-                          <a:spcPts val="500"/>
-                        </a:spcAft>
-                        <a:buNone/>
-                      </a:pPr>
-                      <a:r>
-                        <a:rPr cap="none" sz="1100" i="0" b="0" u="none">
-                          <a:solidFill>
-                            <a:srgbClr val="000000">
-                              <a:alpha val="100000"/>
-                            </a:srgbClr>
-                          </a:solidFill>
-                          <a:latin typeface="Helvetica"/>
-                          <a:cs typeface="Helvetica"/>
-                          <a:ea typeface="Helvetica"/>
-                          <a:sym typeface="Helvetica"/>
-                        </a:rPr>
-                        <a:t>I3</a:t>
-                      </a:r>
-                    </a:p>
-                  </a:txBody>
-                  <a:tcPr anchor="ctr" marB="63500" marT="63500" marR="0" marL="0">
-                    <a:lnL algn="ctr" cmpd="sng" cap="flat" w="0">
-                      <a:noFill/>
-                      <a:prstDash val="solid"/>
-                    </a:lnL>
-                    <a:lnR algn="ctr" cmpd="sng" cap="flat" w="0">
-                      <a:noFill/>
-                      <a:prstDash val="solid"/>
-                    </a:lnR>
-                    <a:lnT algn="ctr" cmpd="sng" cap="flat" w="0">
-                      <a:noFill/>
-                      <a:prstDash val="solid"/>
-                    </a:lnT>
-                    <a:lnB algn="ctr" cmpd="sng" cap="flat" w="0">
-                      <a:noFill/>
-                      <a:prstDash val="solid"/>
-                    </a:lnB>
-                    <a:solidFill>
-                      <a:srgbClr val="FFFFFF">
-                        <a:alpha val="0"/>
-                      </a:srgbClr>
-                    </a:solidFill>
-                  </a:tcPr>
-                </a:tc>
-                <a:tc>
-                  <a:txBody>
-                    <a:bodyPr/>
-                    <a:lstStyle/>
-                    <a:p>
-                      <a:pPr algn="r" marL="63500" marR="63500">
-                        <a:lnSpc>
-                          <a:spcPct val="100000"/>
-                        </a:lnSpc>
-                        <a:spcBef>
-                          <a:spcPts val="500"/>
-                        </a:spcBef>
-                        <a:spcAft>
-                          <a:spcPts val="500"/>
-                        </a:spcAft>
-                        <a:buNone/>
-                      </a:pPr>
-                      <a:r>
-                        <a:rPr cap="none" sz="1100" i="0" b="0" u="none">
-                          <a:solidFill>
-                            <a:srgbClr val="000000">
-                              <a:alpha val="100000"/>
-                            </a:srgbClr>
-                          </a:solidFill>
-                          <a:latin typeface="Helvetica"/>
-                          <a:cs typeface="Helvetica"/>
-                          <a:ea typeface="Helvetica"/>
-                          <a:sym typeface="Helvetica"/>
-                        </a:rPr>
-                        <a:t>801.104</a:t>
-                      </a:r>
-                    </a:p>
-                  </a:txBody>
-                  <a:tcPr anchor="ctr" marB="63500" marT="63500" marR="0" marL="0">
-                    <a:lnL algn="ctr" cmpd="sng" cap="flat" w="0">
-                      <a:noFill/>
-                      <a:prstDash val="solid"/>
-                    </a:lnL>
-                    <a:lnR algn="ctr" cmpd="sng" cap="flat" w="0">
-                      <a:noFill/>
-                      <a:prstDash val="solid"/>
-                    </a:lnR>
-                    <a:lnT algn="ctr" cmpd="sng" cap="flat" w="0">
-                      <a:noFill/>
-                      <a:prstDash val="solid"/>
-                    </a:lnT>
-                    <a:lnB algn="ctr" cmpd="sng" cap="flat" w="0">
-                      <a:noFill/>
-                      <a:prstDash val="solid"/>
-                    </a:lnB>
-                    <a:solidFill>
-                      <a:srgbClr val="FFFFFF">
-                        <a:alpha val="0"/>
-                      </a:srgbClr>
-                    </a:solidFill>
-                  </a:tcPr>
-                </a:tc>
-                <a:tc>
-                  <a:txBody>
-                    <a:bodyPr/>
-                    <a:lstStyle/>
-                    <a:p>
-                      <a:pPr algn="r" marL="63500" marR="63500">
-                        <a:lnSpc>
-                          <a:spcPct val="100000"/>
-                        </a:lnSpc>
-                        <a:spcBef>
-                          <a:spcPts val="500"/>
-                        </a:spcBef>
-                        <a:spcAft>
-                          <a:spcPts val="500"/>
-                        </a:spcAft>
-                        <a:buNone/>
-                      </a:pPr>
-                      <a:r>
-                        <a:rPr cap="none" sz="1100" i="0" b="0" u="none">
-                          <a:solidFill>
-                            <a:srgbClr val="000000">
-                              <a:alpha val="100000"/>
-                            </a:srgbClr>
-                          </a:solidFill>
-                          <a:latin typeface="Helvetica"/>
-                          <a:cs typeface="Helvetica"/>
-                          <a:ea typeface="Helvetica"/>
-                          <a:sym typeface="Helvetica"/>
-                        </a:rPr>
-                        <a:t>28.30378</a:t>
-                      </a:r>
-                    </a:p>
-                  </a:txBody>
-                  <a:tcPr anchor="ctr" marB="63500" marT="63500" marR="0" marL="0">
-                    <a:lnL algn="ctr" cmpd="sng" cap="flat" w="0">
-                      <a:noFill/>
-                      <a:prstDash val="solid"/>
-                    </a:lnL>
-                    <a:lnR algn="ctr" cmpd="sng" cap="flat" w="0">
-                      <a:noFill/>
-                      <a:prstDash val="solid"/>
-                    </a:lnR>
-                    <a:lnT algn="ctr" cmpd="sng" cap="flat" w="0">
-                      <a:noFill/>
-                      <a:prstDash val="solid"/>
-                    </a:lnT>
-                    <a:lnB algn="ctr" cmpd="sng" cap="flat" w="0">
-                      <a:noFill/>
-                      <a:prstDash val="solid"/>
-                    </a:lnB>
-                    <a:solidFill>
-                      <a:srgbClr val="FFFFFF">
-                        <a:alpha val="0"/>
-                      </a:srgbClr>
-                    </a:solidFill>
-                  </a:tcPr>
-                </a:tc>
-              </a:tr>
-              <a:tr h="228600">
-                <a:tc>
-                  <a:txBody>
-                    <a:bodyPr/>
-                    <a:lstStyle/>
-                    <a:p>
-                      <a:pPr algn="l" marL="63500" marR="63500">
-                        <a:lnSpc>
-                          <a:spcPct val="100000"/>
-                        </a:lnSpc>
-                        <a:spcBef>
-                          <a:spcPts val="500"/>
-                        </a:spcBef>
-                        <a:spcAft>
-                          <a:spcPts val="500"/>
-                        </a:spcAft>
-                        <a:buNone/>
-                      </a:pPr>
-                      <a:r>
-                        <a:rPr cap="none" sz="1100" i="0" b="0" u="none">
-                          <a:solidFill>
-                            <a:srgbClr val="000000">
-                              <a:alpha val="100000"/>
-                            </a:srgbClr>
-                          </a:solidFill>
-                          <a:latin typeface="Helvetica"/>
-                          <a:cs typeface="Helvetica"/>
-                          <a:ea typeface="Helvetica"/>
-                          <a:sym typeface="Helvetica"/>
-                        </a:rPr>
-                        <a:t>I8</a:t>
-                      </a:r>
-                    </a:p>
-                  </a:txBody>
-                  <a:tcPr anchor="ctr" marB="63500" marT="63500" marR="0" marL="0">
-                    <a:lnL algn="ctr" cmpd="sng" cap="flat" w="0">
-                      <a:noFill/>
-                      <a:prstDash val="solid"/>
-                    </a:lnL>
-                    <a:lnR algn="ctr" cmpd="sng" cap="flat" w="0">
-                      <a:noFill/>
-                      <a:prstDash val="solid"/>
-                    </a:lnR>
-                    <a:lnT algn="ctr" cmpd="sng" cap="flat" w="0">
-                      <a:noFill/>
-                      <a:prstDash val="solid"/>
-                    </a:lnT>
-                    <a:lnB algn="ctr" cmpd="sng" cap="flat" w="19050">
-                      <a:solidFill>
-                        <a:srgbClr val="666666">
-                          <a:alpha val="100000"/>
-                        </a:srgbClr>
-                      </a:solidFill>
-                      <a:prstDash val="solid"/>
-                    </a:lnB>
-                    <a:solidFill>
-                      <a:srgbClr val="FFFFFF">
-                        <a:alpha val="0"/>
-                      </a:srgbClr>
-                    </a:solidFill>
-                  </a:tcPr>
-                </a:tc>
-                <a:tc>
-                  <a:txBody>
-                    <a:bodyPr/>
-                    <a:lstStyle/>
-                    <a:p>
-                      <a:pPr algn="r" marL="63500" marR="63500">
-                        <a:lnSpc>
-                          <a:spcPct val="100000"/>
-                        </a:lnSpc>
-                        <a:spcBef>
-                          <a:spcPts val="500"/>
-                        </a:spcBef>
-                        <a:spcAft>
-                          <a:spcPts val="500"/>
-                        </a:spcAft>
-                        <a:buNone/>
-                      </a:pPr>
-                      <a:r>
-                        <a:rPr cap="none" sz="1100" i="0" b="0" u="none">
-                          <a:solidFill>
-                            <a:srgbClr val="000000">
-                              <a:alpha val="100000"/>
-                            </a:srgbClr>
-                          </a:solidFill>
-                          <a:latin typeface="Helvetica"/>
-                          <a:cs typeface="Helvetica"/>
-                          <a:ea typeface="Helvetica"/>
-                          <a:sym typeface="Helvetica"/>
-                        </a:rPr>
-                        <a:t>2,739.371</a:t>
-                      </a:r>
-                    </a:p>
-                  </a:txBody>
-                  <a:tcPr anchor="ctr" marB="63500" marT="63500" marR="0" marL="0">
-                    <a:lnL algn="ctr" cmpd="sng" cap="flat" w="0">
-                      <a:noFill/>
-                      <a:prstDash val="solid"/>
-                    </a:lnL>
-                    <a:lnR algn="ctr" cmpd="sng" cap="flat" w="0">
-                      <a:noFill/>
-                      <a:prstDash val="solid"/>
-                    </a:lnR>
-                    <a:lnT algn="ctr" cmpd="sng" cap="flat" w="0">
-                      <a:noFill/>
-                      <a:prstDash val="solid"/>
-                    </a:lnT>
-                    <a:lnB algn="ctr" cmpd="sng" cap="flat" w="19050">
-                      <a:solidFill>
-                        <a:srgbClr val="666666">
-                          <a:alpha val="100000"/>
-                        </a:srgbClr>
-                      </a:solidFill>
-                      <a:prstDash val="solid"/>
-                    </a:lnB>
-                    <a:solidFill>
-                      <a:srgbClr val="FFFFFF">
-                        <a:alpha val="0"/>
-                      </a:srgbClr>
-                    </a:solidFill>
-                  </a:tcPr>
-                </a:tc>
-                <a:tc>
-                  <a:txBody>
-                    <a:bodyPr/>
-                    <a:lstStyle/>
-                    <a:p>
-                      <a:pPr algn="r" marL="63500" marR="63500">
-                        <a:lnSpc>
-                          <a:spcPct val="100000"/>
-                        </a:lnSpc>
-                        <a:spcBef>
-                          <a:spcPts val="500"/>
-                        </a:spcBef>
-                        <a:spcAft>
-                          <a:spcPts val="500"/>
-                        </a:spcAft>
-                        <a:buNone/>
-                      </a:pPr>
-                      <a:r>
-                        <a:rPr cap="none" sz="1100" i="0" b="0" u="none">
-                          <a:solidFill>
-                            <a:srgbClr val="000000">
-                              <a:alpha val="100000"/>
-                            </a:srgbClr>
-                          </a:solidFill>
-                          <a:latin typeface="Helvetica"/>
-                          <a:cs typeface="Helvetica"/>
-                          <a:ea typeface="Helvetica"/>
-                          <a:sym typeface="Helvetica"/>
-                        </a:rPr>
-                        <a:t>52.33901</a:t>
-                      </a:r>
-                    </a:p>
-                  </a:txBody>
-                  <a:tcPr anchor="ctr" marB="63500" marT="63500" marR="0" marL="0">
-                    <a:lnL algn="ctr" cmpd="sng" cap="flat" w="0">
-                      <a:noFill/>
-                      <a:prstDash val="solid"/>
-                    </a:lnL>
-                    <a:lnR algn="ctr" cmpd="sng" cap="flat" w="0">
-                      <a:noFill/>
-                      <a:prstDash val="solid"/>
-                    </a:lnR>
-                    <a:lnT algn="ctr" cmpd="sng" cap="flat" w="0">
-                      <a:noFill/>
-                      <a:prstDash val="solid"/>
-                    </a:lnT>
-                    <a:lnB algn="ctr" cmpd="sng" cap="flat" w="19050">
-                      <a:solidFill>
-                        <a:srgbClr val="666666">
-                          <a:alpha val="100000"/>
-                        </a:srgbClr>
-                      </a:solidFill>
-                      <a:prstDash val="solid"/>
-                    </a:lnB>
-                    <a:solidFill>
-                      <a:srgbClr val="FFFFFF">
-                        <a:alpha val="0"/>
-                      </a:srgbClr>
-                    </a:solidFill>
-                  </a:tcPr>
-                </a:tc>
-              </a:tr>
-            </a:tbl>
-          </a:graphicData>
-        </a:graphic>
-      </p:graphicFrame>
     </p:spTree>
   </p:cSld>
 </p:sld>
@@ -7917,6 +6589,35 @@
               <a:t>When data are log-normally distributed, the geometric mean often provides a better measure of central tendency than the arithmetic mean.</a:t>
             </a:r>
           </a:p>
+          <a:p>
+            <a:pPr lvl="0"/>
+            <a:r>
+              <a:rPr/>
+              <a:t>But there are issues and it might not be good…</a:t>
+            </a:r>
+          </a:p>
+          <a:p>
+            <a:pPr lvl="1"/>
+            <a:r>
+              <a:rPr/>
+              <a:t>detecting differences in geometric means, not arithmetic means</a:t>
+            </a:r>
+          </a:p>
+          <a:p>
+            <a:pPr lvl="2"/>
+            <a:r>
+              <a:rPr/>
+              <a:t>geometric is all values multiplied taken to the nth root</a:t>
+            </a:r>
+          </a:p>
+          <a:p>
+            <a:pPr lvl="1"/>
+            <a:r>
+              <a:rPr/>
+              <a:t>Can’t handle zeros without adding arbitrary constants (log(x+1) transformations), which can bias results</a:t>
+            </a:r>
+            <a:br/>
+          </a:p>
         </p:txBody>
       </p:sp>
       <p:pic>
@@ -8023,59 +6724,52 @@
             </a:r>
           </a:p>
           <a:p>
-            <a:pPr lvl="0"/>
+            <a:pPr lvl="1"/>
             <a:r>
               <a:rPr/>
-              <a:t>How to design a well-organized project</a:t>
-            </a:r>
-          </a:p>
-          <a:p>
-            <a:pPr lvl="0"/>
+              <a:t>How to design a well-organized project structure</a:t>
+            </a:r>
+          </a:p>
+          <a:p>
+            <a:pPr lvl="1"/>
             <a:r>
               <a:rPr/>
               <a:t>How to implement good naming conventions</a:t>
             </a:r>
           </a:p>
           <a:p>
-            <a:pPr lvl="1"/>
+            <a:pPr lvl="2"/>
             <a:r>
               <a:rPr/>
               <a:t>Controlled vocabulary</a:t>
             </a:r>
           </a:p>
           <a:p>
-            <a:pPr lvl="1"/>
+            <a:pPr lvl="2"/>
             <a:r>
               <a:rPr/>
               <a:t>Including units in names</a:t>
             </a:r>
           </a:p>
           <a:p>
-            <a:pPr lvl="0"/>
+            <a:pPr lvl="1"/>
             <a:r>
               <a:rPr/>
               <a:t>Create and use metadata effectively</a:t>
             </a:r>
           </a:p>
           <a:p>
-            <a:pPr lvl="0"/>
+            <a:pPr lvl="1"/>
             <a:r>
               <a:rPr/>
               <a:t>Build tidy, well-structured spreadsheets</a:t>
             </a:r>
           </a:p>
           <a:p>
-            <a:pPr lvl="0"/>
+            <a:pPr lvl="1"/>
             <a:r>
               <a:rPr/>
-              <a:t>Understand data repositories</a:t>
-            </a:r>
-          </a:p>
-          <a:p>
-            <a:pPr lvl="0"/>
-            <a:r>
-              <a:rPr/>
-              <a:t>Create effective visualizations with ggplot2</a:t>
+              <a:t>Create visualizations with ggplot2</a:t>
             </a:r>
           </a:p>
         </p:txBody>
@@ -8654,1138 +7348,37 @@
           </a:p>
         </p:txBody>
       </p:sp>
-      <p:graphicFrame xmlns:a="http://schemas.openxmlformats.org/drawingml/2006/main" xmlns:r="http://schemas.openxmlformats.org/officeDocument/2006/relationships" xmlns:p="http://schemas.openxmlformats.org/presentationml/2006/main">
-        <p:nvGraphicFramePr>
-          <p:cNvPr id="455712672" name=""/>
-          <p:cNvGraphicFramePr>
-            <a:graphicFrameLocks noGrp="true"/>
-          </p:cNvGraphicFramePr>
-          <p:nvPr/>
-        </p:nvGraphicFramePr>
-        <p:xfrm rot="0">
-          <a:off x="914400" y="1828800"/>
-          <a:ext cx="9144000" cy="5486400"/>
-        </p:xfrm>
-        <a:graphic>
-          <a:graphicData uri="http://schemas.openxmlformats.org/drawingml/2006/table">
-            <a:tbl>
-              <a:tblPr/>
-              <a:tblGrid>
-                <a:gridCol w="685800"/>
-                <a:gridCol w="685800"/>
-                <a:gridCol w="685800"/>
-                <a:gridCol w="685800"/>
-                <a:gridCol w="685800"/>
-                <a:gridCol w="685800"/>
-              </a:tblGrid>
-              <a:tr h="228600">
-                <a:tc>
-                  <a:txBody>
-                    <a:bodyPr/>
-                    <a:lstStyle/>
-                    <a:p>
-                      <a:pPr algn="l" marL="63500" marR="63500">
-                        <a:lnSpc>
-                          <a:spcPct val="100000"/>
-                        </a:lnSpc>
-                        <a:spcBef>
-                          <a:spcPts val="500"/>
-                        </a:spcBef>
-                        <a:spcAft>
-                          <a:spcPts val="500"/>
-                        </a:spcAft>
-                        <a:buNone/>
-                      </a:pPr>
-                      <a:r>
-                        <a:rPr cap="none" sz="1100" i="0" b="0" u="none">
-                          <a:solidFill>
-                            <a:srgbClr val="000000">
-                              <a:alpha val="100000"/>
-                            </a:srgbClr>
-                          </a:solidFill>
-                          <a:latin typeface="Helvetica"/>
-                          <a:cs typeface="Helvetica"/>
-                          <a:ea typeface="Helvetica"/>
-                          <a:sym typeface="Helvetica"/>
-                        </a:rPr>
-                        <a:t>lake</a:t>
-                      </a:r>
-                    </a:p>
-                  </a:txBody>
-                  <a:tcPr anchor="ctr" marB="63500" marT="63500" marR="0" marL="0">
-                    <a:lnL algn="ctr" cmpd="sng" cap="flat" w="0">
-                      <a:noFill/>
-                      <a:prstDash val="solid"/>
-                    </a:lnL>
-                    <a:lnR algn="ctr" cmpd="sng" cap="flat" w="0">
-                      <a:noFill/>
-                      <a:prstDash val="solid"/>
-                    </a:lnR>
-                    <a:lnT algn="ctr" cmpd="sng" cap="flat" w="19050">
-                      <a:solidFill>
-                        <a:srgbClr val="666666">
-                          <a:alpha val="100000"/>
-                        </a:srgbClr>
-                      </a:solidFill>
-                      <a:prstDash val="solid"/>
-                    </a:lnT>
-                    <a:lnB algn="ctr" cmpd="sng" cap="flat" w="19050">
-                      <a:solidFill>
-                        <a:srgbClr val="666666">
-                          <a:alpha val="100000"/>
-                        </a:srgbClr>
-                      </a:solidFill>
-                      <a:prstDash val="solid"/>
-                    </a:lnB>
-                    <a:solidFill>
-                      <a:srgbClr val="FFFFFF">
-                        <a:alpha val="0"/>
-                      </a:srgbClr>
-                    </a:solidFill>
-                  </a:tcPr>
-                </a:tc>
-                <a:tc>
-                  <a:txBody>
-                    <a:bodyPr/>
-                    <a:lstStyle/>
-                    <a:p>
-                      <a:pPr algn="r" marL="63500" marR="63500">
-                        <a:lnSpc>
-                          <a:spcPct val="100000"/>
-                        </a:lnSpc>
-                        <a:spcBef>
-                          <a:spcPts val="500"/>
-                        </a:spcBef>
-                        <a:spcAft>
-                          <a:spcPts val="500"/>
-                        </a:spcAft>
-                        <a:buNone/>
-                      </a:pPr>
-                      <a:r>
-                        <a:rPr cap="none" sz="1100" i="0" b="0" u="none">
-                          <a:solidFill>
-                            <a:srgbClr val="000000">
-                              <a:alpha val="100000"/>
-                            </a:srgbClr>
-                          </a:solidFill>
-                          <a:latin typeface="Helvetica"/>
-                          <a:cs typeface="Helvetica"/>
-                          <a:ea typeface="Helvetica"/>
-                          <a:sym typeface="Helvetica"/>
-                        </a:rPr>
-                        <a:t>mean</a:t>
-                      </a:r>
-                    </a:p>
-                  </a:txBody>
-                  <a:tcPr anchor="ctr" marB="63500" marT="63500" marR="0" marL="0">
-                    <a:lnL algn="ctr" cmpd="sng" cap="flat" w="0">
-                      <a:noFill/>
-                      <a:prstDash val="solid"/>
-                    </a:lnL>
-                    <a:lnR algn="ctr" cmpd="sng" cap="flat" w="0">
-                      <a:noFill/>
-                      <a:prstDash val="solid"/>
-                    </a:lnR>
-                    <a:lnT algn="ctr" cmpd="sng" cap="flat" w="19050">
-                      <a:solidFill>
-                        <a:srgbClr val="666666">
-                          <a:alpha val="100000"/>
-                        </a:srgbClr>
-                      </a:solidFill>
-                      <a:prstDash val="solid"/>
-                    </a:lnT>
-                    <a:lnB algn="ctr" cmpd="sng" cap="flat" w="19050">
-                      <a:solidFill>
-                        <a:srgbClr val="666666">
-                          <a:alpha val="100000"/>
-                        </a:srgbClr>
-                      </a:solidFill>
-                      <a:prstDash val="solid"/>
-                    </a:lnB>
-                    <a:solidFill>
-                      <a:srgbClr val="FFFFFF">
-                        <a:alpha val="0"/>
-                      </a:srgbClr>
-                    </a:solidFill>
-                  </a:tcPr>
-                </a:tc>
-                <a:tc>
-                  <a:txBody>
-                    <a:bodyPr/>
-                    <a:lstStyle/>
-                    <a:p>
-                      <a:pPr algn="r" marL="63500" marR="63500">
-                        <a:lnSpc>
-                          <a:spcPct val="100000"/>
-                        </a:lnSpc>
-                        <a:spcBef>
-                          <a:spcPts val="500"/>
-                        </a:spcBef>
-                        <a:spcAft>
-                          <a:spcPts val="500"/>
-                        </a:spcAft>
-                        <a:buNone/>
-                      </a:pPr>
-                      <a:r>
-                        <a:rPr cap="none" sz="1100" i="0" b="0" u="none">
-                          <a:solidFill>
-                            <a:srgbClr val="000000">
-                              <a:alpha val="100000"/>
-                            </a:srgbClr>
-                          </a:solidFill>
-                          <a:latin typeface="Helvetica"/>
-                          <a:cs typeface="Helvetica"/>
-                          <a:ea typeface="Helvetica"/>
-                          <a:sym typeface="Helvetica"/>
-                        </a:rPr>
-                        <a:t>median</a:t>
-                      </a:r>
-                    </a:p>
-                  </a:txBody>
-                  <a:tcPr anchor="ctr" marB="63500" marT="63500" marR="0" marL="0">
-                    <a:lnL algn="ctr" cmpd="sng" cap="flat" w="0">
-                      <a:noFill/>
-                      <a:prstDash val="solid"/>
-                    </a:lnL>
-                    <a:lnR algn="ctr" cmpd="sng" cap="flat" w="0">
-                      <a:noFill/>
-                      <a:prstDash val="solid"/>
-                    </a:lnR>
-                    <a:lnT algn="ctr" cmpd="sng" cap="flat" w="19050">
-                      <a:solidFill>
-                        <a:srgbClr val="666666">
-                          <a:alpha val="100000"/>
-                        </a:srgbClr>
-                      </a:solidFill>
-                      <a:prstDash val="solid"/>
-                    </a:lnT>
-                    <a:lnB algn="ctr" cmpd="sng" cap="flat" w="19050">
-                      <a:solidFill>
-                        <a:srgbClr val="666666">
-                          <a:alpha val="100000"/>
-                        </a:srgbClr>
-                      </a:solidFill>
-                      <a:prstDash val="solid"/>
-                    </a:lnB>
-                    <a:solidFill>
-                      <a:srgbClr val="FFFFFF">
-                        <a:alpha val="0"/>
-                      </a:srgbClr>
-                    </a:solidFill>
-                  </a:tcPr>
-                </a:tc>
-                <a:tc>
-                  <a:txBody>
-                    <a:bodyPr/>
-                    <a:lstStyle/>
-                    <a:p>
-                      <a:pPr algn="r" marL="63500" marR="63500">
-                        <a:lnSpc>
-                          <a:spcPct val="100000"/>
-                        </a:lnSpc>
-                        <a:spcBef>
-                          <a:spcPts val="500"/>
-                        </a:spcBef>
-                        <a:spcAft>
-                          <a:spcPts val="500"/>
-                        </a:spcAft>
-                        <a:buNone/>
-                      </a:pPr>
-                      <a:r>
-                        <a:rPr cap="none" sz="1100" i="0" b="0" u="none">
-                          <a:solidFill>
-                            <a:srgbClr val="000000">
-                              <a:alpha val="100000"/>
-                            </a:srgbClr>
-                          </a:solidFill>
-                          <a:latin typeface="Helvetica"/>
-                          <a:cs typeface="Helvetica"/>
-                          <a:ea typeface="Helvetica"/>
-                          <a:sym typeface="Helvetica"/>
-                        </a:rPr>
-                        <a:t>sd</a:t>
-                      </a:r>
-                    </a:p>
-                  </a:txBody>
-                  <a:tcPr anchor="ctr" marB="63500" marT="63500" marR="0" marL="0">
-                    <a:lnL algn="ctr" cmpd="sng" cap="flat" w="0">
-                      <a:noFill/>
-                      <a:prstDash val="solid"/>
-                    </a:lnL>
-                    <a:lnR algn="ctr" cmpd="sng" cap="flat" w="0">
-                      <a:noFill/>
-                      <a:prstDash val="solid"/>
-                    </a:lnR>
-                    <a:lnT algn="ctr" cmpd="sng" cap="flat" w="19050">
-                      <a:solidFill>
-                        <a:srgbClr val="666666">
-                          <a:alpha val="100000"/>
-                        </a:srgbClr>
-                      </a:solidFill>
-                      <a:prstDash val="solid"/>
-                    </a:lnT>
-                    <a:lnB algn="ctr" cmpd="sng" cap="flat" w="19050">
-                      <a:solidFill>
-                        <a:srgbClr val="666666">
-                          <a:alpha val="100000"/>
-                        </a:srgbClr>
-                      </a:solidFill>
-                      <a:prstDash val="solid"/>
-                    </a:lnB>
-                    <a:solidFill>
-                      <a:srgbClr val="FFFFFF">
-                        <a:alpha val="0"/>
-                      </a:srgbClr>
-                    </a:solidFill>
-                  </a:tcPr>
-                </a:tc>
-                <a:tc>
-                  <a:txBody>
-                    <a:bodyPr/>
-                    <a:lstStyle/>
-                    <a:p>
-                      <a:pPr algn="r" marL="63500" marR="63500">
-                        <a:lnSpc>
-                          <a:spcPct val="100000"/>
-                        </a:lnSpc>
-                        <a:spcBef>
-                          <a:spcPts val="500"/>
-                        </a:spcBef>
-                        <a:spcAft>
-                          <a:spcPts val="500"/>
-                        </a:spcAft>
-                        <a:buNone/>
-                      </a:pPr>
-                      <a:r>
-                        <a:rPr cap="none" sz="1100" i="0" b="0" u="none">
-                          <a:solidFill>
-                            <a:srgbClr val="000000">
-                              <a:alpha val="100000"/>
-                            </a:srgbClr>
-                          </a:solidFill>
-                          <a:latin typeface="Helvetica"/>
-                          <a:cs typeface="Helvetica"/>
-                          <a:ea typeface="Helvetica"/>
-                          <a:sym typeface="Helvetica"/>
-                        </a:rPr>
-                        <a:t>iqr</a:t>
-                      </a:r>
-                    </a:p>
-                  </a:txBody>
-                  <a:tcPr anchor="ctr" marB="63500" marT="63500" marR="0" marL="0">
-                    <a:lnL algn="ctr" cmpd="sng" cap="flat" w="0">
-                      <a:noFill/>
-                      <a:prstDash val="solid"/>
-                    </a:lnL>
-                    <a:lnR algn="ctr" cmpd="sng" cap="flat" w="0">
-                      <a:noFill/>
-                      <a:prstDash val="solid"/>
-                    </a:lnR>
-                    <a:lnT algn="ctr" cmpd="sng" cap="flat" w="19050">
-                      <a:solidFill>
-                        <a:srgbClr val="666666">
-                          <a:alpha val="100000"/>
-                        </a:srgbClr>
-                      </a:solidFill>
-                      <a:prstDash val="solid"/>
-                    </a:lnT>
-                    <a:lnB algn="ctr" cmpd="sng" cap="flat" w="19050">
-                      <a:solidFill>
-                        <a:srgbClr val="666666">
-                          <a:alpha val="100000"/>
-                        </a:srgbClr>
-                      </a:solidFill>
-                      <a:prstDash val="solid"/>
-                    </a:lnB>
-                    <a:solidFill>
-                      <a:srgbClr val="FFFFFF">
-                        <a:alpha val="0"/>
-                      </a:srgbClr>
-                    </a:solidFill>
-                  </a:tcPr>
-                </a:tc>
-                <a:tc>
-                  <a:txBody>
-                    <a:bodyPr/>
-                    <a:lstStyle/>
-                    <a:p>
-                      <a:pPr algn="r" marL="63500" marR="63500">
-                        <a:lnSpc>
-                          <a:spcPct val="100000"/>
-                        </a:lnSpc>
-                        <a:spcBef>
-                          <a:spcPts val="500"/>
-                        </a:spcBef>
-                        <a:spcAft>
-                          <a:spcPts val="500"/>
-                        </a:spcAft>
-                        <a:buNone/>
-                      </a:pPr>
-                      <a:r>
-                        <a:rPr cap="none" sz="1100" i="0" b="0" u="none">
-                          <a:solidFill>
-                            <a:srgbClr val="000000">
-                              <a:alpha val="100000"/>
-                            </a:srgbClr>
-                          </a:solidFill>
-                          <a:latin typeface="Helvetica"/>
-                          <a:cs typeface="Helvetica"/>
-                          <a:ea typeface="Helvetica"/>
-                          <a:sym typeface="Helvetica"/>
-                        </a:rPr>
-                        <a:t>skewness</a:t>
-                      </a:r>
-                    </a:p>
-                  </a:txBody>
-                  <a:tcPr anchor="ctr" marB="63500" marT="63500" marR="0" marL="0">
-                    <a:lnL algn="ctr" cmpd="sng" cap="flat" w="0">
-                      <a:noFill/>
-                      <a:prstDash val="solid"/>
-                    </a:lnL>
-                    <a:lnR algn="ctr" cmpd="sng" cap="flat" w="0">
-                      <a:noFill/>
-                      <a:prstDash val="solid"/>
-                    </a:lnR>
-                    <a:lnT algn="ctr" cmpd="sng" cap="flat" w="19050">
-                      <a:solidFill>
-                        <a:srgbClr val="666666">
-                          <a:alpha val="100000"/>
-                        </a:srgbClr>
-                      </a:solidFill>
-                      <a:prstDash val="solid"/>
-                    </a:lnT>
-                    <a:lnB algn="ctr" cmpd="sng" cap="flat" w="19050">
-                      <a:solidFill>
-                        <a:srgbClr val="666666">
-                          <a:alpha val="100000"/>
-                        </a:srgbClr>
-                      </a:solidFill>
-                      <a:prstDash val="solid"/>
-                    </a:lnB>
-                    <a:solidFill>
-                      <a:srgbClr val="FFFFFF">
-                        <a:alpha val="0"/>
-                      </a:srgbClr>
-                    </a:solidFill>
-                  </a:tcPr>
-                </a:tc>
-              </a:tr>
-              <a:tr h="228600">
-                <a:tc>
-                  <a:txBody>
-                    <a:bodyPr/>
-                    <a:lstStyle/>
-                    <a:p>
-                      <a:pPr algn="l" marL="63500" marR="63500">
-                        <a:lnSpc>
-                          <a:spcPct val="100000"/>
-                        </a:lnSpc>
-                        <a:spcBef>
-                          <a:spcPts val="500"/>
-                        </a:spcBef>
-                        <a:spcAft>
-                          <a:spcPts val="500"/>
-                        </a:spcAft>
-                        <a:buNone/>
-                      </a:pPr>
-                      <a:r>
-                        <a:rPr cap="none" sz="1100" i="0" b="0" u="none">
-                          <a:solidFill>
-                            <a:srgbClr val="000000">
-                              <a:alpha val="100000"/>
-                            </a:srgbClr>
-                          </a:solidFill>
-                          <a:latin typeface="Helvetica"/>
-                          <a:cs typeface="Helvetica"/>
-                          <a:ea typeface="Helvetica"/>
-                          <a:sym typeface="Helvetica"/>
-                        </a:rPr>
-                        <a:t>I3</a:t>
-                      </a:r>
-                    </a:p>
-                  </a:txBody>
-                  <a:tcPr anchor="ctr" marB="63500" marT="63500" marR="0" marL="0">
-                    <a:lnL algn="ctr" cmpd="sng" cap="flat" w="0">
-                      <a:noFill/>
-                      <a:prstDash val="solid"/>
-                    </a:lnL>
-                    <a:lnR algn="ctr" cmpd="sng" cap="flat" w="0">
-                      <a:noFill/>
-                      <a:prstDash val="solid"/>
-                    </a:lnR>
-                    <a:lnT algn="ctr" cmpd="sng" cap="flat" w="0">
-                      <a:noFill/>
-                      <a:prstDash val="solid"/>
-                    </a:lnT>
-                    <a:lnB algn="ctr" cmpd="sng" cap="flat" w="0">
-                      <a:noFill/>
-                      <a:prstDash val="solid"/>
-                    </a:lnB>
-                    <a:solidFill>
-                      <a:srgbClr val="FFFFFF">
-                        <a:alpha val="0"/>
-                      </a:srgbClr>
-                    </a:solidFill>
-                  </a:tcPr>
-                </a:tc>
-                <a:tc>
-                  <a:txBody>
-                    <a:bodyPr/>
-                    <a:lstStyle/>
-                    <a:p>
-                      <a:pPr algn="r" marL="63500" marR="63500">
-                        <a:lnSpc>
-                          <a:spcPct val="100000"/>
-                        </a:lnSpc>
-                        <a:spcBef>
-                          <a:spcPts val="500"/>
-                        </a:spcBef>
-                        <a:spcAft>
-                          <a:spcPts val="500"/>
-                        </a:spcAft>
-                        <a:buNone/>
-                      </a:pPr>
-                      <a:r>
-                        <a:rPr cap="none" sz="1100" i="0" b="0" u="none">
-                          <a:solidFill>
-                            <a:srgbClr val="000000">
-                              <a:alpha val="100000"/>
-                            </a:srgbClr>
-                          </a:solidFill>
-                          <a:latin typeface="Helvetica"/>
-                          <a:cs typeface="Helvetica"/>
-                          <a:ea typeface="Helvetica"/>
-                          <a:sym typeface="Helvetica"/>
-                        </a:rPr>
-                        <a:t>265.6061</a:t>
-                      </a:r>
-                    </a:p>
-                  </a:txBody>
-                  <a:tcPr anchor="ctr" marB="63500" marT="63500" marR="0" marL="0">
-                    <a:lnL algn="ctr" cmpd="sng" cap="flat" w="0">
-                      <a:noFill/>
-                      <a:prstDash val="solid"/>
-                    </a:lnL>
-                    <a:lnR algn="ctr" cmpd="sng" cap="flat" w="0">
-                      <a:noFill/>
-                      <a:prstDash val="solid"/>
-                    </a:lnR>
-                    <a:lnT algn="ctr" cmpd="sng" cap="flat" w="0">
-                      <a:noFill/>
-                      <a:prstDash val="solid"/>
-                    </a:lnT>
-                    <a:lnB algn="ctr" cmpd="sng" cap="flat" w="0">
-                      <a:noFill/>
-                      <a:prstDash val="solid"/>
-                    </a:lnB>
-                    <a:solidFill>
-                      <a:srgbClr val="FFFFFF">
-                        <a:alpha val="0"/>
-                      </a:srgbClr>
-                    </a:solidFill>
-                  </a:tcPr>
-                </a:tc>
-                <a:tc>
-                  <a:txBody>
-                    <a:bodyPr/>
-                    <a:lstStyle/>
-                    <a:p>
-                      <a:pPr algn="r" marL="63500" marR="63500">
-                        <a:lnSpc>
-                          <a:spcPct val="100000"/>
-                        </a:lnSpc>
-                        <a:spcBef>
-                          <a:spcPts val="500"/>
-                        </a:spcBef>
-                        <a:spcAft>
-                          <a:spcPts val="500"/>
-                        </a:spcAft>
-                        <a:buNone/>
-                      </a:pPr>
-                      <a:r>
-                        <a:rPr cap="none" sz="1100" i="0" b="0" u="none">
-                          <a:solidFill>
-                            <a:srgbClr val="000000">
-                              <a:alpha val="100000"/>
-                            </a:srgbClr>
-                          </a:solidFill>
-                          <a:latin typeface="Helvetica"/>
-                          <a:cs typeface="Helvetica"/>
-                          <a:ea typeface="Helvetica"/>
-                          <a:sym typeface="Helvetica"/>
-                        </a:rPr>
-                        <a:t>266</a:t>
-                      </a:r>
-                    </a:p>
-                  </a:txBody>
-                  <a:tcPr anchor="ctr" marB="63500" marT="63500" marR="0" marL="0">
-                    <a:lnL algn="ctr" cmpd="sng" cap="flat" w="0">
-                      <a:noFill/>
-                      <a:prstDash val="solid"/>
-                    </a:lnL>
-                    <a:lnR algn="ctr" cmpd="sng" cap="flat" w="0">
-                      <a:noFill/>
-                      <a:prstDash val="solid"/>
-                    </a:lnR>
-                    <a:lnT algn="ctr" cmpd="sng" cap="flat" w="0">
-                      <a:noFill/>
-                      <a:prstDash val="solid"/>
-                    </a:lnT>
-                    <a:lnB algn="ctr" cmpd="sng" cap="flat" w="0">
-                      <a:noFill/>
-                      <a:prstDash val="solid"/>
-                    </a:lnB>
-                    <a:solidFill>
-                      <a:srgbClr val="FFFFFF">
-                        <a:alpha val="0"/>
-                      </a:srgbClr>
-                    </a:solidFill>
-                  </a:tcPr>
-                </a:tc>
-                <a:tc>
-                  <a:txBody>
-                    <a:bodyPr/>
-                    <a:lstStyle/>
-                    <a:p>
-                      <a:pPr algn="r" marL="63500" marR="63500">
-                        <a:lnSpc>
-                          <a:spcPct val="100000"/>
-                        </a:lnSpc>
-                        <a:spcBef>
-                          <a:spcPts val="500"/>
-                        </a:spcBef>
-                        <a:spcAft>
-                          <a:spcPts val="500"/>
-                        </a:spcAft>
-                        <a:buNone/>
-                      </a:pPr>
-                      <a:r>
-                        <a:rPr cap="none" sz="1100" i="0" b="0" u="none">
-                          <a:solidFill>
-                            <a:srgbClr val="000000">
-                              <a:alpha val="100000"/>
-                            </a:srgbClr>
-                          </a:solidFill>
-                          <a:latin typeface="Helvetica"/>
-                          <a:cs typeface="Helvetica"/>
-                          <a:ea typeface="Helvetica"/>
-                          <a:sym typeface="Helvetica"/>
-                        </a:rPr>
-                        <a:t>28.30378</a:t>
-                      </a:r>
-                    </a:p>
-                  </a:txBody>
-                  <a:tcPr anchor="ctr" marB="63500" marT="63500" marR="0" marL="0">
-                    <a:lnL algn="ctr" cmpd="sng" cap="flat" w="0">
-                      <a:noFill/>
-                      <a:prstDash val="solid"/>
-                    </a:lnL>
-                    <a:lnR algn="ctr" cmpd="sng" cap="flat" w="0">
-                      <a:noFill/>
-                      <a:prstDash val="solid"/>
-                    </a:lnR>
-                    <a:lnT algn="ctr" cmpd="sng" cap="flat" w="0">
-                      <a:noFill/>
-                      <a:prstDash val="solid"/>
-                    </a:lnT>
-                    <a:lnB algn="ctr" cmpd="sng" cap="flat" w="0">
-                      <a:noFill/>
-                      <a:prstDash val="solid"/>
-                    </a:lnB>
-                    <a:solidFill>
-                      <a:srgbClr val="FFFFFF">
-                        <a:alpha val="0"/>
-                      </a:srgbClr>
-                    </a:solidFill>
-                  </a:tcPr>
-                </a:tc>
-                <a:tc>
-                  <a:txBody>
-                    <a:bodyPr/>
-                    <a:lstStyle/>
-                    <a:p>
-                      <a:pPr algn="r" marL="63500" marR="63500">
-                        <a:lnSpc>
-                          <a:spcPct val="100000"/>
-                        </a:lnSpc>
-                        <a:spcBef>
-                          <a:spcPts val="500"/>
-                        </a:spcBef>
-                        <a:spcAft>
-                          <a:spcPts val="500"/>
-                        </a:spcAft>
-                        <a:buNone/>
-                      </a:pPr>
-                      <a:r>
-                        <a:rPr cap="none" sz="1100" i="0" b="0" u="none">
-                          <a:solidFill>
-                            <a:srgbClr val="000000">
-                              <a:alpha val="100000"/>
-                            </a:srgbClr>
-                          </a:solidFill>
-                          <a:latin typeface="Helvetica"/>
-                          <a:cs typeface="Helvetica"/>
-                          <a:ea typeface="Helvetica"/>
-                          <a:sym typeface="Helvetica"/>
-                        </a:rPr>
-                        <a:t>24</a:t>
-                      </a:r>
-                    </a:p>
-                  </a:txBody>
-                  <a:tcPr anchor="ctr" marB="63500" marT="63500" marR="0" marL="0">
-                    <a:lnL algn="ctr" cmpd="sng" cap="flat" w="0">
-                      <a:noFill/>
-                      <a:prstDash val="solid"/>
-                    </a:lnL>
-                    <a:lnR algn="ctr" cmpd="sng" cap="flat" w="0">
-                      <a:noFill/>
-                      <a:prstDash val="solid"/>
-                    </a:lnR>
-                    <a:lnT algn="ctr" cmpd="sng" cap="flat" w="0">
-                      <a:noFill/>
-                      <a:prstDash val="solid"/>
-                    </a:lnT>
-                    <a:lnB algn="ctr" cmpd="sng" cap="flat" w="0">
-                      <a:noFill/>
-                      <a:prstDash val="solid"/>
-                    </a:lnB>
-                    <a:solidFill>
-                      <a:srgbClr val="FFFFFF">
-                        <a:alpha val="0"/>
-                      </a:srgbClr>
-                    </a:solidFill>
-                  </a:tcPr>
-                </a:tc>
-                <a:tc>
-                  <a:txBody>
-                    <a:bodyPr/>
-                    <a:lstStyle/>
-                    <a:p>
-                      <a:pPr algn="r" marL="63500" marR="63500">
-                        <a:lnSpc>
-                          <a:spcPct val="100000"/>
-                        </a:lnSpc>
-                        <a:spcBef>
-                          <a:spcPts val="500"/>
-                        </a:spcBef>
-                        <a:spcAft>
-                          <a:spcPts val="500"/>
-                        </a:spcAft>
-                        <a:buNone/>
-                      </a:pPr>
-                      <a:r>
-                        <a:rPr cap="none" sz="1100" i="0" b="0" u="none">
-                          <a:solidFill>
-                            <a:srgbClr val="000000">
-                              <a:alpha val="100000"/>
-                            </a:srgbClr>
-                          </a:solidFill>
-                          <a:latin typeface="Helvetica"/>
-                          <a:cs typeface="Helvetica"/>
-                          <a:ea typeface="Helvetica"/>
-                          <a:sym typeface="Helvetica"/>
-                        </a:rPr>
-                        <a:t>-0.8826195</a:t>
-                      </a:r>
-                    </a:p>
-                  </a:txBody>
-                  <a:tcPr anchor="ctr" marB="63500" marT="63500" marR="0" marL="0">
-                    <a:lnL algn="ctr" cmpd="sng" cap="flat" w="0">
-                      <a:noFill/>
-                      <a:prstDash val="solid"/>
-                    </a:lnL>
-                    <a:lnR algn="ctr" cmpd="sng" cap="flat" w="0">
-                      <a:noFill/>
-                      <a:prstDash val="solid"/>
-                    </a:lnR>
-                    <a:lnT algn="ctr" cmpd="sng" cap="flat" w="0">
-                      <a:noFill/>
-                      <a:prstDash val="solid"/>
-                    </a:lnT>
-                    <a:lnB algn="ctr" cmpd="sng" cap="flat" w="0">
-                      <a:noFill/>
-                      <a:prstDash val="solid"/>
-                    </a:lnB>
-                    <a:solidFill>
-                      <a:srgbClr val="FFFFFF">
-                        <a:alpha val="0"/>
-                      </a:srgbClr>
-                    </a:solidFill>
-                  </a:tcPr>
-                </a:tc>
-              </a:tr>
-              <a:tr h="228600">
-                <a:tc>
-                  <a:txBody>
-                    <a:bodyPr/>
-                    <a:lstStyle/>
-                    <a:p>
-                      <a:pPr algn="l" marL="63500" marR="63500">
-                        <a:lnSpc>
-                          <a:spcPct val="100000"/>
-                        </a:lnSpc>
-                        <a:spcBef>
-                          <a:spcPts val="500"/>
-                        </a:spcBef>
-                        <a:spcAft>
-                          <a:spcPts val="500"/>
-                        </a:spcAft>
-                        <a:buNone/>
-                      </a:pPr>
-                      <a:r>
-                        <a:rPr cap="none" sz="1100" i="0" b="0" u="none">
-                          <a:solidFill>
-                            <a:srgbClr val="000000">
-                              <a:alpha val="100000"/>
-                            </a:srgbClr>
-                          </a:solidFill>
-                          <a:latin typeface="Helvetica"/>
-                          <a:cs typeface="Helvetica"/>
-                          <a:ea typeface="Helvetica"/>
-                          <a:sym typeface="Helvetica"/>
-                        </a:rPr>
-                        <a:t>I8</a:t>
-                      </a:r>
-                    </a:p>
-                  </a:txBody>
-                  <a:tcPr anchor="ctr" marB="63500" marT="63500" marR="0" marL="0">
-                    <a:lnL algn="ctr" cmpd="sng" cap="flat" w="0">
-                      <a:noFill/>
-                      <a:prstDash val="solid"/>
-                    </a:lnL>
-                    <a:lnR algn="ctr" cmpd="sng" cap="flat" w="0">
-                      <a:noFill/>
-                      <a:prstDash val="solid"/>
-                    </a:lnR>
-                    <a:lnT algn="ctr" cmpd="sng" cap="flat" w="0">
-                      <a:noFill/>
-                      <a:prstDash val="solid"/>
-                    </a:lnT>
-                    <a:lnB algn="ctr" cmpd="sng" cap="flat" w="19050">
-                      <a:solidFill>
-                        <a:srgbClr val="666666">
-                          <a:alpha val="100000"/>
-                        </a:srgbClr>
-                      </a:solidFill>
-                      <a:prstDash val="solid"/>
-                    </a:lnB>
-                    <a:solidFill>
-                      <a:srgbClr val="FFFFFF">
-                        <a:alpha val="0"/>
-                      </a:srgbClr>
-                    </a:solidFill>
-                  </a:tcPr>
-                </a:tc>
-                <a:tc>
-                  <a:txBody>
-                    <a:bodyPr/>
-                    <a:lstStyle/>
-                    <a:p>
-                      <a:pPr algn="r" marL="63500" marR="63500">
-                        <a:lnSpc>
-                          <a:spcPct val="100000"/>
-                        </a:lnSpc>
-                        <a:spcBef>
-                          <a:spcPts val="500"/>
-                        </a:spcBef>
-                        <a:spcAft>
-                          <a:spcPts val="500"/>
-                        </a:spcAft>
-                        <a:buNone/>
-                      </a:pPr>
-                      <a:r>
-                        <a:rPr cap="none" sz="1100" i="0" b="0" u="none">
-                          <a:solidFill>
-                            <a:srgbClr val="000000">
-                              <a:alpha val="100000"/>
-                            </a:srgbClr>
-                          </a:solidFill>
-                          <a:latin typeface="Helvetica"/>
-                          <a:cs typeface="Helvetica"/>
-                          <a:ea typeface="Helvetica"/>
-                          <a:sym typeface="Helvetica"/>
-                        </a:rPr>
-                        <a:t>362.5980</a:t>
-                      </a:r>
-                    </a:p>
-                  </a:txBody>
-                  <a:tcPr anchor="ctr" marB="63500" marT="63500" marR="0" marL="0">
-                    <a:lnL algn="ctr" cmpd="sng" cap="flat" w="0">
-                      <a:noFill/>
-                      <a:prstDash val="solid"/>
-                    </a:lnL>
-                    <a:lnR algn="ctr" cmpd="sng" cap="flat" w="0">
-                      <a:noFill/>
-                      <a:prstDash val="solid"/>
-                    </a:lnR>
-                    <a:lnT algn="ctr" cmpd="sng" cap="flat" w="0">
-                      <a:noFill/>
-                      <a:prstDash val="solid"/>
-                    </a:lnT>
-                    <a:lnB algn="ctr" cmpd="sng" cap="flat" w="19050">
-                      <a:solidFill>
-                        <a:srgbClr val="666666">
-                          <a:alpha val="100000"/>
-                        </a:srgbClr>
-                      </a:solidFill>
-                      <a:prstDash val="solid"/>
-                    </a:lnB>
-                    <a:solidFill>
-                      <a:srgbClr val="FFFFFF">
-                        <a:alpha val="0"/>
-                      </a:srgbClr>
-                    </a:solidFill>
-                  </a:tcPr>
-                </a:tc>
-                <a:tc>
-                  <a:txBody>
-                    <a:bodyPr/>
-                    <a:lstStyle/>
-                    <a:p>
-                      <a:pPr algn="r" marL="63500" marR="63500">
-                        <a:lnSpc>
-                          <a:spcPct val="100000"/>
-                        </a:lnSpc>
-                        <a:spcBef>
-                          <a:spcPts val="500"/>
-                        </a:spcBef>
-                        <a:spcAft>
-                          <a:spcPts val="500"/>
-                        </a:spcAft>
-                        <a:buNone/>
-                      </a:pPr>
-                      <a:r>
-                        <a:rPr cap="none" sz="1100" i="0" b="0" u="none">
-                          <a:solidFill>
-                            <a:srgbClr val="000000">
-                              <a:alpha val="100000"/>
-                            </a:srgbClr>
-                          </a:solidFill>
-                          <a:latin typeface="Helvetica"/>
-                          <a:cs typeface="Helvetica"/>
-                          <a:ea typeface="Helvetica"/>
-                          <a:sym typeface="Helvetica"/>
-                        </a:rPr>
-                        <a:t>373</a:t>
-                      </a:r>
-                    </a:p>
-                  </a:txBody>
-                  <a:tcPr anchor="ctr" marB="63500" marT="63500" marR="0" marL="0">
-                    <a:lnL algn="ctr" cmpd="sng" cap="flat" w="0">
-                      <a:noFill/>
-                      <a:prstDash val="solid"/>
-                    </a:lnL>
-                    <a:lnR algn="ctr" cmpd="sng" cap="flat" w="0">
-                      <a:noFill/>
-                      <a:prstDash val="solid"/>
-                    </a:lnR>
-                    <a:lnT algn="ctr" cmpd="sng" cap="flat" w="0">
-                      <a:noFill/>
-                      <a:prstDash val="solid"/>
-                    </a:lnT>
-                    <a:lnB algn="ctr" cmpd="sng" cap="flat" w="19050">
-                      <a:solidFill>
-                        <a:srgbClr val="666666">
-                          <a:alpha val="100000"/>
-                        </a:srgbClr>
-                      </a:solidFill>
-                      <a:prstDash val="solid"/>
-                    </a:lnB>
-                    <a:solidFill>
-                      <a:srgbClr val="FFFFFF">
-                        <a:alpha val="0"/>
-                      </a:srgbClr>
-                    </a:solidFill>
-                  </a:tcPr>
-                </a:tc>
-                <a:tc>
-                  <a:txBody>
-                    <a:bodyPr/>
-                    <a:lstStyle/>
-                    <a:p>
-                      <a:pPr algn="r" marL="63500" marR="63500">
-                        <a:lnSpc>
-                          <a:spcPct val="100000"/>
-                        </a:lnSpc>
-                        <a:spcBef>
-                          <a:spcPts val="500"/>
-                        </a:spcBef>
-                        <a:spcAft>
-                          <a:spcPts val="500"/>
-                        </a:spcAft>
-                        <a:buNone/>
-                      </a:pPr>
-                      <a:r>
-                        <a:rPr cap="none" sz="1100" i="0" b="0" u="none">
-                          <a:solidFill>
-                            <a:srgbClr val="000000">
-                              <a:alpha val="100000"/>
-                            </a:srgbClr>
-                          </a:solidFill>
-                          <a:latin typeface="Helvetica"/>
-                          <a:cs typeface="Helvetica"/>
-                          <a:ea typeface="Helvetica"/>
-                          <a:sym typeface="Helvetica"/>
-                        </a:rPr>
-                        <a:t>52.33901</a:t>
-                      </a:r>
-                    </a:p>
-                  </a:txBody>
-                  <a:tcPr anchor="ctr" marB="63500" marT="63500" marR="0" marL="0">
-                    <a:lnL algn="ctr" cmpd="sng" cap="flat" w="0">
-                      <a:noFill/>
-                      <a:prstDash val="solid"/>
-                    </a:lnL>
-                    <a:lnR algn="ctr" cmpd="sng" cap="flat" w="0">
-                      <a:noFill/>
-                      <a:prstDash val="solid"/>
-                    </a:lnR>
-                    <a:lnT algn="ctr" cmpd="sng" cap="flat" w="0">
-                      <a:noFill/>
-                      <a:prstDash val="solid"/>
-                    </a:lnT>
-                    <a:lnB algn="ctr" cmpd="sng" cap="flat" w="19050">
-                      <a:solidFill>
-                        <a:srgbClr val="666666">
-                          <a:alpha val="100000"/>
-                        </a:srgbClr>
-                      </a:solidFill>
-                      <a:prstDash val="solid"/>
-                    </a:lnB>
-                    <a:solidFill>
-                      <a:srgbClr val="FFFFFF">
-                        <a:alpha val="0"/>
-                      </a:srgbClr>
-                    </a:solidFill>
-                  </a:tcPr>
-                </a:tc>
-                <a:tc>
-                  <a:txBody>
-                    <a:bodyPr/>
-                    <a:lstStyle/>
-                    <a:p>
-                      <a:pPr algn="r" marL="63500" marR="63500">
-                        <a:lnSpc>
-                          <a:spcPct val="100000"/>
-                        </a:lnSpc>
-                        <a:spcBef>
-                          <a:spcPts val="500"/>
-                        </a:spcBef>
-                        <a:spcAft>
-                          <a:spcPts val="500"/>
-                        </a:spcAft>
-                        <a:buNone/>
-                      </a:pPr>
-                      <a:r>
-                        <a:rPr cap="none" sz="1100" i="0" b="0" u="none">
-                          <a:solidFill>
-                            <a:srgbClr val="000000">
-                              <a:alpha val="100000"/>
-                            </a:srgbClr>
-                          </a:solidFill>
-                          <a:latin typeface="Helvetica"/>
-                          <a:cs typeface="Helvetica"/>
-                          <a:ea typeface="Helvetica"/>
-                          <a:sym typeface="Helvetica"/>
-                        </a:rPr>
-                        <a:t>61</a:t>
-                      </a:r>
-                    </a:p>
-                  </a:txBody>
-                  <a:tcPr anchor="ctr" marB="63500" marT="63500" marR="0" marL="0">
-                    <a:lnL algn="ctr" cmpd="sng" cap="flat" w="0">
-                      <a:noFill/>
-                      <a:prstDash val="solid"/>
-                    </a:lnL>
-                    <a:lnR algn="ctr" cmpd="sng" cap="flat" w="0">
-                      <a:noFill/>
-                      <a:prstDash val="solid"/>
-                    </a:lnR>
-                    <a:lnT algn="ctr" cmpd="sng" cap="flat" w="0">
-                      <a:noFill/>
-                      <a:prstDash val="solid"/>
-                    </a:lnT>
-                    <a:lnB algn="ctr" cmpd="sng" cap="flat" w="19050">
-                      <a:solidFill>
-                        <a:srgbClr val="666666">
-                          <a:alpha val="100000"/>
-                        </a:srgbClr>
-                      </a:solidFill>
-                      <a:prstDash val="solid"/>
-                    </a:lnB>
-                    <a:solidFill>
-                      <a:srgbClr val="FFFFFF">
-                        <a:alpha val="0"/>
-                      </a:srgbClr>
-                    </a:solidFill>
-                  </a:tcPr>
-                </a:tc>
-                <a:tc>
-                  <a:txBody>
-                    <a:bodyPr/>
-                    <a:lstStyle/>
-                    <a:p>
-                      <a:pPr algn="r" marL="63500" marR="63500">
-                        <a:lnSpc>
-                          <a:spcPct val="100000"/>
-                        </a:lnSpc>
-                        <a:spcBef>
-                          <a:spcPts val="500"/>
-                        </a:spcBef>
-                        <a:spcAft>
-                          <a:spcPts val="500"/>
-                        </a:spcAft>
-                        <a:buNone/>
-                      </a:pPr>
-                      <a:r>
-                        <a:rPr cap="none" sz="1100" i="0" b="0" u="none">
-                          <a:solidFill>
-                            <a:srgbClr val="000000">
-                              <a:alpha val="100000"/>
-                            </a:srgbClr>
-                          </a:solidFill>
-                          <a:latin typeface="Helvetica"/>
-                          <a:cs typeface="Helvetica"/>
-                          <a:ea typeface="Helvetica"/>
-                          <a:sym typeface="Helvetica"/>
-                        </a:rPr>
-                        <a:t>-1.0909961</a:t>
-                      </a:r>
-                    </a:p>
-                  </a:txBody>
-                  <a:tcPr anchor="ctr" marB="63500" marT="63500" marR="0" marL="0">
-                    <a:lnL algn="ctr" cmpd="sng" cap="flat" w="0">
-                      <a:noFill/>
-                      <a:prstDash val="solid"/>
-                    </a:lnL>
-                    <a:lnR algn="ctr" cmpd="sng" cap="flat" w="0">
-                      <a:noFill/>
-                      <a:prstDash val="solid"/>
-                    </a:lnR>
-                    <a:lnT algn="ctr" cmpd="sng" cap="flat" w="0">
-                      <a:noFill/>
-                      <a:prstDash val="solid"/>
-                    </a:lnT>
-                    <a:lnB algn="ctr" cmpd="sng" cap="flat" w="19050">
-                      <a:solidFill>
-                        <a:srgbClr val="666666">
-                          <a:alpha val="100000"/>
-                        </a:srgbClr>
-                      </a:solidFill>
-                      <a:prstDash val="solid"/>
-                    </a:lnB>
-                    <a:solidFill>
-                      <a:srgbClr val="FFFFFF">
-                        <a:alpha val="0"/>
-                      </a:srgbClr>
-                    </a:solidFill>
-                  </a:tcPr>
-                </a:tc>
-              </a:tr>
-            </a:tbl>
-          </a:graphicData>
-        </a:graphic>
-      </p:graphicFrame>
+      <p:sp>
+        <p:nvSpPr>
+          <p:cNvPr id="4" name="Content Placeholder 3"/>
+          <p:cNvSpPr>
+            <a:spLocks noGrp="1"/>
+          </p:cNvSpPr>
+          <p:nvPr>
+            <p:ph idx="2" sz="half"/>
+          </p:nvPr>
+        </p:nvSpPr>
+        <p:spPr/>
+        <p:txBody>
+          <a:bodyPr/>
+          <a:lstStyle/>
+          <a:p>
+            <a:pPr lvl="0" indent="0">
+              <a:buNone/>
+            </a:pPr>
+            <a:r>
+              <a:rPr>
+                <a:latin typeface="Courier"/>
+              </a:rPr>
+              <a:t># A tibble: 2 × 6
+  lake   mean median    sd   iqr skewness
+  &lt;chr&gt; &lt;dbl&gt;  &lt;dbl&gt; &lt;dbl&gt; &lt;dbl&gt;    &lt;dbl&gt;
+1 I3     266.    266  28.3    24   -0.883
+2 I8     363.    373  52.3    61   -1.09 </a:t>
+            </a:r>
+          </a:p>
+        </p:txBody>
+      </p:sp>
     </p:spTree>
   </p:cSld>
 </p:sld>
@@ -13002,20 +10595,6 @@
             <a:pPr lvl="0"/>
             <a:r>
               <a:rPr/>
-              <a:t>Distinguish between different types of biological variables</a:t>
-            </a:r>
-          </a:p>
-          <a:p>
-            <a:pPr lvl="0"/>
-            <a:r>
-              <a:rPr/>
-              <a:t>Learn about accuracy, precision, and bias in measurements</a:t>
-            </a:r>
-          </a:p>
-          <a:p>
-            <a:pPr lvl="0"/>
-            <a:r>
-              <a:rPr/>
               <a:t>Calculate and interpret measures of central tendency (mean, median, geometric mean)</a:t>
             </a:r>
           </a:p>
@@ -13053,7 +10632,17 @@
             </a:pPr>
             <a:r>
               <a:rPr/>
-              <a:t>We’ll use a dataset on grayling fish from two different lakes to explore these concepts..</a:t>
+              <a:t>We’ll use a dataset on grayling - </a:t>
+            </a:r>
+            <a:r>
+              <a:rPr>
+                <a:latin typeface="Courier"/>
+              </a:rPr>
+              <a:t>gray_I3_I8.csv</a:t>
+            </a:r>
+            <a:r>
+              <a:rPr/>
+              <a:t>` from two different lakes to explore these concepts.. like you did in the homework</a:t>
             </a:r>
           </a:p>
         </p:txBody>
@@ -15765,7 +13354,34 @@
             </a:pPr>
             <a:r>
               <a:rPr/>
-              <a:t>Important properties: 1. It is centered at the population mean (μ) 2. Its standard deviation is the standard error (σ/√n) 3. For large sample sizes, it approaches a normal distribution (Central Limit Theorem)</a:t>
+              <a:t>Important properties:</a:t>
+            </a:r>
+          </a:p>
+          <a:p>
+            <a:pPr lvl="0" indent="-342900" marL="342900">
+              <a:buAutoNum type="arabicPeriod"/>
+            </a:pPr>
+            <a:r>
+              <a:rPr/>
+              <a:t>It is centered at the population mean (μ)</a:t>
+            </a:r>
+          </a:p>
+          <a:p>
+            <a:pPr lvl="0" indent="-342900" marL="342900">
+              <a:buAutoNum type="arabicPeriod"/>
+            </a:pPr>
+            <a:r>
+              <a:rPr/>
+              <a:t>Its standard deviation is the standard error (σ/√n)</a:t>
+            </a:r>
+          </a:p>
+          <a:p>
+            <a:pPr lvl="0" indent="-342900" marL="342900">
+              <a:buAutoNum type="arabicPeriod"/>
+            </a:pPr>
+            <a:r>
+              <a:rPr/>
+              <a:t>For large sample sizes, it approaches a normal distribution (Central Limit Theorem)</a:t>
             </a:r>
           </a:p>
           <a:p>
@@ -15774,7 +13390,28 @@
             </a:pPr>
             <a:r>
               <a:rPr/>
-              <a:t>The larger the sample size: - The narrower the sampling distribution - The smaller the standard error - The more precise our estimate of the population mean</a:t>
+              <a:t>The larger the sample size:</a:t>
+            </a:r>
+          </a:p>
+          <a:p>
+            <a:pPr lvl="0"/>
+            <a:r>
+              <a:rPr/>
+              <a:t>- The narrower the sampling distribution</a:t>
+            </a:r>
+          </a:p>
+          <a:p>
+            <a:pPr lvl="0"/>
+            <a:r>
+              <a:rPr/>
+              <a:t>- The smaller the standard error</a:t>
+            </a:r>
+          </a:p>
+          <a:p>
+            <a:pPr lvl="0"/>
+            <a:r>
+              <a:rPr/>
+              <a:t>- The more precise our estimate of the population mean</a:t>
             </a:r>
           </a:p>
         </p:txBody>
@@ -16712,7 +14349,7 @@
                 </a:solidFill>
                 <a:latin typeface="Courier"/>
               </a:rPr>
-              <a:t>size =</a:t>
+              <a:t>linewidth =</a:t>
             </a:r>
             <a:r>
               <a:rPr>
@@ -17396,7 +15033,7 @@
             </a:pPr>
             <a:r>
               <a:rPr/>
-              <a:t>Biology is fundamentally different from fields like physics in that:</a:t>
+              <a:t>Biology is fundamentally different from fields like physics/chemistry in that:</a:t>
             </a:r>
           </a:p>
           <a:p>
@@ -17519,8 +15156,8 @@
         </p:blipFill>
         <p:spPr bwMode="auto">
           <a:xfrm>
-            <a:off x="6121400" y="1498600"/>
-            <a:ext cx="2781300" cy="2781300"/>
+            <a:off x="6121400" y="2044700"/>
+            <a:ext cx="2781300" cy="1714500"/>
           </a:xfrm>
           <a:prstGeom prst="rect">
             <a:avLst/>
@@ -22325,8 +19962,8 @@
               <a:buNone/>
             </a:pPr>
             <a:r>
-              <a:rPr b="1"/>
-              <a:t>For Further Practice</a:t>
+              <a:rPr/>
+              <a:t>Lecture 3: Conclusion</a:t>
             </a:r>
           </a:p>
         </p:txBody>
@@ -22346,31 +19983,77 @@
           <a:bodyPr/>
           <a:lstStyle/>
           <a:p>
+            <a:pPr lvl="0" indent="0" marL="0">
+              <a:buNone/>
+            </a:pPr>
+            <a:r>
+              <a:rPr/>
+              <a:t>In this lecture, we’ve explored:</a:t>
+            </a:r>
+          </a:p>
+          <a:p>
             <a:pPr lvl="0"/>
             <a:r>
               <a:rPr/>
-              <a:t>Try calculating the standard error and confidence intervals for other variables in the dataset</a:t>
+              <a:t>Why statistics is essential in biology</a:t>
             </a:r>
           </a:p>
           <a:p>
             <a:pPr lvl="0"/>
             <a:r>
               <a:rPr/>
-              <a:t>Experiment with different sample sizes to see how they affect the precision of estimates</a:t>
+              <a:t>Types of biological variables and their properties</a:t>
             </a:r>
           </a:p>
           <a:p>
             <a:pPr lvl="0"/>
             <a:r>
               <a:rPr/>
-              <a:t>Compare the means of the two lakes using confidence intervals - do they overlap?</a:t>
+              <a:t>Accuracy, precision, and bias in measurements</a:t>
             </a:r>
           </a:p>
           <a:p>
             <a:pPr lvl="0"/>
             <a:r>
               <a:rPr/>
-              <a:t>Consider how these concepts extend to other statistics beyond the mean</a:t>
+              <a:t>Measures of central tendency (mean, median, geometric mean)</a:t>
+            </a:r>
+          </a:p>
+          <a:p>
+            <a:pPr lvl="0"/>
+            <a:r>
+              <a:rPr/>
+              <a:t>Measures of spread (standard deviation, variance, and interquartile range)</a:t>
+            </a:r>
+          </a:p>
+          <a:p>
+            <a:pPr lvl="0"/>
+            <a:r>
+              <a:rPr/>
+              <a:t>Data transformations for skewed distributions</a:t>
+            </a:r>
+          </a:p>
+          <a:p>
+            <a:pPr lvl="0"/>
+            <a:r>
+              <a:rPr/>
+              <a:t>Visualization techniques for understanding distributions</a:t>
+            </a:r>
+          </a:p>
+          <a:p>
+            <a:pPr lvl="0"/>
+            <a:r>
+              <a:rPr/>
+              <a:t>Handling missing values</a:t>
+            </a:r>
+          </a:p>
+          <a:p>
+            <a:pPr lvl="0" indent="0" marL="0">
+              <a:buNone/>
+            </a:pPr>
+            <a:r>
+              <a:rPr/>
+              <a:t>These tools form the foundation of statistical analysis and will be essential as we move forward to more complex statistical methods.</a:t>
             </a:r>
           </a:p>
         </p:txBody>
@@ -22422,7 +20105,7 @@
             </a:pPr>
             <a:r>
               <a:rPr/>
-              <a:t>Practice Exercise 1: Pine Data Analysis</a:t>
+              <a:t>Practice Exercise 1: Fish Data</a:t>
             </a:r>
           </a:p>
         </p:txBody>
@@ -22447,7 +20130,17 @@
             </a:pPr>
             <a:r>
               <a:rPr sz="2000" b="1"/>
-              <a:t>Practice Exercise 1: Can you do this for the pine data we have collected?</a:t>
+              <a:t>Practice Exercise 1: Can you open the fish data </a:t>
+            </a:r>
+            <a:r>
+              <a:rPr sz="2000" b="1">
+                <a:latin typeface="Courier"/>
+              </a:rPr>
+              <a:t>gray_I3_I8.csv</a:t>
+            </a:r>
+            <a:r>
+              <a:rPr sz="2000" b="1"/>
+              <a:t> and look at the structure and make a histogram?- see activity</a:t>
             </a:r>
           </a:p>
           <a:p>
@@ -22456,17 +20149,13 @@
             </a:pPr>
             <a:r>
               <a:rPr sz="2000"/>
-              <a:t>Let’s recreate the basic histogram of fish lengths from our last class. Use the </a:t>
+              <a:t>Let’s recreate the basic histogram of fish lengths using </a:t>
             </a:r>
             <a:r>
               <a:rPr sz="2000">
                 <a:latin typeface="Courier"/>
               </a:rPr>
-              <a:t>sculpin_df</a:t>
-            </a:r>
-            <a:r>
-              <a:rPr sz="2000"/>
-              <a:t> data frame that’s already loaded.</a:t>
+              <a:t>gray_I3_I8.csv</a:t>
             </a:r>
           </a:p>
           <a:p>
@@ -22491,148 +20180,6 @@
                 <a:latin typeface="Courier"/>
               </a:rPr>
               <a:t># How do you examine the data - what are the ways you think and lets try it!</a:t>
-            </a:r>
-          </a:p>
-        </p:txBody>
-      </p:sp>
-    </p:spTree>
-  </p:cSld>
-</p:sld>
-</file>
-
-<file path=ppt/slides/slide50.xml><?xml version="1.0" encoding="utf-8"?>
-<p:sld xmlns:a="http://schemas.openxmlformats.org/drawingml/2006/main" xmlns:r="http://schemas.openxmlformats.org/officeDocument/2006/relationships" xmlns:p="http://schemas.openxmlformats.org/presentationml/2006/main">
-  <p:cSld>
-    <p:spTree>
-      <p:nvGrpSpPr>
-        <p:cNvPr id="1" name=""/>
-        <p:cNvGrpSpPr/>
-        <p:nvPr/>
-      </p:nvGrpSpPr>
-      <p:grpSpPr>
-        <a:xfrm>
-          <a:off x="0" y="0"/>
-          <a:ext cx="0" cy="0"/>
-          <a:chOff x="0" y="0"/>
-          <a:chExt cx="0" cy="0"/>
-        </a:xfrm>
-      </p:grpSpPr>
-      <p:sp>
-        <p:nvSpPr>
-          <p:cNvPr id="2" name="Title 1"/>
-          <p:cNvSpPr>
-            <a:spLocks noGrp="1"/>
-          </p:cNvSpPr>
-          <p:nvPr>
-            <p:ph type="title"/>
-          </p:nvPr>
-        </p:nvSpPr>
-        <p:spPr>
-          <a:xfrm>
-            <a:off x="0" y="0"/>
-            <a:ext cx="9144000" cy="582780"/>
-          </a:xfrm>
-        </p:spPr>
-        <p:txBody>
-          <a:bodyPr/>
-          <a:lstStyle/>
-          <a:p>
-            <a:pPr lvl="0" indent="0" marL="0">
-              <a:buNone/>
-            </a:pPr>
-            <a:r>
-              <a:rPr/>
-              <a:t>Lecture 3: Conclusion</a:t>
-            </a:r>
-          </a:p>
-        </p:txBody>
-      </p:sp>
-      <p:sp>
-        <p:nvSpPr>
-          <p:cNvPr id="3" name="Content Placeholder 2"/>
-          <p:cNvSpPr>
-            <a:spLocks noGrp="1"/>
-          </p:cNvSpPr>
-          <p:nvPr>
-            <p:ph idx="1"/>
-          </p:nvPr>
-        </p:nvSpPr>
-        <p:spPr/>
-        <p:txBody>
-          <a:bodyPr/>
-          <a:lstStyle/>
-          <a:p>
-            <a:pPr lvl="0" indent="0" marL="0">
-              <a:buNone/>
-            </a:pPr>
-            <a:r>
-              <a:rPr/>
-              <a:t>In this lecture, we’ve explored:</a:t>
-            </a:r>
-          </a:p>
-          <a:p>
-            <a:pPr lvl="0"/>
-            <a:r>
-              <a:rPr/>
-              <a:t>Why statistics is essential in biology</a:t>
-            </a:r>
-          </a:p>
-          <a:p>
-            <a:pPr lvl="0"/>
-            <a:r>
-              <a:rPr/>
-              <a:t>Types of biological variables and their properties</a:t>
-            </a:r>
-          </a:p>
-          <a:p>
-            <a:pPr lvl="0"/>
-            <a:r>
-              <a:rPr/>
-              <a:t>Accuracy, precision, and bias in measurements</a:t>
-            </a:r>
-          </a:p>
-          <a:p>
-            <a:pPr lvl="0"/>
-            <a:r>
-              <a:rPr/>
-              <a:t>Measures of central tendency (mean, median, geometric mean)</a:t>
-            </a:r>
-          </a:p>
-          <a:p>
-            <a:pPr lvl="0"/>
-            <a:r>
-              <a:rPr/>
-              <a:t>Measures of spread (standard deviation, variance, and interquartile range)</a:t>
-            </a:r>
-          </a:p>
-          <a:p>
-            <a:pPr lvl="0"/>
-            <a:r>
-              <a:rPr/>
-              <a:t>Data transformations for skewed distributions</a:t>
-            </a:r>
-          </a:p>
-          <a:p>
-            <a:pPr lvl="0"/>
-            <a:r>
-              <a:rPr/>
-              <a:t>Visualization techniques for understanding distributions</a:t>
-            </a:r>
-          </a:p>
-          <a:p>
-            <a:pPr lvl="0"/>
-            <a:r>
-              <a:rPr/>
-              <a:t>Handling missing values</a:t>
-            </a:r>
-          </a:p>
-          <a:p>
-            <a:pPr lvl="0" indent="0" marL="0">
-              <a:buNone/>
-            </a:pPr>
-            <a:r>
-              <a:rPr/>
-              <a:t>These tools form the foundation of statistical analysis and will be essential as we move forward to more complex statistical methods.</a:t>
             </a:r>
           </a:p>
         </p:txBody>
@@ -23304,7 +20851,7 @@
             </a:pPr>
             <a:r>
               <a:rPr/>
-              <a:t>Let’s explore our grayling fish dataset and identify the types of variables it contains.</a:t>
+              <a:t>Let’s explore our grayling dataset and identify the types of variables it contains.</a:t>
             </a:r>
           </a:p>
         </p:txBody>

</xml_diff>

<commit_message>
fixing lecture 3 and html download
</commit_message>
<xml_diff>
--- a/docs/ecostats_lectures/lecture_03/03_01_lecture_powerpoint.pptx
+++ b/docs/ecostats_lectures/lecture_03/03_01_lecture_powerpoint.pptx
@@ -3710,8 +3710,45 @@
               <a:buNone/>
             </a:pPr>
             <a:r>
-              <a:rPr/>
-              <a:t>Accuracy is a function of both precision and bias. For statisticians, bias is usually a more serious problem than low precision because:</a:t>
+              <a:rPr b="1"/>
+              <a:t>Accuracy</a:t>
+            </a:r>
+            <a:r>
+              <a:rPr/>
+              <a:t> is a </a:t>
+            </a:r>
+            <a:r>
+              <a:rPr b="1"/>
+              <a:t>function</a:t>
+            </a:r>
+            <a:r>
+              <a:rPr/>
+              <a:t> of </a:t>
+            </a:r>
+            <a:r>
+              <a:rPr b="1"/>
+              <a:t>both precision and bias</a:t>
+            </a:r>
+            <a:r>
+              <a:rPr/>
+              <a:t>.</a:t>
+            </a:r>
+          </a:p>
+          <a:p>
+            <a:pPr lvl="0" indent="0" marL="0">
+              <a:buNone/>
+            </a:pPr>
+            <a:r>
+              <a:rPr/>
+              <a:t>For statisticians, </a:t>
+            </a:r>
+            <a:r>
+              <a:rPr b="1"/>
+              <a:t>BIAS is usually a more serious problem than low precision because</a:t>
+            </a:r>
+            <a:r>
+              <a:rPr/>
+              <a:t>:</a:t>
             </a:r>
           </a:p>
           <a:p>
@@ -3832,7 +3869,7 @@
             </a:pPr>
             <a:r>
               <a:rPr sz="2000" b="1"/>
-              <a:t>Practice Exercise 1: What are potential sources of error in pine needles or fish?</a:t>
+              <a:t>Practice Exercise 1: What are potential sources of error in fish data?</a:t>
             </a:r>
           </a:p>
           <a:p>
@@ -4142,9 +4179,221 @@
             </a:pPr>
             <a:r>
               <a:rPr>
-                <a:latin typeface="Courier"/>
-              </a:rPr>
-              <a:t>Mean length of all fish: 324.5 mm</a:t>
+                <a:solidFill>
+                  <a:srgbClr val="5E5E5E"/>
+                </a:solidFill>
+                <a:latin typeface="Courier"/>
+              </a:rPr>
+              <a:t># Calculate mean length of all fish</a:t>
+            </a:r>
+            <a:br/>
+            <a:r>
+              <a:rPr>
+                <a:solidFill>
+                  <a:srgbClr val="4758AB"/>
+                </a:solidFill>
+                <a:latin typeface="Courier"/>
+              </a:rPr>
+              <a:t>mean</a:t>
+            </a:r>
+            <a:r>
+              <a:rPr>
+                <a:solidFill>
+                  <a:srgbClr val="003B4F"/>
+                </a:solidFill>
+                <a:latin typeface="Courier"/>
+              </a:rPr>
+              <a:t>(grayling_df</a:t>
+            </a:r>
+            <a:r>
+              <a:rPr>
+                <a:solidFill>
+                  <a:srgbClr val="5E5E5E"/>
+                </a:solidFill>
+                <a:latin typeface="Courier"/>
+              </a:rPr>
+              <a:t>$</a:t>
+            </a:r>
+            <a:r>
+              <a:rPr>
+                <a:solidFill>
+                  <a:srgbClr val="003B4F"/>
+                </a:solidFill>
+                <a:latin typeface="Courier"/>
+              </a:rPr>
+              <a:t>length_mm)</a:t>
+            </a:r>
+          </a:p>
+          <a:p>
+            <a:pPr lvl="0" indent="0">
+              <a:buNone/>
+            </a:pPr>
+            <a:r>
+              <a:rPr>
+                <a:latin typeface="Courier"/>
+              </a:rPr>
+              <a:t>[1] 324.494</a:t>
+            </a:r>
+          </a:p>
+          <a:p>
+            <a:pPr lvl="0" indent="0">
+              <a:buNone/>
+            </a:pPr>
+            <a:r>
+              <a:rPr>
+                <a:solidFill>
+                  <a:srgbClr val="5E5E5E"/>
+                </a:solidFill>
+                <a:latin typeface="Courier"/>
+              </a:rPr>
+              <a:t># Calculate mean by lake</a:t>
+            </a:r>
+            <a:br/>
+            <a:r>
+              <a:rPr>
+                <a:solidFill>
+                  <a:srgbClr val="003B4F"/>
+                </a:solidFill>
+                <a:latin typeface="Courier"/>
+              </a:rPr>
+              <a:t>grayling_df </a:t>
+            </a:r>
+            <a:r>
+              <a:rPr>
+                <a:solidFill>
+                  <a:srgbClr val="5E5E5E"/>
+                </a:solidFill>
+                <a:latin typeface="Courier"/>
+              </a:rPr>
+              <a:t>%&gt;%</a:t>
+            </a:r>
+            <a:br/>
+            <a:r>
+              <a:rPr>
+                <a:solidFill>
+                  <a:srgbClr val="003B4F"/>
+                </a:solidFill>
+                <a:latin typeface="Courier"/>
+              </a:rPr>
+              <a:t>  </a:t>
+            </a:r>
+            <a:r>
+              <a:rPr>
+                <a:solidFill>
+                  <a:srgbClr val="4758AB"/>
+                </a:solidFill>
+                <a:latin typeface="Courier"/>
+              </a:rPr>
+              <a:t>group_by</a:t>
+            </a:r>
+            <a:r>
+              <a:rPr>
+                <a:solidFill>
+                  <a:srgbClr val="003B4F"/>
+                </a:solidFill>
+                <a:latin typeface="Courier"/>
+              </a:rPr>
+              <a:t>(lake) </a:t>
+            </a:r>
+            <a:r>
+              <a:rPr>
+                <a:solidFill>
+                  <a:srgbClr val="5E5E5E"/>
+                </a:solidFill>
+                <a:latin typeface="Courier"/>
+              </a:rPr>
+              <a:t>%&gt;%</a:t>
+            </a:r>
+            <a:br/>
+            <a:r>
+              <a:rPr>
+                <a:solidFill>
+                  <a:srgbClr val="003B4F"/>
+                </a:solidFill>
+                <a:latin typeface="Courier"/>
+              </a:rPr>
+              <a:t>  </a:t>
+            </a:r>
+            <a:r>
+              <a:rPr>
+                <a:solidFill>
+                  <a:srgbClr val="4758AB"/>
+                </a:solidFill>
+                <a:latin typeface="Courier"/>
+              </a:rPr>
+              <a:t>summarise</a:t>
+            </a:r>
+            <a:r>
+              <a:rPr>
+                <a:solidFill>
+                  <a:srgbClr val="003B4F"/>
+                </a:solidFill>
+                <a:latin typeface="Courier"/>
+              </a:rPr>
+              <a:t>(</a:t>
+            </a:r>
+            <a:r>
+              <a:rPr>
+                <a:solidFill>
+                  <a:srgbClr val="657422"/>
+                </a:solidFill>
+                <a:latin typeface="Courier"/>
+              </a:rPr>
+              <a:t>mean_length =</a:t>
+            </a:r>
+            <a:r>
+              <a:rPr>
+                <a:solidFill>
+                  <a:srgbClr val="003B4F"/>
+                </a:solidFill>
+                <a:latin typeface="Courier"/>
+              </a:rPr>
+              <a:t> </a:t>
+            </a:r>
+            <a:r>
+              <a:rPr>
+                <a:solidFill>
+                  <a:srgbClr val="4758AB"/>
+                </a:solidFill>
+                <a:latin typeface="Courier"/>
+              </a:rPr>
+              <a:t>mean</a:t>
+            </a:r>
+            <a:r>
+              <a:rPr>
+                <a:solidFill>
+                  <a:srgbClr val="003B4F"/>
+                </a:solidFill>
+                <a:latin typeface="Courier"/>
+              </a:rPr>
+              <a:t>(length_mm, </a:t>
+            </a:r>
+            <a:r>
+              <a:rPr>
+                <a:solidFill>
+                  <a:srgbClr val="657422"/>
+                </a:solidFill>
+                <a:latin typeface="Courier"/>
+              </a:rPr>
+              <a:t>na.rm=</a:t>
+            </a:r>
+            <a:r>
+              <a:rPr>
+                <a:solidFill>
+                  <a:srgbClr val="8F5902"/>
+                </a:solidFill>
+                <a:latin typeface="Courier"/>
+              </a:rPr>
+              <a:t>TRUE</a:t>
+            </a:r>
+            <a:r>
+              <a:rPr>
+                <a:solidFill>
+                  <a:srgbClr val="003B4F"/>
+                </a:solidFill>
+                <a:latin typeface="Courier"/>
+              </a:rPr>
+              <a:t>)) </a:t>
             </a:r>
           </a:p>
           <a:p>
@@ -4259,9 +4508,194 @@
             </a:pPr>
             <a:r>
               <a:rPr>
-                <a:latin typeface="Courier"/>
-              </a:rPr>
-              <a:t>Median length of all fish: 324.5 mm</a:t>
+                <a:solidFill>
+                  <a:srgbClr val="5E5E5E"/>
+                </a:solidFill>
+                <a:latin typeface="Courier"/>
+              </a:rPr>
+              <a:t># Calculate median length of all fish</a:t>
+            </a:r>
+            <a:br/>
+            <a:r>
+              <a:rPr>
+                <a:solidFill>
+                  <a:srgbClr val="4758AB"/>
+                </a:solidFill>
+                <a:latin typeface="Courier"/>
+              </a:rPr>
+              <a:t>median</a:t>
+            </a:r>
+            <a:r>
+              <a:rPr>
+                <a:solidFill>
+                  <a:srgbClr val="003B4F"/>
+                </a:solidFill>
+                <a:latin typeface="Courier"/>
+              </a:rPr>
+              <a:t>(grayling_df</a:t>
+            </a:r>
+            <a:r>
+              <a:rPr>
+                <a:solidFill>
+                  <a:srgbClr val="5E5E5E"/>
+                </a:solidFill>
+                <a:latin typeface="Courier"/>
+              </a:rPr>
+              <a:t>$</a:t>
+            </a:r>
+            <a:r>
+              <a:rPr>
+                <a:solidFill>
+                  <a:srgbClr val="003B4F"/>
+                </a:solidFill>
+                <a:latin typeface="Courier"/>
+              </a:rPr>
+              <a:t>length_mm)</a:t>
+            </a:r>
+          </a:p>
+          <a:p>
+            <a:pPr lvl="0" indent="0">
+              <a:buNone/>
+            </a:pPr>
+            <a:r>
+              <a:rPr>
+                <a:latin typeface="Courier"/>
+              </a:rPr>
+              <a:t>[1] 324.5</a:t>
+            </a:r>
+          </a:p>
+          <a:p>
+            <a:pPr lvl="0" indent="0">
+              <a:buNone/>
+            </a:pPr>
+            <a:r>
+              <a:rPr>
+                <a:solidFill>
+                  <a:srgbClr val="5E5E5E"/>
+                </a:solidFill>
+                <a:latin typeface="Courier"/>
+              </a:rPr>
+              <a:t># Calculate median by lake</a:t>
+            </a:r>
+            <a:br/>
+            <a:r>
+              <a:rPr>
+                <a:solidFill>
+                  <a:srgbClr val="003B4F"/>
+                </a:solidFill>
+                <a:latin typeface="Courier"/>
+              </a:rPr>
+              <a:t>grayling_df </a:t>
+            </a:r>
+            <a:r>
+              <a:rPr>
+                <a:solidFill>
+                  <a:srgbClr val="5E5E5E"/>
+                </a:solidFill>
+                <a:latin typeface="Courier"/>
+              </a:rPr>
+              <a:t>%&gt;%</a:t>
+            </a:r>
+            <a:br/>
+            <a:r>
+              <a:rPr>
+                <a:solidFill>
+                  <a:srgbClr val="003B4F"/>
+                </a:solidFill>
+                <a:latin typeface="Courier"/>
+              </a:rPr>
+              <a:t>  </a:t>
+            </a:r>
+            <a:r>
+              <a:rPr>
+                <a:solidFill>
+                  <a:srgbClr val="4758AB"/>
+                </a:solidFill>
+                <a:latin typeface="Courier"/>
+              </a:rPr>
+              <a:t>group_by</a:t>
+            </a:r>
+            <a:r>
+              <a:rPr>
+                <a:solidFill>
+                  <a:srgbClr val="003B4F"/>
+                </a:solidFill>
+                <a:latin typeface="Courier"/>
+              </a:rPr>
+              <a:t>(lake) </a:t>
+            </a:r>
+            <a:r>
+              <a:rPr>
+                <a:solidFill>
+                  <a:srgbClr val="5E5E5E"/>
+                </a:solidFill>
+                <a:latin typeface="Courier"/>
+              </a:rPr>
+              <a:t>%&gt;%</a:t>
+            </a:r>
+            <a:br/>
+            <a:r>
+              <a:rPr>
+                <a:solidFill>
+                  <a:srgbClr val="003B4F"/>
+                </a:solidFill>
+                <a:latin typeface="Courier"/>
+              </a:rPr>
+              <a:t>  </a:t>
+            </a:r>
+            <a:r>
+              <a:rPr>
+                <a:solidFill>
+                  <a:srgbClr val="4758AB"/>
+                </a:solidFill>
+                <a:latin typeface="Courier"/>
+              </a:rPr>
+              <a:t>summarise</a:t>
+            </a:r>
+            <a:r>
+              <a:rPr>
+                <a:solidFill>
+                  <a:srgbClr val="003B4F"/>
+                </a:solidFill>
+                <a:latin typeface="Courier"/>
+              </a:rPr>
+              <a:t>(</a:t>
+            </a:r>
+            <a:r>
+              <a:rPr>
+                <a:solidFill>
+                  <a:srgbClr val="657422"/>
+                </a:solidFill>
+                <a:latin typeface="Courier"/>
+              </a:rPr>
+              <a:t>median_length =</a:t>
+            </a:r>
+            <a:r>
+              <a:rPr>
+                <a:solidFill>
+                  <a:srgbClr val="003B4F"/>
+                </a:solidFill>
+                <a:latin typeface="Courier"/>
+              </a:rPr>
+              <a:t> </a:t>
+            </a:r>
+            <a:r>
+              <a:rPr>
+                <a:solidFill>
+                  <a:srgbClr val="4758AB"/>
+                </a:solidFill>
+                <a:latin typeface="Courier"/>
+              </a:rPr>
+              <a:t>median</a:t>
+            </a:r>
+            <a:r>
+              <a:rPr>
+                <a:solidFill>
+                  <a:srgbClr val="003B4F"/>
+                </a:solidFill>
+                <a:latin typeface="Courier"/>
+              </a:rPr>
+              <a:t>(length_mm)) </a:t>
             </a:r>
           </a:p>
           <a:p>
@@ -4685,10 +5119,291 @@
             </a:pPr>
             <a:r>
               <a:rPr>
-                <a:latin typeface="Courier"/>
-              </a:rPr>
-              <a:t>Variance of length: 4225.9 mm²
- Standard deviation of length: 65 mm</a:t>
+                <a:solidFill>
+                  <a:srgbClr val="5E5E5E"/>
+                </a:solidFill>
+                <a:latin typeface="Courier"/>
+              </a:rPr>
+              <a:t># Calculate standard deviation of fish length</a:t>
+            </a:r>
+            <a:br/>
+            <a:r>
+              <a:rPr>
+                <a:solidFill>
+                  <a:srgbClr val="003B4F"/>
+                </a:solidFill>
+                <a:latin typeface="Courier"/>
+              </a:rPr>
+              <a:t>var_length &lt;- </a:t>
+            </a:r>
+            <a:r>
+              <a:rPr>
+                <a:solidFill>
+                  <a:srgbClr val="4758AB"/>
+                </a:solidFill>
+                <a:latin typeface="Courier"/>
+              </a:rPr>
+              <a:t>var</a:t>
+            </a:r>
+            <a:r>
+              <a:rPr>
+                <a:solidFill>
+                  <a:srgbClr val="003B4F"/>
+                </a:solidFill>
+                <a:latin typeface="Courier"/>
+              </a:rPr>
+              <a:t>(grayling_df</a:t>
+            </a:r>
+            <a:r>
+              <a:rPr>
+                <a:solidFill>
+                  <a:srgbClr val="5E5E5E"/>
+                </a:solidFill>
+                <a:latin typeface="Courier"/>
+              </a:rPr>
+              <a:t>$</a:t>
+            </a:r>
+            <a:r>
+              <a:rPr>
+                <a:solidFill>
+                  <a:srgbClr val="003B4F"/>
+                </a:solidFill>
+                <a:latin typeface="Courier"/>
+              </a:rPr>
+              <a:t>length_mm)</a:t>
+            </a:r>
+            <a:br/>
+            <a:r>
+              <a:rPr>
+                <a:solidFill>
+                  <a:srgbClr val="003B4F"/>
+                </a:solidFill>
+                <a:latin typeface="Courier"/>
+              </a:rPr>
+              <a:t>sd_length &lt;- </a:t>
+            </a:r>
+            <a:r>
+              <a:rPr>
+                <a:solidFill>
+                  <a:srgbClr val="4758AB"/>
+                </a:solidFill>
+                <a:latin typeface="Courier"/>
+              </a:rPr>
+              <a:t>sd</a:t>
+            </a:r>
+            <a:r>
+              <a:rPr>
+                <a:solidFill>
+                  <a:srgbClr val="003B4F"/>
+                </a:solidFill>
+                <a:latin typeface="Courier"/>
+              </a:rPr>
+              <a:t>(grayling_df</a:t>
+            </a:r>
+            <a:r>
+              <a:rPr>
+                <a:solidFill>
+                  <a:srgbClr val="5E5E5E"/>
+                </a:solidFill>
+                <a:latin typeface="Courier"/>
+              </a:rPr>
+              <a:t>$</a:t>
+            </a:r>
+            <a:r>
+              <a:rPr>
+                <a:solidFill>
+                  <a:srgbClr val="003B4F"/>
+                </a:solidFill>
+                <a:latin typeface="Courier"/>
+              </a:rPr>
+              <a:t>length_mm)</a:t>
+            </a:r>
+            <a:br/>
+            <a:br/>
+            <a:r>
+              <a:rPr>
+                <a:solidFill>
+                  <a:srgbClr val="5E5E5E"/>
+                </a:solidFill>
+                <a:latin typeface="Courier"/>
+              </a:rPr>
+              <a:t># Calculate by lake</a:t>
+            </a:r>
+            <a:br/>
+            <a:r>
+              <a:rPr>
+                <a:solidFill>
+                  <a:srgbClr val="003B4F"/>
+                </a:solidFill>
+                <a:latin typeface="Courier"/>
+              </a:rPr>
+              <a:t>grayling_df </a:t>
+            </a:r>
+            <a:r>
+              <a:rPr>
+                <a:solidFill>
+                  <a:srgbClr val="5E5E5E"/>
+                </a:solidFill>
+                <a:latin typeface="Courier"/>
+              </a:rPr>
+              <a:t>%&gt;%</a:t>
+            </a:r>
+            <a:br/>
+            <a:r>
+              <a:rPr>
+                <a:solidFill>
+                  <a:srgbClr val="003B4F"/>
+                </a:solidFill>
+                <a:latin typeface="Courier"/>
+              </a:rPr>
+              <a:t>  </a:t>
+            </a:r>
+            <a:r>
+              <a:rPr>
+                <a:solidFill>
+                  <a:srgbClr val="4758AB"/>
+                </a:solidFill>
+                <a:latin typeface="Courier"/>
+              </a:rPr>
+              <a:t>group_by</a:t>
+            </a:r>
+            <a:r>
+              <a:rPr>
+                <a:solidFill>
+                  <a:srgbClr val="003B4F"/>
+                </a:solidFill>
+                <a:latin typeface="Courier"/>
+              </a:rPr>
+              <a:t>(lake) </a:t>
+            </a:r>
+            <a:r>
+              <a:rPr>
+                <a:solidFill>
+                  <a:srgbClr val="5E5E5E"/>
+                </a:solidFill>
+                <a:latin typeface="Courier"/>
+              </a:rPr>
+              <a:t>%&gt;%</a:t>
+            </a:r>
+            <a:br/>
+            <a:r>
+              <a:rPr>
+                <a:solidFill>
+                  <a:srgbClr val="003B4F"/>
+                </a:solidFill>
+                <a:latin typeface="Courier"/>
+              </a:rPr>
+              <a:t>  </a:t>
+            </a:r>
+            <a:r>
+              <a:rPr>
+                <a:solidFill>
+                  <a:srgbClr val="4758AB"/>
+                </a:solidFill>
+                <a:latin typeface="Courier"/>
+              </a:rPr>
+              <a:t>summarise</a:t>
+            </a:r>
+            <a:r>
+              <a:rPr>
+                <a:solidFill>
+                  <a:srgbClr val="003B4F"/>
+                </a:solidFill>
+                <a:latin typeface="Courier"/>
+              </a:rPr>
+              <a:t>(</a:t>
+            </a:r>
+            <a:br/>
+            <a:r>
+              <a:rPr>
+                <a:solidFill>
+                  <a:srgbClr val="003B4F"/>
+                </a:solidFill>
+                <a:latin typeface="Courier"/>
+              </a:rPr>
+              <a:t>     </a:t>
+            </a:r>
+            <a:r>
+              <a:rPr>
+                <a:solidFill>
+                  <a:srgbClr val="657422"/>
+                </a:solidFill>
+                <a:latin typeface="Courier"/>
+              </a:rPr>
+              <a:t>var_length =</a:t>
+            </a:r>
+            <a:r>
+              <a:rPr>
+                <a:solidFill>
+                  <a:srgbClr val="003B4F"/>
+                </a:solidFill>
+                <a:latin typeface="Courier"/>
+              </a:rPr>
+              <a:t> </a:t>
+            </a:r>
+            <a:r>
+              <a:rPr>
+                <a:solidFill>
+                  <a:srgbClr val="4758AB"/>
+                </a:solidFill>
+                <a:latin typeface="Courier"/>
+              </a:rPr>
+              <a:t>var</a:t>
+            </a:r>
+            <a:r>
+              <a:rPr>
+                <a:solidFill>
+                  <a:srgbClr val="003B4F"/>
+                </a:solidFill>
+                <a:latin typeface="Courier"/>
+              </a:rPr>
+              <a:t>(length_mm), </a:t>
+            </a:r>
+            <a:br/>
+            <a:r>
+              <a:rPr>
+                <a:solidFill>
+                  <a:srgbClr val="003B4F"/>
+                </a:solidFill>
+                <a:latin typeface="Courier"/>
+              </a:rPr>
+              <a:t>     </a:t>
+            </a:r>
+            <a:r>
+              <a:rPr>
+                <a:solidFill>
+                  <a:srgbClr val="657422"/>
+                </a:solidFill>
+                <a:latin typeface="Courier"/>
+              </a:rPr>
+              <a:t>sd_length =</a:t>
+            </a:r>
+            <a:r>
+              <a:rPr>
+                <a:solidFill>
+                  <a:srgbClr val="003B4F"/>
+                </a:solidFill>
+                <a:latin typeface="Courier"/>
+              </a:rPr>
+              <a:t> </a:t>
+            </a:r>
+            <a:r>
+              <a:rPr>
+                <a:solidFill>
+                  <a:srgbClr val="4758AB"/>
+                </a:solidFill>
+                <a:latin typeface="Courier"/>
+              </a:rPr>
+              <a:t>sd</a:t>
+            </a:r>
+            <a:r>
+              <a:rPr>
+                <a:solidFill>
+                  <a:srgbClr val="003B4F"/>
+                </a:solidFill>
+                <a:latin typeface="Courier"/>
+              </a:rPr>
+              <a:t>(length_mm) ) </a:t>
             </a:r>
           </a:p>
           <a:p>
@@ -4783,7 +5498,7 @@
             </a:pPr>
             <a:r>
               <a:rPr/>
-              <a:t>The area under the curve of a bell shaped curve within + and - 2 Standard deviations on each side includes about 95% of the data</a:t>
+              <a:t>The area under the curve of a bell shaped curve within + and - 2 standard deviations on each side includes about 95% of the data</a:t>
             </a:r>
             <a:br/>
             <a:br/>
@@ -4793,12 +5508,17 @@
             </a:r>
           </a:p>
           <a:p>
-            <a:pPr lvl="0" indent="0" marL="0">
-              <a:buNone/>
-            </a:pPr>
-            <a:r>
-              <a:rPr/>
-              <a:t>- note the similarity to the p &lt; 0.5</a:t>
+            <a:pPr lvl="0"/>
+            <a:r>
+              <a:rPr/>
+              <a:t>note the similarity to the p &lt; 0.5</a:t>
+            </a:r>
+          </a:p>
+          <a:p>
+            <a:pPr lvl="0"/>
+            <a:r>
+              <a:rPr/>
+              <a:t>note that it is 90.91% and that is because the curve is not normal</a:t>
             </a:r>
           </a:p>
           <a:p>
@@ -5623,27 +6343,21 @@
             </a:r>
           </a:p>
           <a:p>
-            <a:pPr lvl="0" indent="0" marL="0">
-              <a:buNone/>
-            </a:pPr>
+            <a:pPr lvl="0"/>
             <a:r>
               <a:rPr/>
               <a:t>TGW - yep its a thing</a:t>
             </a:r>
           </a:p>
           <a:p>
-            <a:pPr lvl="0" indent="0" marL="0">
-              <a:buNone/>
-            </a:pPr>
+            <a:pPr lvl="0"/>
             <a:r>
               <a:rPr/>
               <a:t>ODO - what do you think it is?</a:t>
             </a:r>
           </a:p>
           <a:p>
-            <a:pPr lvl="0" indent="0" marL="0">
-              <a:buNone/>
-            </a:pPr>
+            <a:pPr lvl="0"/>
             <a:r>
               <a:rPr/>
               <a:t>NO3 - what is it? Are you sure? Why might you get in legal trouble if you used this?</a:t>
@@ -5751,6 +6465,15 @@
           <a:bodyPr/>
           <a:lstStyle/>
           <a:p>
+            <a:pPr lvl="0" indent="0" marL="0">
+              <a:buNone/>
+            </a:pPr>
+            <a:r>
+              <a:rPr/>
+              <a:t>To tranform data to a “normal” distribution we can use the following transformations…</a:t>
+            </a:r>
+          </a:p>
+          <a:p>
             <a:pPr lvl="0"/>
             <a:r>
               <a:rPr b="1"/>
@@ -7064,7 +7787,7 @@
             </a:r>
             <a:r>
               <a:rPr/>
-              <a:t>` from two different lakes to explore these concepts.. like you did in the homework</a:t>
+              <a:t> from two different lakes to explore these concepts.. like you did in the homework</a:t>
             </a:r>
           </a:p>
         </p:txBody>
@@ -7432,15 +8155,134 @@
               <a:t>)</a:t>
             </a:r>
             <a:br/>
+            <a:r>
+              <a:rPr>
+                <a:solidFill>
+                  <a:srgbClr val="5E5E5E"/>
+                </a:solidFill>
+                <a:latin typeface="Courier"/>
+              </a:rPr>
+              <a:t># Function to take a random sample and calculate the mean</a:t>
+            </a:r>
             <a:br/>
             <a:r>
               <a:rPr>
                 <a:solidFill>
+                  <a:srgbClr val="003B4F"/>
+                </a:solidFill>
+                <a:latin typeface="Courier"/>
+              </a:rPr>
+              <a:t>sample_mean &lt;- </a:t>
+            </a:r>
+            <a:r>
+              <a:rPr b="1">
+                <a:solidFill>
+                  <a:srgbClr val="003B4F"/>
+                </a:solidFill>
+                <a:latin typeface="Courier"/>
+              </a:rPr>
+              <a:t>function</a:t>
+            </a:r>
+            <a:r>
+              <a:rPr>
+                <a:solidFill>
+                  <a:srgbClr val="003B4F"/>
+                </a:solidFill>
+                <a:latin typeface="Courier"/>
+              </a:rPr>
+              <a:t>(data, sample_size) {</a:t>
+            </a:r>
+            <a:br/>
+            <a:r>
+              <a:rPr>
+                <a:solidFill>
+                  <a:srgbClr val="003B4F"/>
+                </a:solidFill>
+                <a:latin typeface="Courier"/>
+              </a:rPr>
+              <a:t>  sample_data &lt;- </a:t>
+            </a:r>
+            <a:r>
+              <a:rPr>
+                <a:solidFill>
+                  <a:srgbClr val="4758AB"/>
+                </a:solidFill>
+                <a:latin typeface="Courier"/>
+              </a:rPr>
+              <a:t>sample_n</a:t>
+            </a:r>
+            <a:r>
+              <a:rPr>
+                <a:solidFill>
+                  <a:srgbClr val="003B4F"/>
+                </a:solidFill>
+                <a:latin typeface="Courier"/>
+              </a:rPr>
+              <a:t>(data, sample_size)</a:t>
+            </a:r>
+            <a:br/>
+            <a:r>
+              <a:rPr>
+                <a:solidFill>
+                  <a:srgbClr val="003B4F"/>
+                </a:solidFill>
+                <a:latin typeface="Courier"/>
+              </a:rPr>
+              <a:t>  </a:t>
+            </a:r>
+            <a:r>
+              <a:rPr>
+                <a:solidFill>
+                  <a:srgbClr val="4758AB"/>
+                </a:solidFill>
+                <a:latin typeface="Courier"/>
+              </a:rPr>
+              <a:t>return</a:t>
+            </a:r>
+            <a:r>
+              <a:rPr>
+                <a:solidFill>
+                  <a:srgbClr val="003B4F"/>
+                </a:solidFill>
+                <a:latin typeface="Courier"/>
+              </a:rPr>
+              <a:t>(</a:t>
+            </a:r>
+            <a:r>
+              <a:rPr>
+                <a:solidFill>
+                  <a:srgbClr val="4758AB"/>
+                </a:solidFill>
+                <a:latin typeface="Courier"/>
+              </a:rPr>
+              <a:t>mean</a:t>
+            </a:r>
+            <a:r>
+              <a:rPr>
+                <a:solidFill>
+                  <a:srgbClr val="003B4F"/>
+                </a:solidFill>
+                <a:latin typeface="Courier"/>
+              </a:rPr>
+              <a:t>(sample_data</a:t>
+            </a:r>
+            <a:r>
+              <a:rPr>
+                <a:solidFill>
                   <a:srgbClr val="5E5E5E"/>
                 </a:solidFill>
                 <a:latin typeface="Courier"/>
               </a:rPr>
-              <a:t># Function to take a random sample and calculate the mean</a:t>
+              <a:t>$</a:t>
+            </a:r>
+            <a:r>
+              <a:rPr>
+                <a:solidFill>
+                  <a:srgbClr val="003B4F"/>
+                </a:solidFill>
+                <a:latin typeface="Courier"/>
+              </a:rPr>
+              <a:t>length_mm))</a:t>
             </a:r>
             <a:br/>
             <a:r>
@@ -7450,36 +8292,19 @@
                 </a:solidFill>
                 <a:latin typeface="Courier"/>
               </a:rPr>
-              <a:t>sample_mean &lt;- </a:t>
-            </a:r>
-            <a:r>
-              <a:rPr b="1">
-                <a:solidFill>
-                  <a:srgbClr val="003B4F"/>
-                </a:solidFill>
-                <a:latin typeface="Courier"/>
-              </a:rPr>
-              <a:t>function</a:t>
-            </a:r>
-            <a:r>
-              <a:rPr>
-                <a:solidFill>
-                  <a:srgbClr val="003B4F"/>
-                </a:solidFill>
-                <a:latin typeface="Courier"/>
-              </a:rPr>
-              <a:t>(data, sample_size) {</a:t>
+              <a:t>}</a:t>
             </a:r>
             <a:br/>
             <a:r>
               <a:rPr>
                 <a:solidFill>
-                  <a:srgbClr val="003B4F"/>
-                </a:solidFill>
-                <a:latin typeface="Courier"/>
-              </a:rPr>
-              <a:t>  sample_data &lt;- </a:t>
-            </a:r>
+                  <a:srgbClr val="5E5E5E"/>
+                </a:solidFill>
+                <a:latin typeface="Courier"/>
+              </a:rPr>
+              <a:t># Take 10 different samples of size 15 from Lake I3</a:t>
+            </a:r>
+            <a:br/>
             <a:r>
               <a:rPr>
                 <a:solidFill>
@@ -7487,16 +8312,43 @@
                 </a:solidFill>
                 <a:latin typeface="Courier"/>
               </a:rPr>
-              <a:t>sample_n</a:t>
-            </a:r>
-            <a:r>
-              <a:rPr>
-                <a:solidFill>
-                  <a:srgbClr val="003B4F"/>
-                </a:solidFill>
-                <a:latin typeface="Courier"/>
-              </a:rPr>
-              <a:t>(data, sample_size)</a:t>
+              <a:t>set.seed</a:t>
+            </a:r>
+            <a:r>
+              <a:rPr>
+                <a:solidFill>
+                  <a:srgbClr val="003B4F"/>
+                </a:solidFill>
+                <a:latin typeface="Courier"/>
+              </a:rPr>
+              <a:t>(</a:t>
+            </a:r>
+            <a:r>
+              <a:rPr>
+                <a:solidFill>
+                  <a:srgbClr val="AD0000"/>
+                </a:solidFill>
+                <a:latin typeface="Courier"/>
+              </a:rPr>
+              <a:t>123</a:t>
+            </a:r>
+            <a:r>
+              <a:rPr>
+                <a:solidFill>
+                  <a:srgbClr val="003B4F"/>
+                </a:solidFill>
+                <a:latin typeface="Courier"/>
+              </a:rPr>
+              <a:t>) </a:t>
+            </a:r>
+            <a:r>
+              <a:rPr>
+                <a:solidFill>
+                  <a:srgbClr val="5E5E5E"/>
+                </a:solidFill>
+                <a:latin typeface="Courier"/>
+              </a:rPr>
+              <a:t># For reproducibility</a:t>
             </a:r>
             <a:br/>
             <a:r>
@@ -7506,43 +8358,155 @@
                 </a:solidFill>
                 <a:latin typeface="Courier"/>
               </a:rPr>
+              <a:t>sample_size &lt;- </a:t>
+            </a:r>
+            <a:r>
+              <a:rPr>
+                <a:solidFill>
+                  <a:srgbClr val="AD0000"/>
+                </a:solidFill>
+                <a:latin typeface="Courier"/>
+              </a:rPr>
+              <a:t>15</a:t>
+            </a:r>
+            <a:br/>
+            <a:r>
+              <a:rPr>
+                <a:solidFill>
+                  <a:srgbClr val="003B4F"/>
+                </a:solidFill>
+                <a:latin typeface="Courier"/>
+              </a:rPr>
+              <a:t>sample_means &lt;- </a:t>
+            </a:r>
+            <a:r>
+              <a:rPr>
+                <a:solidFill>
+                  <a:srgbClr val="4758AB"/>
+                </a:solidFill>
+                <a:latin typeface="Courier"/>
+              </a:rPr>
+              <a:t>replicate</a:t>
+            </a:r>
+            <a:r>
+              <a:rPr>
+                <a:solidFill>
+                  <a:srgbClr val="003B4F"/>
+                </a:solidFill>
+                <a:latin typeface="Courier"/>
+              </a:rPr>
+              <a:t>(</a:t>
+            </a:r>
+            <a:r>
+              <a:rPr>
+                <a:solidFill>
+                  <a:srgbClr val="AD0000"/>
+                </a:solidFill>
+                <a:latin typeface="Courier"/>
+              </a:rPr>
+              <a:t>50</a:t>
+            </a:r>
+            <a:r>
+              <a:rPr>
+                <a:solidFill>
+                  <a:srgbClr val="003B4F"/>
+                </a:solidFill>
+                <a:latin typeface="Courier"/>
+              </a:rPr>
+              <a:t>, </a:t>
+            </a:r>
+            <a:r>
+              <a:rPr>
+                <a:solidFill>
+                  <a:srgbClr val="4758AB"/>
+                </a:solidFill>
+                <a:latin typeface="Courier"/>
+              </a:rPr>
+              <a:t>sample_mean</a:t>
+            </a:r>
+            <a:r>
+              <a:rPr>
+                <a:solidFill>
+                  <a:srgbClr val="003B4F"/>
+                </a:solidFill>
+                <a:latin typeface="Courier"/>
+              </a:rPr>
+              <a:t>(i3_data, sample_size))</a:t>
+            </a:r>
+            <a:br/>
+            <a:r>
+              <a:rPr>
+                <a:solidFill>
+                  <a:srgbClr val="5E5E5E"/>
+                </a:solidFill>
+                <a:latin typeface="Courier"/>
+              </a:rPr>
+              <a:t># Create a data frame with sample numbers and means</a:t>
+            </a:r>
+            <a:br/>
+            <a:r>
+              <a:rPr>
+                <a:solidFill>
+                  <a:srgbClr val="003B4F"/>
+                </a:solidFill>
+                <a:latin typeface="Courier"/>
+              </a:rPr>
+              <a:t>samples_df &lt;- </a:t>
+            </a:r>
+            <a:r>
+              <a:rPr>
+                <a:solidFill>
+                  <a:srgbClr val="4758AB"/>
+                </a:solidFill>
+                <a:latin typeface="Courier"/>
+              </a:rPr>
+              <a:t>data.frame</a:t>
+            </a:r>
+            <a:r>
+              <a:rPr>
+                <a:solidFill>
+                  <a:srgbClr val="003B4F"/>
+                </a:solidFill>
+                <a:latin typeface="Courier"/>
+              </a:rPr>
+              <a:t>(</a:t>
+            </a:r>
+            <a:br/>
+            <a:r>
+              <a:rPr>
+                <a:solidFill>
+                  <a:srgbClr val="003B4F"/>
+                </a:solidFill>
+                <a:latin typeface="Courier"/>
+              </a:rPr>
               <a:t>  </a:t>
             </a:r>
             <a:r>
               <a:rPr>
                 <a:solidFill>
-                  <a:srgbClr val="4758AB"/>
-                </a:solidFill>
-                <a:latin typeface="Courier"/>
-              </a:rPr>
-              <a:t>return</a:t>
-            </a:r>
-            <a:r>
-              <a:rPr>
-                <a:solidFill>
-                  <a:srgbClr val="003B4F"/>
-                </a:solidFill>
-                <a:latin typeface="Courier"/>
-              </a:rPr>
-              <a:t>(</a:t>
-            </a:r>
-            <a:r>
-              <a:rPr>
-                <a:solidFill>
-                  <a:srgbClr val="4758AB"/>
-                </a:solidFill>
-                <a:latin typeface="Courier"/>
-              </a:rPr>
-              <a:t>mean</a:t>
-            </a:r>
-            <a:r>
-              <a:rPr>
-                <a:solidFill>
-                  <a:srgbClr val="003B4F"/>
-                </a:solidFill>
-                <a:latin typeface="Courier"/>
-              </a:rPr>
-              <a:t>(sample_data</a:t>
+                  <a:srgbClr val="657422"/>
+                </a:solidFill>
+                <a:latin typeface="Courier"/>
+              </a:rPr>
+              <a:t>sample_number =</a:t>
+            </a:r>
+            <a:r>
+              <a:rPr>
+                <a:solidFill>
+                  <a:srgbClr val="003B4F"/>
+                </a:solidFill>
+                <a:latin typeface="Courier"/>
+              </a:rPr>
+              <a:t> </a:t>
+            </a:r>
+            <a:r>
+              <a:rPr>
+                <a:solidFill>
+                  <a:srgbClr val="AD0000"/>
+                </a:solidFill>
+                <a:latin typeface="Courier"/>
+              </a:rPr>
+              <a:t>1</a:t>
             </a:r>
             <a:r>
               <a:rPr>
@@ -7551,56 +8515,7 @@
                 </a:solidFill>
                 <a:latin typeface="Courier"/>
               </a:rPr>
-              <a:t>$</a:t>
-            </a:r>
-            <a:r>
-              <a:rPr>
-                <a:solidFill>
-                  <a:srgbClr val="003B4F"/>
-                </a:solidFill>
-                <a:latin typeface="Courier"/>
-              </a:rPr>
-              <a:t>length_mm))</a:t>
-            </a:r>
-            <a:br/>
-            <a:r>
-              <a:rPr>
-                <a:solidFill>
-                  <a:srgbClr val="003B4F"/>
-                </a:solidFill>
-                <a:latin typeface="Courier"/>
-              </a:rPr>
-              <a:t>}</a:t>
-            </a:r>
-            <a:br/>
-            <a:br/>
-            <a:r>
-              <a:rPr>
-                <a:solidFill>
-                  <a:srgbClr val="5E5E5E"/>
-                </a:solidFill>
-                <a:latin typeface="Courier"/>
-              </a:rPr>
-              <a:t># Take 10 different samples of size 15 from Lake I3</a:t>
-            </a:r>
-            <a:br/>
-            <a:r>
-              <a:rPr>
-                <a:solidFill>
-                  <a:srgbClr val="4758AB"/>
-                </a:solidFill>
-                <a:latin typeface="Courier"/>
-              </a:rPr>
-              <a:t>set.seed</a:t>
-            </a:r>
-            <a:r>
-              <a:rPr>
-                <a:solidFill>
-                  <a:srgbClr val="003B4F"/>
-                </a:solidFill>
-                <a:latin typeface="Courier"/>
-              </a:rPr>
-              <a:t>(</a:t>
+              <a:t>:</a:t>
             </a:r>
             <a:r>
               <a:rPr>
@@ -7609,202 +8524,7 @@
                 </a:solidFill>
                 <a:latin typeface="Courier"/>
               </a:rPr>
-              <a:t>123</a:t>
-            </a:r>
-            <a:r>
-              <a:rPr>
-                <a:solidFill>
-                  <a:srgbClr val="003B4F"/>
-                </a:solidFill>
-                <a:latin typeface="Courier"/>
-              </a:rPr>
-              <a:t>) </a:t>
-            </a:r>
-            <a:r>
-              <a:rPr>
-                <a:solidFill>
-                  <a:srgbClr val="5E5E5E"/>
-                </a:solidFill>
-                <a:latin typeface="Courier"/>
-              </a:rPr>
-              <a:t># For reproducibility</a:t>
-            </a:r>
-            <a:br/>
-            <a:r>
-              <a:rPr>
-                <a:solidFill>
-                  <a:srgbClr val="003B4F"/>
-                </a:solidFill>
-                <a:latin typeface="Courier"/>
-              </a:rPr>
-              <a:t>sample_size &lt;- </a:t>
-            </a:r>
-            <a:r>
-              <a:rPr>
-                <a:solidFill>
-                  <a:srgbClr val="AD0000"/>
-                </a:solidFill>
-                <a:latin typeface="Courier"/>
-              </a:rPr>
-              <a:t>15</a:t>
-            </a:r>
-            <a:br/>
-            <a:r>
-              <a:rPr>
-                <a:solidFill>
-                  <a:srgbClr val="003B4F"/>
-                </a:solidFill>
-                <a:latin typeface="Courier"/>
-              </a:rPr>
-              <a:t>sample_means &lt;- </a:t>
-            </a:r>
-            <a:r>
-              <a:rPr>
-                <a:solidFill>
-                  <a:srgbClr val="4758AB"/>
-                </a:solidFill>
-                <a:latin typeface="Courier"/>
-              </a:rPr>
-              <a:t>replicate</a:t>
-            </a:r>
-            <a:r>
-              <a:rPr>
-                <a:solidFill>
-                  <a:srgbClr val="003B4F"/>
-                </a:solidFill>
-                <a:latin typeface="Courier"/>
-              </a:rPr>
-              <a:t>(</a:t>
-            </a:r>
-            <a:r>
-              <a:rPr>
-                <a:solidFill>
-                  <a:srgbClr val="AD0000"/>
-                </a:solidFill>
-                <a:latin typeface="Courier"/>
-              </a:rPr>
-              <a:t>10</a:t>
-            </a:r>
-            <a:r>
-              <a:rPr>
-                <a:solidFill>
-                  <a:srgbClr val="003B4F"/>
-                </a:solidFill>
-                <a:latin typeface="Courier"/>
-              </a:rPr>
-              <a:t>, </a:t>
-            </a:r>
-            <a:r>
-              <a:rPr>
-                <a:solidFill>
-                  <a:srgbClr val="4758AB"/>
-                </a:solidFill>
-                <a:latin typeface="Courier"/>
-              </a:rPr>
-              <a:t>sample_mean</a:t>
-            </a:r>
-            <a:r>
-              <a:rPr>
-                <a:solidFill>
-                  <a:srgbClr val="003B4F"/>
-                </a:solidFill>
-                <a:latin typeface="Courier"/>
-              </a:rPr>
-              <a:t>(i3_data, sample_size))</a:t>
-            </a:r>
-            <a:br/>
-            <a:br/>
-            <a:r>
-              <a:rPr>
-                <a:solidFill>
-                  <a:srgbClr val="5E5E5E"/>
-                </a:solidFill>
-                <a:latin typeface="Courier"/>
-              </a:rPr>
-              <a:t># Create a data frame with sample numbers and means</a:t>
-            </a:r>
-            <a:br/>
-            <a:r>
-              <a:rPr>
-                <a:solidFill>
-                  <a:srgbClr val="003B4F"/>
-                </a:solidFill>
-                <a:latin typeface="Courier"/>
-              </a:rPr>
-              <a:t>samples_df &lt;- </a:t>
-            </a:r>
-            <a:r>
-              <a:rPr>
-                <a:solidFill>
-                  <a:srgbClr val="4758AB"/>
-                </a:solidFill>
-                <a:latin typeface="Courier"/>
-              </a:rPr>
-              <a:t>data.frame</a:t>
-            </a:r>
-            <a:r>
-              <a:rPr>
-                <a:solidFill>
-                  <a:srgbClr val="003B4F"/>
-                </a:solidFill>
-                <a:latin typeface="Courier"/>
-              </a:rPr>
-              <a:t>(</a:t>
-            </a:r>
-            <a:br/>
-            <a:r>
-              <a:rPr>
-                <a:solidFill>
-                  <a:srgbClr val="003B4F"/>
-                </a:solidFill>
-                <a:latin typeface="Courier"/>
-              </a:rPr>
-              <a:t>  </a:t>
-            </a:r>
-            <a:r>
-              <a:rPr>
-                <a:solidFill>
-                  <a:srgbClr val="657422"/>
-                </a:solidFill>
-                <a:latin typeface="Courier"/>
-              </a:rPr>
-              <a:t>sample_number =</a:t>
-            </a:r>
-            <a:r>
-              <a:rPr>
-                <a:solidFill>
-                  <a:srgbClr val="003B4F"/>
-                </a:solidFill>
-                <a:latin typeface="Courier"/>
-              </a:rPr>
-              <a:t> </a:t>
-            </a:r>
-            <a:r>
-              <a:rPr>
-                <a:solidFill>
-                  <a:srgbClr val="AD0000"/>
-                </a:solidFill>
-                <a:latin typeface="Courier"/>
-              </a:rPr>
-              <a:t>1</a:t>
-            </a:r>
-            <a:r>
-              <a:rPr>
-                <a:solidFill>
-                  <a:srgbClr val="5E5E5E"/>
-                </a:solidFill>
-                <a:latin typeface="Courier"/>
-              </a:rPr>
-              <a:t>:</a:t>
-            </a:r>
-            <a:r>
-              <a:rPr>
-                <a:solidFill>
-                  <a:srgbClr val="AD0000"/>
-                </a:solidFill>
-                <a:latin typeface="Courier"/>
-              </a:rPr>
-              <a:t>10</a:t>
+              <a:t>50</a:t>
             </a:r>
             <a:r>
               <a:rPr>
@@ -11340,7 +12060,7 @@
             </a:pPr>
             <a:r>
               <a:rPr/>
-              <a:t>Lecture 3: Why Statistics is Vital in Biology</a:t>
+              <a:t>Lecture 3: Populations and Samples</a:t>
             </a:r>
           </a:p>
         </p:txBody>
@@ -11365,116 +12085,129 @@
             </a:pPr>
             <a:r>
               <a:rPr/>
-              <a:t>Biology is fundamentally different from fields like physics/chemistry in that:</a:t>
+              <a:t>Before we dive into descriptive statistics, let’s clarify some fundamental concepts:</a:t>
             </a:r>
           </a:p>
           <a:p>
             <a:pPr lvl="0"/>
             <a:r>
-              <a:rPr/>
-              <a:t>Most biological phenomena are </a:t>
-            </a:r>
-            <a:r>
               <a:rPr b="1"/>
-              <a:t>probabilistic</a:t>
-            </a:r>
-            <a:r>
-              <a:rPr/>
-              <a:t> rather than </a:t>
-            </a:r>
+              <a:t>Population</a:t>
+            </a:r>
+            <a:r>
+              <a:rPr/>
+              <a:t>: entire group of things under consideration</a:t>
+            </a:r>
+          </a:p>
+          <a:p>
+            <a:pPr lvl="0"/>
             <a:r>
               <a:rPr b="1"/>
-              <a:t>deterministic</a:t>
-            </a:r>
-          </a:p>
-          <a:p>
-            <a:pPr lvl="1"/>
-            <a:r>
-              <a:rPr/>
-              <a:t>Responses occur with some characteristic probability, not with certainty</a:t>
+              <a:t>Sample</a:t>
+            </a:r>
+            <a:r>
+              <a:rPr/>
+              <a:t>: A subset of the population that is actually measured</a:t>
             </a:r>
           </a:p>
           <a:p>
             <a:pPr lvl="0"/>
             <a:r>
-              <a:rPr/>
-              <a:t>All biological material varies, which is essential for evolution (recall Darwin’s postulates):</a:t>
-            </a:r>
-          </a:p>
-          <a:p>
-            <a:pPr lvl="1"/>
-            <a:r>
-              <a:rPr/>
-              <a:t>Variation exists within populations</a:t>
-            </a:r>
-          </a:p>
-          <a:p>
-            <a:pPr lvl="1"/>
-            <a:r>
-              <a:rPr/>
-              <a:t>Some variation is heritable</a:t>
-            </a:r>
-          </a:p>
-          <a:p>
-            <a:pPr lvl="1"/>
-            <a:r>
-              <a:rPr/>
-              <a:t>Some heritable variation affects survival/reproduction</a:t>
+              <a:rPr b="1"/>
+              <a:t>Sample unit</a:t>
+            </a:r>
+            <a:r>
+              <a:rPr/>
+              <a:t>: The individual thing drawn from the population</a:t>
+            </a:r>
+          </a:p>
+          <a:p>
+            <a:pPr lvl="0" indent="0" marL="0">
+              <a:buNone/>
+            </a:pPr>
+            <a:r>
+              <a:rPr/>
+              <a:t>Types of populations:</a:t>
             </a:r>
           </a:p>
           <a:p>
             <a:pPr lvl="0"/>
             <a:r>
-              <a:rPr/>
-              <a:t>Environmental conditions (in nature, lab, or greenhouse) always vary</a:t>
+              <a:rPr b="1"/>
+              <a:t>Observational population</a:t>
+            </a:r>
+            <a:r>
+              <a:rPr/>
+              <a:t>: </a:t>
+            </a:r>
+            <a:r>
+              <a:rPr b="1"/>
+              <a:t>group whose characteristics are studied passively</a:t>
+            </a:r>
+            <a:r>
+              <a:rPr/>
+              <a:t> (e.g., head width of all corn earworms in a field)</a:t>
             </a:r>
           </a:p>
           <a:p>
             <a:pPr lvl="0"/>
             <a:r>
-              <a:rPr/>
-              <a:t>Measurements include error</a:t>
+              <a:rPr b="1"/>
+              <a:t>Experimental population</a:t>
+            </a:r>
+            <a:r>
+              <a:rPr/>
+              <a:t>: </a:t>
+            </a:r>
+            <a:r>
+              <a:rPr b="1"/>
+              <a:t>actively manipulate variables to observe effects and establish cause-and-effect relationships (e.g.,</a:t>
+            </a:r>
+            <a:r>
+              <a:rPr/>
+              <a:t> manipulate temperature and monitor head width)</a:t>
+            </a:r>
+          </a:p>
+          <a:p>
+            <a:pPr lvl="0" indent="0" marL="0">
+              <a:buNone/>
+            </a:pPr>
+            <a:r>
+              <a:rPr/>
+              <a:t>Sampling involves</a:t>
             </a:r>
           </a:p>
           <a:p>
             <a:pPr lvl="0"/>
             <a:r>
-              <a:rPr/>
-              <a:t>Multiple unmeasured causal factors influence nearly all biological systems</a:t>
-            </a:r>
-          </a:p>
-          <a:p>
-            <a:pPr lvl="0" indent="0" marL="0">
-              <a:buNone/>
-            </a:pPr>
-            <a:r>
-              <a:rPr/>
-              <a:t>Statistics helps us understand biological processes in this variable world by:</a:t>
-            </a:r>
-          </a:p>
-          <a:p>
-            <a:pPr lvl="0" indent="-342900" marL="342900">
-              <a:buAutoNum type="arabicPeriod"/>
-            </a:pPr>
-            <a:r>
-              <a:rPr/>
-              <a:t>Condensing variation into summary form (Descriptive statistics)</a:t>
-            </a:r>
-          </a:p>
-          <a:p>
-            <a:pPr lvl="0" indent="-342900" marL="342900">
-              <a:buAutoNum type="arabicPeriod"/>
-            </a:pPr>
-            <a:r>
-              <a:rPr/>
-              <a:t>Testing whether observations are consistent with predictions (Inferential statistics)</a:t>
+              <a:rPr b="1"/>
+              <a:t>inference</a:t>
+            </a:r>
+            <a:r>
+              <a:rPr/>
+              <a:t> - generalizing from what is observed in the sample to what is present in the population.</a:t>
+            </a:r>
+          </a:p>
+          <a:p>
+            <a:pPr lvl="0"/>
+            <a:r>
+              <a:rPr/>
+              <a:t>Valid inference requires </a:t>
+            </a:r>
+            <a:r>
+              <a:rPr b="1"/>
+              <a:t>random sampling</a:t>
+            </a:r>
+            <a:r>
+              <a:rPr/>
+              <a:t>.</a:t>
             </a:r>
           </a:p>
         </p:txBody>
       </p:sp>
       <p:pic>
         <p:nvPicPr>
-          <p:cNvPr descr="03_01_lecture_powerpoint_files/figure-pptx/unnamed-chunk-1-1.png" id="0" name="Picture 1"/>
+          <p:cNvPr descr="images/pop_sample_stats.png" id="0" name="Picture 1"/>
           <p:cNvPicPr>
             <a:picLocks noGrp="1" noChangeAspect="1"/>
           </p:cNvPicPr>
@@ -11488,8 +12221,8 @@
         </p:blipFill>
         <p:spPr bwMode="auto">
           <a:xfrm>
-            <a:off x="6121400" y="2044700"/>
-            <a:ext cx="2781300" cy="1714500"/>
+            <a:off x="6121400" y="889000"/>
+            <a:ext cx="2781300" cy="4013200"/>
           </a:xfrm>
           <a:prstGeom prst="rect">
             <a:avLst/>
@@ -16390,132 +17123,6 @@
         <p:spPr>
           <a:xfrm>
             <a:off x="0" y="0"/>
-            <a:ext cx="9144000" cy="582780"/>
-          </a:xfrm>
-        </p:spPr>
-        <p:txBody>
-          <a:bodyPr/>
-          <a:lstStyle/>
-          <a:p>
-            <a:pPr lvl="0" indent="0" marL="0">
-              <a:buNone/>
-            </a:pPr>
-            <a:r>
-              <a:rPr/>
-              <a:t>Practice Exercise 1: Fish Data</a:t>
-            </a:r>
-          </a:p>
-        </p:txBody>
-      </p:sp>
-      <p:sp>
-        <p:nvSpPr>
-          <p:cNvPr id="3" name="Content Placeholder 2"/>
-          <p:cNvSpPr>
-            <a:spLocks noGrp="1"/>
-          </p:cNvSpPr>
-          <p:nvPr>
-            <p:ph idx="1"/>
-          </p:nvPr>
-        </p:nvSpPr>
-        <p:spPr/>
-        <p:txBody>
-          <a:bodyPr/>
-          <a:lstStyle/>
-          <a:p>
-            <a:pPr lvl="0" indent="0" marL="1270000">
-              <a:buNone/>
-            </a:pPr>
-            <a:r>
-              <a:rPr sz="2000" b="1"/>
-              <a:t>Practice Exercise 1: Can you open the fish data </a:t>
-            </a:r>
-            <a:r>
-              <a:rPr sz="2000" b="1">
-                <a:latin typeface="Courier"/>
-              </a:rPr>
-              <a:t>gray_I3_I8.csv</a:t>
-            </a:r>
-            <a:r>
-              <a:rPr sz="2000" b="1"/>
-              <a:t> and look at the structure and make a histogram?- see activity</a:t>
-            </a:r>
-          </a:p>
-          <a:p>
-            <a:pPr lvl="0" indent="0" marL="1270000">
-              <a:buNone/>
-            </a:pPr>
-            <a:r>
-              <a:rPr sz="2000"/>
-              <a:t>Let’s recreate the basic histogram of fish lengths using </a:t>
-            </a:r>
-            <a:r>
-              <a:rPr sz="2000">
-                <a:latin typeface="Courier"/>
-              </a:rPr>
-              <a:t>gray_I3_I8.csv</a:t>
-            </a:r>
-          </a:p>
-          <a:p>
-            <a:pPr lvl="0" indent="0">
-              <a:buNone/>
-            </a:pPr>
-            <a:r>
-              <a:rPr>
-                <a:solidFill>
-                  <a:srgbClr val="5E5E5E"/>
-                </a:solidFill>
-                <a:latin typeface="Courier"/>
-              </a:rPr>
-              <a:t># Write your code here to read in the file</a:t>
-            </a:r>
-            <a:br/>
-            <a:r>
-              <a:rPr>
-                <a:solidFill>
-                  <a:srgbClr val="5E5E5E"/>
-                </a:solidFill>
-                <a:latin typeface="Courier"/>
-              </a:rPr>
-              <a:t># How do you examine the data - what are the ways you think and lets try it!</a:t>
-            </a:r>
-          </a:p>
-        </p:txBody>
-      </p:sp>
-    </p:spTree>
-  </p:cSld>
-</p:sld>
-</file>
-
-<file path=ppt/slides/slide6.xml><?xml version="1.0" encoding="utf-8"?>
-<p:sld xmlns:a="http://schemas.openxmlformats.org/drawingml/2006/main" xmlns:r="http://schemas.openxmlformats.org/officeDocument/2006/relationships" xmlns:p="http://schemas.openxmlformats.org/presentationml/2006/main">
-  <p:cSld>
-    <p:spTree>
-      <p:nvGrpSpPr>
-        <p:cNvPr id="1" name=""/>
-        <p:cNvGrpSpPr/>
-        <p:nvPr/>
-      </p:nvGrpSpPr>
-      <p:grpSpPr>
-        <a:xfrm>
-          <a:off x="0" y="0"/>
-          <a:ext cx="0" cy="0"/>
-          <a:chOff x="0" y="0"/>
-          <a:chExt cx="0" cy="0"/>
-        </a:xfrm>
-      </p:grpSpPr>
-      <p:sp>
-        <p:nvSpPr>
-          <p:cNvPr id="2" name="Title 1"/>
-          <p:cNvSpPr>
-            <a:spLocks noGrp="1"/>
-          </p:cNvSpPr>
-          <p:nvPr>
-            <p:ph type="title"/>
-          </p:nvPr>
-        </p:nvSpPr>
-        <p:spPr>
-          <a:xfrm>
-            <a:off x="0" y="0"/>
             <a:ext cx="9144000" cy="602780"/>
           </a:xfrm>
           <a:solidFill>
@@ -16531,7 +17138,7 @@
             </a:pPr>
             <a:r>
               <a:rPr/>
-              <a:t>Lecture 3: Populations and Samples</a:t>
+              <a:t>Lecture 3: Parameters vs. Statistics</a:t>
             </a:r>
           </a:p>
         </p:txBody>
@@ -16556,106 +17163,52 @@
             </a:pPr>
             <a:r>
               <a:rPr/>
-              <a:t>Before we dive into descriptive statistics, let’s clarify some fundamental concepts:</a:t>
+              <a:t>It’s important to distinguish between:</a:t>
             </a:r>
           </a:p>
           <a:p>
             <a:pPr lvl="0"/>
             <a:r>
               <a:rPr b="1"/>
-              <a:t>Population</a:t>
-            </a:r>
-            <a:r>
-              <a:rPr/>
-              <a:t>: The entire group of things under consideration; the group for which answers obtained from measurements and statistical analysis are pertinent.</a:t>
+              <a:t>Parameters</a:t>
+            </a:r>
+            <a:r>
+              <a:rPr/>
+              <a:t>: True numerical values for a population (usually denoted by Greek letters)</a:t>
             </a:r>
           </a:p>
           <a:p>
             <a:pPr lvl="0"/>
             <a:r>
               <a:rPr b="1"/>
-              <a:t>Sample</a:t>
-            </a:r>
-            <a:r>
-              <a:rPr/>
-              <a:t>: A subset of the population that is actually measured.</a:t>
+              <a:t>Statistics</a:t>
+            </a:r>
+            <a:r>
+              <a:rPr/>
+              <a:t>: Estimates of parameters based on samples (usually denoted by Roman letters)</a:t>
+            </a:r>
+          </a:p>
+          <a:p>
+            <a:pPr lvl="0" indent="0" marL="0">
+              <a:buNone/>
+            </a:pPr>
+            <a:r>
+              <a:rPr/>
+              <a:t>For example:</a:t>
             </a:r>
           </a:p>
           <a:p>
             <a:pPr lvl="0"/>
             <a:r>
-              <a:rPr b="1"/>
-              <a:t>Sample unit</a:t>
-            </a:r>
-            <a:r>
-              <a:rPr/>
-              <a:t>: The individual thing drawn from the population.</a:t>
-            </a:r>
-          </a:p>
-          <a:p>
-            <a:pPr lvl="0" indent="0" marL="0">
-              <a:buNone/>
-            </a:pPr>
-            <a:r>
-              <a:rPr/>
-              <a:t>Types of populations:</a:t>
+              <a:rPr/>
+              <a:t>Population mean (μ) is estimated by sample mean (Y̅)</a:t>
             </a:r>
           </a:p>
           <a:p>
             <a:pPr lvl="0"/>
             <a:r>
-              <a:rPr b="1"/>
-              <a:t>Observational population</a:t>
-            </a:r>
-            <a:r>
-              <a:rPr/>
-              <a:t>: Usually finite but may be very large (e.g., head width of all corn earworms in a field)</a:t>
-            </a:r>
-          </a:p>
-          <a:p>
-            <a:pPr lvl="0"/>
-            <a:r>
-              <a:rPr b="1"/>
-              <a:t>Experimental population</a:t>
-            </a:r>
-            <a:r>
-              <a:rPr/>
-              <a:t>: Often conceptually infinite (e.g., all possible goldenrod plants that could receive a specific fertilizer treatment)</a:t>
-            </a:r>
-          </a:p>
-          <a:p>
-            <a:pPr lvl="0" indent="0" marL="0">
-              <a:buNone/>
-            </a:pPr>
-            <a:r>
-              <a:rPr/>
-              <a:t>Sampling involves</a:t>
-            </a:r>
-          </a:p>
-          <a:p>
-            <a:pPr lvl="0"/>
-            <a:r>
-              <a:rPr b="1"/>
-              <a:t>inference</a:t>
-            </a:r>
-            <a:r>
-              <a:rPr/>
-              <a:t> - generalizing from what is observed in the sample to what is present in the population.</a:t>
-            </a:r>
-          </a:p>
-          <a:p>
-            <a:pPr lvl="0"/>
-            <a:r>
-              <a:rPr/>
-              <a:t>Valid inference requires </a:t>
-            </a:r>
-            <a:r>
-              <a:rPr b="1"/>
-              <a:t>random sampling</a:t>
-            </a:r>
-            <a:r>
-              <a:rPr/>
-              <a:t>.</a:t>
+              <a:rPr/>
+              <a:t>Population standard deviation (σ) is estimated by sample standard deviation (s)</a:t>
             </a:r>
           </a:p>
         </p:txBody>
@@ -16695,6 +17248,172 @@
 </p:sld>
 </file>
 
+<file path=ppt/slides/slide6.xml><?xml version="1.0" encoding="utf-8"?>
+<p:sld xmlns:a="http://schemas.openxmlformats.org/drawingml/2006/main" xmlns:r="http://schemas.openxmlformats.org/officeDocument/2006/relationships" xmlns:p="http://schemas.openxmlformats.org/presentationml/2006/main">
+  <p:cSld>
+    <p:spTree>
+      <p:nvGrpSpPr>
+        <p:cNvPr id="1" name=""/>
+        <p:cNvGrpSpPr/>
+        <p:nvPr/>
+      </p:nvGrpSpPr>
+      <p:grpSpPr>
+        <a:xfrm>
+          <a:off x="0" y="0"/>
+          <a:ext cx="0" cy="0"/>
+          <a:chOff x="0" y="0"/>
+          <a:chExt cx="0" cy="0"/>
+        </a:xfrm>
+      </p:grpSpPr>
+      <p:sp>
+        <p:nvSpPr>
+          <p:cNvPr id="2" name="Title 1"/>
+          <p:cNvSpPr>
+            <a:spLocks noGrp="1"/>
+          </p:cNvSpPr>
+          <p:nvPr>
+            <p:ph type="title"/>
+          </p:nvPr>
+        </p:nvSpPr>
+        <p:spPr>
+          <a:xfrm>
+            <a:off x="0" y="0"/>
+            <a:ext cx="9144000" cy="582780"/>
+          </a:xfrm>
+        </p:spPr>
+        <p:txBody>
+          <a:bodyPr/>
+          <a:lstStyle/>
+          <a:p>
+            <a:pPr lvl="0" indent="0" marL="0">
+              <a:buNone/>
+            </a:pPr>
+            <a:r>
+              <a:rPr/>
+              <a:t>Lecture 3: Kinds of Biological Variables</a:t>
+            </a:r>
+          </a:p>
+        </p:txBody>
+      </p:sp>
+      <p:sp>
+        <p:nvSpPr>
+          <p:cNvPr id="3" name="Content Placeholder 2"/>
+          <p:cNvSpPr>
+            <a:spLocks noGrp="1"/>
+          </p:cNvSpPr>
+          <p:nvPr>
+            <p:ph idx="1"/>
+          </p:nvPr>
+        </p:nvSpPr>
+        <p:spPr/>
+        <p:txBody>
+          <a:bodyPr/>
+          <a:lstStyle/>
+          <a:p>
+            <a:pPr lvl="0" indent="0" marL="0">
+              <a:spcBef>
+                <a:spcPts val="3000"/>
+              </a:spcBef>
+              <a:buNone/>
+            </a:pPr>
+            <a:r>
+              <a:rPr b="1"/>
+              <a:t>Understanding the type of variable you’re working with is essential for selecting appropriate statistics:</a:t>
+            </a:r>
+          </a:p>
+          <a:p>
+            <a:pPr lvl="0" indent="0" marL="0">
+              <a:spcBef>
+                <a:spcPts val="3000"/>
+              </a:spcBef>
+              <a:buNone/>
+            </a:pPr>
+            <a:r>
+              <a:rPr b="1"/>
+              <a:t>Measurement or Quantitative Variables</a:t>
+            </a:r>
+          </a:p>
+          <a:p>
+            <a:pPr lvl="0"/>
+            <a:r>
+              <a:rPr b="1"/>
+              <a:t>Continuous</a:t>
+            </a:r>
+            <a:r>
+              <a:rPr/>
+              <a:t>: Any value between extremes of scale is possible (e.g., mass, length)</a:t>
+            </a:r>
+          </a:p>
+          <a:p>
+            <a:pPr lvl="0"/>
+            <a:r>
+              <a:rPr b="1"/>
+              <a:t>Discrete (meristic)</a:t>
+            </a:r>
+            <a:r>
+              <a:rPr/>
+              <a:t>: Only fixed values (usually integers) between extremes are possible (e.g., bristle number, egg count)</a:t>
+            </a:r>
+          </a:p>
+          <a:p>
+            <a:pPr lvl="0" indent="0" marL="0">
+              <a:spcBef>
+                <a:spcPts val="3000"/>
+              </a:spcBef>
+              <a:buNone/>
+            </a:pPr>
+            <a:r>
+              <a:rPr b="1"/>
+              <a:t>Rank Variables (Ordinal)</a:t>
+            </a:r>
+          </a:p>
+          <a:p>
+            <a:pPr lvl="0"/>
+            <a:r>
+              <a:rPr/>
+              <a:t>Assign only order, not quantity - student rank - 1 2 3</a:t>
+            </a:r>
+          </a:p>
+          <a:p>
+            <a:pPr lvl="0"/>
+            <a:r>
+              <a:rPr/>
+              <a:t>Nothing implied about relative distance between values</a:t>
+            </a:r>
+          </a:p>
+          <a:p>
+            <a:pPr lvl="0" indent="0" marL="0">
+              <a:spcBef>
+                <a:spcPts val="3000"/>
+              </a:spcBef>
+              <a:buNone/>
+            </a:pPr>
+            <a:r>
+              <a:rPr b="1"/>
+              <a:t>Categorical Variables (Qualitative)</a:t>
+            </a:r>
+          </a:p>
+          <a:p>
+            <a:pPr lvl="0"/>
+            <a:r>
+              <a:rPr/>
+              <a:t>No quantitative information (e.g., male/female, living/dead)</a:t>
+            </a:r>
+          </a:p>
+          <a:p>
+            <a:pPr lvl="0"/>
+            <a:r>
+              <a:rPr/>
+              <a:t>Some are simplifications of quantitative variables (e.g., color instead of wavelength)</a:t>
+            </a:r>
+          </a:p>
+        </p:txBody>
+      </p:sp>
+    </p:spTree>
+  </p:cSld>
+</p:sld>
+</file>
+
 <file path=ppt/slides/slide7.xml><?xml version="1.0" encoding="utf-8"?>
 <p:sld xmlns:a="http://schemas.openxmlformats.org/drawingml/2006/main" xmlns:r="http://schemas.openxmlformats.org/officeDocument/2006/relationships" xmlns:p="http://schemas.openxmlformats.org/presentationml/2006/main">
   <p:cSld>
@@ -16725,11 +17444,8 @@
         <p:spPr>
           <a:xfrm>
             <a:off x="0" y="0"/>
-            <a:ext cx="9144000" cy="602780"/>
+            <a:ext cx="9144000" cy="582780"/>
           </a:xfrm>
-          <a:solidFill>
-            <a:srgbClr val="70121D"/>
-          </a:solidFill>
         </p:spPr>
         <p:txBody>
           <a:bodyPr/>
@@ -16740,7 +17456,7 @@
             </a:pPr>
             <a:r>
               <a:rPr/>
-              <a:t>Lecture 3: Parameters vs. Statistics</a:t>
+              <a:t>Lecture 3: Derived Variables</a:t>
             </a:r>
           </a:p>
         </p:txBody>
@@ -16752,7 +17468,7 @@
             <a:spLocks noGrp="1"/>
           </p:cNvSpPr>
           <p:nvPr>
-            <p:ph idx="1" sz="half"/>
+            <p:ph idx="1"/>
           </p:nvPr>
         </p:nvSpPr>
         <p:spPr/>
@@ -16761,33 +17477,58 @@
           <a:lstStyle/>
           <a:p>
             <a:pPr lvl="0" indent="0" marL="0">
+              <a:spcBef>
+                <a:spcPts val="3000"/>
+              </a:spcBef>
               <a:buNone/>
             </a:pPr>
             <a:r>
-              <a:rPr/>
-              <a:t>It’s important to distinguish between:</a:t>
+              <a:rPr b="1"/>
+              <a:t>Derived Variables</a:t>
             </a:r>
           </a:p>
           <a:p>
             <a:pPr lvl="0"/>
             <a:r>
               <a:rPr b="1"/>
-              <a:t>Parameters</a:t>
-            </a:r>
-            <a:r>
-              <a:rPr/>
-              <a:t>: True numerical values for a population (usually denoted by Greek letters)</a:t>
+              <a:t>Percentages, Proportions</a:t>
+            </a:r>
+            <a:r>
+              <a:rPr/>
+              <a:t>: Ratio of some component to total</a:t>
             </a:r>
           </a:p>
           <a:p>
             <a:pPr lvl="0"/>
             <a:r>
               <a:rPr b="1"/>
-              <a:t>Statistics</a:t>
-            </a:r>
-            <a:r>
-              <a:rPr/>
-              <a:t>: Estimates of parameters based on samples (usually denoted by Roman letters)</a:t>
+              <a:t>Ratios</a:t>
+            </a:r>
+            <a:r>
+              <a:rPr/>
+              <a:t>: Relation of two variables</a:t>
+            </a:r>
+          </a:p>
+          <a:p>
+            <a:pPr lvl="0"/>
+            <a:r>
+              <a:rPr b="1"/>
+              <a:t>Rates</a:t>
+            </a:r>
+            <a:r>
+              <a:rPr/>
+              <a:t>: Quantity per unit (time, mass, etc.)</a:t>
+            </a:r>
+          </a:p>
+          <a:p>
+            <a:pPr lvl="0"/>
+            <a:r>
+              <a:rPr b="1"/>
+              <a:t>Indices</a:t>
+            </a:r>
+            <a:r>
+              <a:rPr/>
+              <a:t>: More complex derived variables (e.g., condition index)</a:t>
             </a:r>
           </a:p>
           <a:p>
@@ -16796,64 +17537,11 @@
             </a:pPr>
             <a:r>
               <a:rPr/>
-              <a:t>For example:</a:t>
-            </a:r>
-          </a:p>
-          <a:p>
-            <a:pPr lvl="0"/>
-            <a:r>
-              <a:rPr/>
-              <a:t>Population mean (μ) is estimated by sample mean (Y̅)</a:t>
-            </a:r>
-          </a:p>
-          <a:p>
-            <a:pPr lvl="0"/>
-            <a:r>
-              <a:rPr/>
-              <a:t>Population standard deviation (σ) is estimated by sample standard deviation (s)</a:t>
-            </a:r>
-          </a:p>
-          <a:p>
-            <a:pPr lvl="0" indent="0" marL="0">
-              <a:buNone/>
-            </a:pPr>
-            <a:r>
-              <a:rPr/>
-              <a:t>The standard deviation formula above includes n-1 in the denominator (rather than n) to provide an unbiased estimate of the population parameter.</a:t>
+              <a:t>Let’s explore our grayling dataset and identify the types of variables it contains.</a:t>
             </a:r>
           </a:p>
         </p:txBody>
       </p:sp>
-      <p:pic>
-        <p:nvPicPr>
-          <p:cNvPr descr="images/pop_sample_stats.png" id="0" name="Picture 1"/>
-          <p:cNvPicPr>
-            <a:picLocks noGrp="1" noChangeAspect="1"/>
-          </p:cNvPicPr>
-          <p:nvPr/>
-        </p:nvPicPr>
-        <p:blipFill>
-          <a:blip r:embed="rId2"/>
-          <a:stretch>
-            <a:fillRect/>
-          </a:stretch>
-        </p:blipFill>
-        <p:spPr bwMode="auto">
-          <a:xfrm>
-            <a:off x="6121400" y="889000"/>
-            <a:ext cx="2781300" cy="4013200"/>
-          </a:xfrm>
-          <a:prstGeom prst="rect">
-            <a:avLst/>
-          </a:prstGeom>
-          <a:noFill/>
-          <a:ln w="9525">
-            <a:noFill/>
-            <a:headEnd/>
-            <a:tailEnd/>
-          </a:ln>
-        </p:spPr>
-      </p:pic>
     </p:spTree>
   </p:cSld>
 </p:sld>
@@ -16904,7 +17592,7 @@
             </a:pPr>
             <a:r>
               <a:rPr/>
-              <a:t>Lecture 3: Kinds of Biological Variables</a:t>
+              <a:t>Lecture 3: Why Statistics is Vital in Biology</a:t>
             </a:r>
           </a:p>
         </p:txBody>
@@ -16925,104 +17613,151 @@
           <a:lstStyle/>
           <a:p>
             <a:pPr lvl="0" indent="0" marL="0">
-              <a:spcBef>
-                <a:spcPts val="3000"/>
-              </a:spcBef>
               <a:buNone/>
             </a:pPr>
             <a:r>
+              <a:rPr/>
+              <a:t>Biology is fundamentally different from fields like physics/chemistry in that:</a:t>
+            </a:r>
+          </a:p>
+          <a:p>
+            <a:pPr lvl="0"/>
+            <a:r>
+              <a:rPr/>
+              <a:t>Most biological phenomena are </a:t>
+            </a:r>
+            <a:r>
               <a:rPr b="1"/>
-              <a:t>Understanding the type of variable you’re working with is essential for selecting appropriate statistics:</a:t>
+              <a:t>probabilistic</a:t>
+            </a:r>
+            <a:r>
+              <a:rPr/>
+              <a:t> rather than </a:t>
+            </a:r>
+            <a:r>
+              <a:rPr b="1"/>
+              <a:t>deterministic</a:t>
+            </a:r>
+          </a:p>
+          <a:p>
+            <a:pPr lvl="1"/>
+            <a:r>
+              <a:rPr/>
+              <a:t>Responses occur with some characteristic probability, </a:t>
+            </a:r>
+            <a:r>
+              <a:rPr b="1"/>
+              <a:t>not with certainty</a:t>
+            </a:r>
+          </a:p>
+          <a:p>
+            <a:pPr lvl="0"/>
+            <a:r>
+              <a:rPr/>
+              <a:t>All biological material varies, which is essential for evolution (recall Darwin’s postulates):</a:t>
+            </a:r>
+          </a:p>
+          <a:p>
+            <a:pPr lvl="1"/>
+            <a:r>
+              <a:rPr/>
+              <a:t>Variation exists within populations</a:t>
+            </a:r>
+          </a:p>
+          <a:p>
+            <a:pPr lvl="1"/>
+            <a:r>
+              <a:rPr/>
+              <a:t>Some variation is heritable</a:t>
+            </a:r>
+          </a:p>
+          <a:p>
+            <a:pPr lvl="1"/>
+            <a:r>
+              <a:rPr/>
+              <a:t>Some heritable variation affects survival/reproduction</a:t>
+            </a:r>
+          </a:p>
+          <a:p>
+            <a:pPr lvl="0"/>
+            <a:r>
+              <a:rPr/>
+              <a:t>Environmental conditions (in nature, lab, or greenhouse) always vary</a:t>
+            </a:r>
+          </a:p>
+          <a:p>
+            <a:pPr lvl="0"/>
+            <a:r>
+              <a:rPr/>
+              <a:t>Measurements include error</a:t>
+            </a:r>
+          </a:p>
+          <a:p>
+            <a:pPr lvl="0"/>
+            <a:r>
+              <a:rPr/>
+              <a:t>Multiple unmeasured causal factors influence nearly all biological systems</a:t>
             </a:r>
           </a:p>
           <a:p>
             <a:pPr lvl="0" indent="0" marL="0">
-              <a:spcBef>
-                <a:spcPts val="3000"/>
-              </a:spcBef>
               <a:buNone/>
             </a:pPr>
             <a:r>
-              <a:rPr b="1"/>
-              <a:t>Measurement or Quantitative Variables</a:t>
-            </a:r>
-          </a:p>
-          <a:p>
-            <a:pPr lvl="0"/>
-            <a:r>
-              <a:rPr b="1"/>
-              <a:t>Continuous</a:t>
-            </a:r>
-            <a:r>
-              <a:rPr/>
-              <a:t>: Any value between extremes of scale is possible (e.g., mass, length)</a:t>
-            </a:r>
-          </a:p>
-          <a:p>
-            <a:pPr lvl="0"/>
-            <a:r>
-              <a:rPr b="1"/>
-              <a:t>Discrete (meristic)</a:t>
-            </a:r>
-            <a:r>
-              <a:rPr/>
-              <a:t>: Only fixed values (usually integers) between extremes are possible (e.g., bristle number, egg count)</a:t>
-            </a:r>
-          </a:p>
-          <a:p>
-            <a:pPr lvl="0" indent="0" marL="0">
-              <a:spcBef>
-                <a:spcPts val="3000"/>
-              </a:spcBef>
-              <a:buNone/>
+              <a:rPr/>
+              <a:t>Statistics helps us understand biological processes in this variable world by:</a:t>
+            </a:r>
+          </a:p>
+          <a:p>
+            <a:pPr lvl="0" indent="-342900" marL="342900">
+              <a:buAutoNum type="arabicPeriod"/>
             </a:pPr>
             <a:r>
-              <a:rPr b="1"/>
-              <a:t>Rank Variables (Ordinal)</a:t>
-            </a:r>
-          </a:p>
-          <a:p>
-            <a:pPr lvl="0"/>
-            <a:r>
-              <a:rPr/>
-              <a:t>Assign only order, not quantity</a:t>
-            </a:r>
-          </a:p>
-          <a:p>
-            <a:pPr lvl="0"/>
-            <a:r>
-              <a:rPr/>
-              <a:t>Nothing implied about relative distance between values</a:t>
-            </a:r>
-          </a:p>
-          <a:p>
-            <a:pPr lvl="0" indent="0" marL="0">
-              <a:spcBef>
-                <a:spcPts val="3000"/>
-              </a:spcBef>
-              <a:buNone/>
+              <a:rPr/>
+              <a:t>Condensing variation into summary form (Descriptive statistics)</a:t>
+            </a:r>
+          </a:p>
+          <a:p>
+            <a:pPr lvl="0" indent="-342900" marL="342900">
+              <a:buAutoNum type="arabicPeriod"/>
             </a:pPr>
             <a:r>
-              <a:rPr b="1"/>
-              <a:t>Categorical Variables (Qualitative)</a:t>
-            </a:r>
-          </a:p>
-          <a:p>
-            <a:pPr lvl="0"/>
-            <a:r>
-              <a:rPr/>
-              <a:t>No quantitative information (e.g., male/female, living/dead)</a:t>
-            </a:r>
-          </a:p>
-          <a:p>
-            <a:pPr lvl="0"/>
-            <a:r>
-              <a:rPr/>
-              <a:t>Some are simplifications of quantitative variables (e.g., color instead of wavelength)</a:t>
+              <a:rPr/>
+              <a:t>Testing whether observations are consistent with predictions (Inferential statistics)</a:t>
             </a:r>
           </a:p>
         </p:txBody>
       </p:sp>
+      <p:pic>
+        <p:nvPicPr>
+          <p:cNvPr descr="03_01_lecture_powerpoint_files/figure-pptx/unnamed-chunk-1-1.png" id="0" name="Picture 1"/>
+          <p:cNvPicPr>
+            <a:picLocks noGrp="1" noChangeAspect="1"/>
+          </p:cNvPicPr>
+          <p:nvPr/>
+        </p:nvPicPr>
+        <p:blipFill>
+          <a:blip r:embed="rId2"/>
+          <a:stretch>
+            <a:fillRect/>
+          </a:stretch>
+        </p:blipFill>
+        <p:spPr bwMode="auto">
+          <a:xfrm>
+            <a:off x="6121400" y="2044700"/>
+            <a:ext cx="2781300" cy="1714500"/>
+          </a:xfrm>
+          <a:prstGeom prst="rect">
+            <a:avLst/>
+          </a:prstGeom>
+          <a:noFill/>
+          <a:ln w="9525">
+            <a:noFill/>
+            <a:headEnd/>
+            <a:tailEnd/>
+          </a:ln>
+        </p:spPr>
+      </p:pic>
     </p:spTree>
   </p:cSld>
 </p:sld>
@@ -17058,11 +17793,8 @@
         <p:spPr>
           <a:xfrm>
             <a:off x="0" y="0"/>
-            <a:ext cx="9144000" cy="602780"/>
+            <a:ext cx="9144000" cy="582780"/>
           </a:xfrm>
-          <a:solidFill>
-            <a:srgbClr val="70121D"/>
-          </a:solidFill>
         </p:spPr>
         <p:txBody>
           <a:bodyPr/>
@@ -17073,7 +17805,7 @@
             </a:pPr>
             <a:r>
               <a:rPr/>
-              <a:t>Lecture 3: Derived Variables</a:t>
+              <a:t>Practice Exercise 1: Fish Data</a:t>
             </a:r>
           </a:p>
         </p:txBody>
@@ -17085,7 +17817,7 @@
             <a:spLocks noGrp="1"/>
           </p:cNvSpPr>
           <p:nvPr>
-            <p:ph idx="1" sz="half"/>
+            <p:ph idx="1"/>
           </p:nvPr>
         </p:nvSpPr>
         <p:spPr/>
@@ -17093,68 +17825,70 @@
           <a:bodyPr/>
           <a:lstStyle/>
           <a:p>
-            <a:pPr lvl="0" indent="0" marL="0">
-              <a:spcBef>
-                <a:spcPts val="3000"/>
-              </a:spcBef>
+            <a:pPr lvl="0" indent="0" marL="1270000">
               <a:buNone/>
             </a:pPr>
             <a:r>
-              <a:rPr b="1"/>
-              <a:t>Derived Variables</a:t>
-            </a:r>
-          </a:p>
-          <a:p>
-            <a:pPr lvl="0"/>
-            <a:r>
-              <a:rPr b="1"/>
-              <a:t>Percentages, Proportions</a:t>
-            </a:r>
-            <a:r>
-              <a:rPr/>
-              <a:t>: Ratio of some component to total</a:t>
-            </a:r>
-          </a:p>
-          <a:p>
-            <a:pPr lvl="0"/>
-            <a:r>
-              <a:rPr b="1"/>
-              <a:t>Ratios</a:t>
-            </a:r>
-            <a:r>
-              <a:rPr/>
-              <a:t>: Relation of two variables</a:t>
-            </a:r>
-          </a:p>
-          <a:p>
-            <a:pPr lvl="0"/>
-            <a:r>
-              <a:rPr b="1"/>
-              <a:t>Rates</a:t>
-            </a:r>
-            <a:r>
-              <a:rPr/>
-              <a:t>: Quantity per unit (time, mass, etc.)</a:t>
-            </a:r>
-          </a:p>
-          <a:p>
-            <a:pPr lvl="0"/>
-            <a:r>
-              <a:rPr b="1"/>
-              <a:t>Indices</a:t>
-            </a:r>
-            <a:r>
-              <a:rPr/>
-              <a:t>: More complex derived variables (e.g., condition index)</a:t>
-            </a:r>
-          </a:p>
-          <a:p>
-            <a:pPr lvl="0" indent="0" marL="0">
+              <a:rPr sz="2000" b="1"/>
+              <a:t>Practice Exercise 1: Can you open the fish data </a:t>
+            </a:r>
+            <a:r>
+              <a:rPr sz="2000" b="1">
+                <a:latin typeface="Courier"/>
+              </a:rPr>
+              <a:t>gray_I3_I8.csv</a:t>
+            </a:r>
+            <a:r>
+              <a:rPr sz="2000" b="1"/>
+              <a:t> and look at the structure and make a histogram?</a:t>
+            </a:r>
+          </a:p>
+          <a:p>
+            <a:pPr lvl="0" indent="0" marL="1270000">
               <a:buNone/>
             </a:pPr>
             <a:r>
-              <a:rPr/>
-              <a:t>Let’s explore our grayling dataset and identify the types of variables it contains.</a:t>
+              <a:rPr sz="2000"/>
+              <a:t>Note the variation around the mean… some could be due to measurement error</a:t>
+            </a:r>
+          </a:p>
+          <a:p>
+            <a:pPr lvl="0" indent="0" marL="1270000">
+              <a:buNone/>
+            </a:pPr>
+            <a:r>
+              <a:rPr sz="2000"/>
+              <a:t>Let’s recreate the basic histogram of fish lengths using </a:t>
+            </a:r>
+            <a:r>
+              <a:rPr sz="2000">
+                <a:latin typeface="Courier"/>
+              </a:rPr>
+              <a:t>gray_I3_I8.csv</a:t>
+            </a:r>
+          </a:p>
+          <a:p>
+            <a:pPr lvl="0" indent="0">
+              <a:buNone/>
+            </a:pPr>
+            <a:r>
+              <a:rPr>
+                <a:solidFill>
+                  <a:srgbClr val="5E5E5E"/>
+                </a:solidFill>
+                <a:latin typeface="Courier"/>
+              </a:rPr>
+              <a:t># Write your code here to read in the file</a:t>
+            </a:r>
+            <a:br/>
+            <a:r>
+              <a:rPr>
+                <a:solidFill>
+                  <a:srgbClr val="5E5E5E"/>
+                </a:solidFill>
+                <a:latin typeface="Courier"/>
+              </a:rPr>
+              <a:t># How do you examine the data - what are the ways you think and lets try it!</a:t>
             </a:r>
           </a:p>
         </p:txBody>

</xml_diff>